<commit_message>
Fix throughput data: use actual req/s not output tokens/s
All throughput numbers were wrong — using guidellm's per-request
output token rate instead of requests_completed/duration. Real
throughput is ~25 req/s (flat, concurrency-limited at 100 users).
The real optimization gains are in TTFT, not throughput.

Corrected: Qwen Agg 3.3 was 30.9 not 6.2 req/s, tuned was 23.6
not 30.1. Narrative updated: TTFT is the win (71-76% improvement),
throughput is saturated.

Co-Authored-By: Claude Opus 4.6 (1M context) <noreply@anthropic.com>
</commit_message>
<xml_diff>
--- a/docs/rhaiis-3.3-vs-3.4-final.pptx
+++ b/docs/rhaiis-3.3-vs-3.4-final.pptx
@@ -3142,6 +3142,8 @@
                 <a:spcPts val="2400"/>
               </a:spcBef>
             </a:pPr>
+          </a:p>
+          <a:p>
             <a:r>
               <a:rPr sz="1200" b="1">
                 <a:solidFill>
@@ -3228,7 +3230,7 @@
                   <a:srgbClr val="64748B"/>
                 </a:solidFill>
               </a:rPr>
-              <a:t>Inftune Studio — automated 11-step optimization pipeline</a:t>
+              <a:t>ServeIt Studio — automated 11-step optimization pipeline</a:t>
             </a:r>
           </a:p>
         </p:txBody>
@@ -3369,7 +3371,7 @@
                           </a:solidFill>
                         </a:rPr>
                         <a:t>3.3
-Baseline</a:t>
+Base</a:t>
                       </a:r>
                     </a:p>
                   </a:txBody>
@@ -3392,7 +3394,7 @@
                           </a:solidFill>
                         </a:rPr>
                         <a:t>3.4
-Baseline</a:t>
+Base</a:t>
                       </a:r>
                     </a:p>
                   </a:txBody>
@@ -3896,7 +3898,7 @@
                       <a:pPr algn="l"/>
                       <a:r>
                         <a:rPr sz="700" b="0"/>
-                        <a:t>Not supported. model_type 'ministral3' not recognized by vLLM/transformers in llm-d v0.6.0.</a:t>
+                        <a:t>Not supported. model_type 'ministral3' not recognized by vLLM in llm-d v0.6.0.</a:t>
                       </a:r>
                     </a:p>
                   </a:txBody>
@@ -4045,7 +4047,7 @@
                       <a:pPr algn="l"/>
                       <a:r>
                         <a:rPr sz="700" b="0"/>
-                        <a:t>New model. Aggregated only on 3.4. PD blocked: hybrid attention + NixlConnector HMA. DeepGemm incompatible (compressed-tensors per-channel FP8).</a:t>
+                        <a:t>New model. Aggregated only on 3.4. PD blocked: hybrid attention + NixlConnector HMA.</a:t>
                       </a:r>
                     </a:p>
                   </a:txBody>
@@ -4189,7 +4191,7 @@
                       <a:pPr algn="l"/>
                       <a:r>
                         <a:rPr sz="700" b="0"/>
-                        <a:t>New model. Not in RHAIIS 3.3. Can run aggregated and EP on 16 GPUs. Not tested yet.</a:t>
+                        <a:t>New model. Can run aggregated and EP on 16 GPUs. Not tested yet.</a:t>
                       </a:r>
                     </a:p>
                   </a:txBody>
@@ -4338,7 +4340,7 @@
                       <a:pPr algn="l"/>
                       <a:r>
                         <a:rPr sz="700" b="0"/>
-                        <a:t>Not new. Can run aggregated TP=8 on 16 GPUs (~29GB/GPU FP8). Not tested yet.</a:t>
+                        <a:t>Can run aggregated TP=8 on 16 GPUs (~29GB/GPU FP8). Not tested yet.</a:t>
                       </a:r>
                     </a:p>
                   </a:txBody>
@@ -4487,7 +4489,7 @@
                       <a:pPr algn="l"/>
                       <a:r>
                         <a:rPr sz="700" b="0"/>
-                        <a:t>New model. Aggregated TP&lt;=4 only. PD blocked: hybrid attention (GDN) + NixlConnector HMA. FP8 block quant limits TP&lt;=4. DeepGemm JIT crash at TP&lt;8.</a:t>
+                        <a:t>New model. Aggregated TP&lt;=4 only. PD blocked: hybrid attention (GDN) + HMA.</a:t>
                       </a:r>
                     </a:p>
                   </a:txBody>
@@ -4532,162 +4534,6 @@
                   <a:tcPr anchor="ctr">
                     <a:solidFill>
                       <a:srgbClr val="f8fafc"/>
-                    </a:solidFill>
-                  </a:tcPr>
-                </a:tc>
-                <a:tc>
-                  <a:txBody>
-                    <a:bodyPr wrap="square"/>
-                    <a:lstStyle/>
-                    <a:p>
-                      <a:pPr algn="ctr"/>
-                      <a:r>
-                        <a:rPr sz="533" b="0">
-                          <a:solidFill>
-                            <a:srgbClr val="991B1B"/>
-                          </a:solidFill>
-                        </a:rPr>
-                        <a:t>—</a:t>
-                      </a:r>
-                    </a:p>
-                  </a:txBody>
-                  <a:tcPr anchor="ctr">
-                    <a:solidFill>
-                      <a:srgbClr val="fee2e2"/>
-                    </a:solidFill>
-                    <a:solidFill>
-                      <a:srgbClr val="fee2e2"/>
-                    </a:solidFill>
-                  </a:tcPr>
-                </a:tc>
-                <a:tc>
-                  <a:txBody>
-                    <a:bodyPr wrap="square"/>
-                    <a:lstStyle/>
-                    <a:p>
-                      <a:pPr algn="ctr"/>
-                      <a:r>
-                        <a:rPr sz="533" b="0">
-                          <a:solidFill>
-                            <a:srgbClr val="991B1B"/>
-                          </a:solidFill>
-                        </a:rPr>
-                        <a:t>—</a:t>
-                      </a:r>
-                    </a:p>
-                  </a:txBody>
-                  <a:tcPr anchor="ctr">
-                    <a:solidFill>
-                      <a:srgbClr val="fee2e2"/>
-                    </a:solidFill>
-                    <a:solidFill>
-                      <a:srgbClr val="fee2e2"/>
-                    </a:solidFill>
-                  </a:tcPr>
-                </a:tc>
-                <a:tc>
-                  <a:txBody>
-                    <a:bodyPr wrap="square"/>
-                    <a:lstStyle/>
-                    <a:p>
-                      <a:pPr algn="ctr"/>
-                      <a:r>
-                        <a:rPr sz="533" b="0">
-                          <a:solidFill>
-                            <a:srgbClr val="991B1B"/>
-                          </a:solidFill>
-                        </a:rPr>
-                        <a:t>—</a:t>
-                      </a:r>
-                    </a:p>
-                  </a:txBody>
-                  <a:tcPr anchor="ctr">
-                    <a:solidFill>
-                      <a:srgbClr val="fee2e2"/>
-                    </a:solidFill>
-                    <a:solidFill>
-                      <a:srgbClr val="fee2e2"/>
-                    </a:solidFill>
-                  </a:tcPr>
-                </a:tc>
-                <a:tc>
-                  <a:txBody>
-                    <a:bodyPr wrap="square"/>
-                    <a:lstStyle/>
-                    <a:p>
-                      <a:pPr algn="ctr"/>
-                      <a:r>
-                        <a:rPr sz="533" b="0">
-                          <a:solidFill>
-                            <a:srgbClr val="991B1B"/>
-                          </a:solidFill>
-                        </a:rPr>
-                        <a:t>—</a:t>
-                      </a:r>
-                    </a:p>
-                  </a:txBody>
-                  <a:tcPr anchor="ctr">
-                    <a:solidFill>
-                      <a:srgbClr val="fee2e2"/>
-                    </a:solidFill>
-                    <a:solidFill>
-                      <a:srgbClr val="fee2e2"/>
-                    </a:solidFill>
-                  </a:tcPr>
-                </a:tc>
-                <a:tc>
-                  <a:txBody>
-                    <a:bodyPr wrap="square"/>
-                    <a:lstStyle/>
-                    <a:p>
-                      <a:pPr algn="l"/>
-                      <a:r>
-                        <a:rPr sz="700" b="0"/>
-                        <a:t>Not tested. Need to check hybrid attention status for PD support.</a:t>
-                      </a:r>
-                    </a:p>
-                  </a:txBody>
-                  <a:tcPr anchor="ctr">
-                    <a:solidFill>
-                      <a:srgbClr val="f8fafc"/>
-                    </a:solidFill>
-                  </a:tcPr>
-                </a:tc>
-              </a:tr>
-              <a:tr h="502920">
-                <a:tc vMerge="1">
-                  <a:txBody>
-                    <a:bodyPr wrap="square"/>
-                    <a:lstStyle/>
-                    <a:p>
-                      <a:pPr algn="l"/>
-                      <a:r>
-                        <a:rPr sz="900" b="0"/>
-                        <a:t/>
-                      </a:r>
-                    </a:p>
-                  </a:txBody>
-                  <a:tcPr anchor="ctr">
-                    <a:solidFill>
-                      <a:srgbClr val="ffffff"/>
-                    </a:solidFill>
-                  </a:tcPr>
-                </a:tc>
-                <a:tc>
-                  <a:txBody>
-                    <a:bodyPr wrap="square"/>
-                    <a:lstStyle/>
-                    <a:p>
-                      <a:pPr algn="l"/>
-                      <a:r>
-                        <a:rPr sz="700" b="0"/>
-                        <a:t>nvidia/NVIDIA-Nemotron-3-Nano-30B-A3B-FP8</a:t>
-                      </a:r>
-                    </a:p>
-                  </a:txBody>
-                  <a:tcPr anchor="ctr">
-                    <a:solidFill>
-                      <a:srgbClr val="ffffff"/>
                     </a:solidFill>
                   </a:tcPr>
                 </a:tc>
@@ -4787,7 +4633,151 @@
                       <a:pPr algn="l"/>
                       <a:r>
                         <a:rPr sz="700" b="0"/>
-                        <a:t>New model. Not tested yet. Likely same hybrid attention constraints as Qwen3-Next.</a:t>
+                        <a:t>Not tested. Need to check hybrid attention status for PD support.</a:t>
+                      </a:r>
+                    </a:p>
+                  </a:txBody>
+                  <a:tcPr anchor="ctr">
+                    <a:solidFill>
+                      <a:srgbClr val="f8fafc"/>
+                    </a:solidFill>
+                  </a:tcPr>
+                </a:tc>
+              </a:tr>
+              <a:tr h="502920">
+                <a:tc vMerge="1">
+                  <a:txBody>
+                    <a:bodyPr wrap="square"/>
+                    <a:lstStyle/>
+                    <a:p>
+                      <a:pPr algn="l"/>
+                      <a:r>
+                        <a:rPr sz="900" b="0"/>
+                        <a:t/>
+                      </a:r>
+                    </a:p>
+                  </a:txBody>
+                  <a:tcPr anchor="ctr">
+                    <a:solidFill>
+                      <a:srgbClr val="ffffff"/>
+                    </a:solidFill>
+                  </a:tcPr>
+                </a:tc>
+                <a:tc>
+                  <a:txBody>
+                    <a:bodyPr wrap="square"/>
+                    <a:lstStyle/>
+                    <a:p>
+                      <a:pPr algn="l"/>
+                      <a:r>
+                        <a:rPr sz="700" b="0"/>
+                        <a:t>nvidia/NVIDIA-Nemotron-3-Nano-30B-A3B-FP8</a:t>
+                      </a:r>
+                    </a:p>
+                  </a:txBody>
+                  <a:tcPr anchor="ctr">
+                    <a:solidFill>
+                      <a:srgbClr val="ffffff"/>
+                    </a:solidFill>
+                  </a:tcPr>
+                </a:tc>
+                <a:tc>
+                  <a:txBody>
+                    <a:bodyPr wrap="square"/>
+                    <a:lstStyle/>
+                    <a:p>
+                      <a:pPr algn="ctr"/>
+                      <a:r>
+                        <a:rPr sz="800" b="0">
+                          <a:solidFill>
+                            <a:srgbClr val="991B1B"/>
+                          </a:solidFill>
+                        </a:rPr>
+                        <a:t>—</a:t>
+                      </a:r>
+                    </a:p>
+                  </a:txBody>
+                  <a:tcPr anchor="ctr">
+                    <a:solidFill>
+                      <a:srgbClr val="fee2e2"/>
+                    </a:solidFill>
+                  </a:tcPr>
+                </a:tc>
+                <a:tc>
+                  <a:txBody>
+                    <a:bodyPr wrap="square"/>
+                    <a:lstStyle/>
+                    <a:p>
+                      <a:pPr algn="ctr"/>
+                      <a:r>
+                        <a:rPr sz="800" b="0">
+                          <a:solidFill>
+                            <a:srgbClr val="991B1B"/>
+                          </a:solidFill>
+                        </a:rPr>
+                        <a:t>—</a:t>
+                      </a:r>
+                    </a:p>
+                  </a:txBody>
+                  <a:tcPr anchor="ctr">
+                    <a:solidFill>
+                      <a:srgbClr val="fee2e2"/>
+                    </a:solidFill>
+                  </a:tcPr>
+                </a:tc>
+                <a:tc>
+                  <a:txBody>
+                    <a:bodyPr wrap="square"/>
+                    <a:lstStyle/>
+                    <a:p>
+                      <a:pPr algn="ctr"/>
+                      <a:r>
+                        <a:rPr sz="800" b="0">
+                          <a:solidFill>
+                            <a:srgbClr val="991B1B"/>
+                          </a:solidFill>
+                        </a:rPr>
+                        <a:t>—</a:t>
+                      </a:r>
+                    </a:p>
+                  </a:txBody>
+                  <a:tcPr anchor="ctr">
+                    <a:solidFill>
+                      <a:srgbClr val="fee2e2"/>
+                    </a:solidFill>
+                  </a:tcPr>
+                </a:tc>
+                <a:tc>
+                  <a:txBody>
+                    <a:bodyPr wrap="square"/>
+                    <a:lstStyle/>
+                    <a:p>
+                      <a:pPr algn="ctr"/>
+                      <a:r>
+                        <a:rPr sz="800" b="0">
+                          <a:solidFill>
+                            <a:srgbClr val="991B1B"/>
+                          </a:solidFill>
+                        </a:rPr>
+                        <a:t>—</a:t>
+                      </a:r>
+                    </a:p>
+                  </a:txBody>
+                  <a:tcPr anchor="ctr">
+                    <a:solidFill>
+                      <a:srgbClr val="fee2e2"/>
+                    </a:solidFill>
+                  </a:tcPr>
+                </a:tc>
+                <a:tc>
+                  <a:txBody>
+                    <a:bodyPr wrap="square"/>
+                    <a:lstStyle/>
+                    <a:p>
+                      <a:pPr algn="l"/>
+                      <a:r>
+                        <a:rPr sz="700" b="0"/>
+                        <a:t>New model. Not tested yet. Likely same constraints as Qwen3-Next.</a:t>
                       </a:r>
                     </a:p>
                   </a:txBody>
@@ -4929,7 +4919,7 @@
                   <a:srgbClr val="374151"/>
                 </a:solidFill>
               </a:rPr>
-              <a:t>Ministral-3-14B, DeepSeek-R1, Qwen3-Next-80B, Nemotron-3-Nano are new models that didn't exist when RHAIIS 3.3 shipped. There is no 3.3 baseline to compare against, so regression testing is not applicable. These models can only be validated on 3.4.</a:t>
+              <a:t>Ministral-3-14B, DeepSeek-R1, Qwen3-Next-80B, Nemotron-3-Nano are new models that didn't exist when RHAIIS 3.3 shipped. There is no 3.3 baseline to compare against.</a:t>
             </a:r>
           </a:p>
         </p:txBody>
@@ -4942,7 +4932,7 @@
         </p:nvSpPr>
         <p:spPr>
           <a:xfrm>
-            <a:off x="457200" y="2331720"/>
+            <a:off x="457200" y="2240280"/>
             <a:ext cx="10972800" cy="1097280"/>
           </a:xfrm>
           <a:prstGeom prst="rect">
@@ -4977,7 +4967,7 @@
                   <a:srgbClr val="374151"/>
                 </a:solidFill>
               </a:rPr>
-              <a:t>Llama-4-Maverick (attention_chunk_size=8192) and Qwen3-Next (GDN + full attention) use hybrid attention — mixing different attention types across layers. PD disaggregation via NixlConnector requires the Hybrid Memory Allocator (HMA) interface, which NixlConnector does not implement in vLLM v0.17.1 (llm-d v0.6.0 / RHAIIS 3.4). HMA support was added in vLLM v0.19.1 (llm-d v0.7.0 / RHAIIS 3.5 EA2). Aggregated mode works for all models.</a:t>
+              <a:t>Llama-4-Maverick and Qwen3-Next use hybrid attention. PD via NixlConnector requires the HMA interface, which is not implemented in vLLM v0.17.1 (llm-d v0.6.0). Available in vLLM v0.19.1+ (llm-d v0.7.0 / RHAIIS 3.5 EA2). Aggregated mode works for all models.</a:t>
             </a:r>
           </a:p>
         </p:txBody>
@@ -4990,7 +4980,7 @@
         </p:nvSpPr>
         <p:spPr>
           <a:xfrm>
-            <a:off x="457200" y="3749039"/>
+            <a:off x="457200" y="3566160"/>
             <a:ext cx="10972800" cy="1097280"/>
           </a:xfrm>
           <a:prstGeom prst="rect">
@@ -5010,7 +5000,7 @@
                   <a:srgbClr val="0C4A6E"/>
                 </a:solidFill>
               </a:rPr>
-              <a:t>3. Model Size Exceeds 16 GPU Test Bed</a:t>
+              <a:t>3. Ministral Not Supported</a:t>
             </a:r>
           </a:p>
           <a:p>
@@ -5025,7 +5015,7 @@
                   <a:srgbClr val="374151"/>
                 </a:solidFill>
               </a:rPr>
-              <a:t>DeepSeek-R1-0528 (~671B total) and Qwen3-235B-A22B (~235B total, ~29GB/GPU at TP=8 FP8) can both run on 16 GPUs for aggregated and EP testing. Not yet tested due to time constraints.</a:t>
+              <a:t>model_type 'ministral3' is not recognized by vLLM/transformers in the llm-d v0.6.0 image. The model architecture is not yet implemented in this version.</a:t>
             </a:r>
           </a:p>
         </p:txBody>
@@ -5038,7 +5028,7 @@
         </p:nvSpPr>
         <p:spPr>
           <a:xfrm>
-            <a:off x="457200" y="5166359"/>
+            <a:off x="457200" y="4892040"/>
             <a:ext cx="10972800" cy="1097280"/>
           </a:xfrm>
           <a:prstGeom prst="rect">
@@ -5073,7 +5063,7 @@
                   <a:srgbClr val="374151"/>
                 </a:solidFill>
               </a:rPr>
-              <a:t>Llama-4-Maverick uses compressed-tensors per-channel FP8 scales — DeepGemm kernel doesn't support this scheme. Qwen3-Next has shared_expert_intermediate_size=512, limiting max TP to 4 (FP8 block_n=128 requires partition &gt;= 128). DeepGemm JIT kernel also crashes at TP&lt;8 for some models (auto-enabled on H200s).</a:t>
+              <a:t>Llama-4-Maverick uses compressed-tensors per-channel FP8 — DeepGemm incompatible. Qwen3-Next has shared_expert_intermediate_size=512, limiting max TP to 4. DeepGemm JIT crashes at TP&lt;8 for some FP8 models (auto-enabled on H200s).</a:t>
             </a:r>
           </a:p>
         </p:txBody>
@@ -5196,7 +5186,7 @@
                     <a:p>
                       <a:pPr algn="ctr"/>
                       <a:r>
-                        <a:rPr sz="900" b="1">
+                        <a:rPr sz="800" b="1">
                           <a:solidFill>
                             <a:srgbClr val="FFFFFF"/>
                           </a:solidFill>
@@ -5218,7 +5208,7 @@
                     <a:p>
                       <a:pPr algn="ctr"/>
                       <a:r>
-                        <a:rPr sz="900" b="1">
+                        <a:rPr sz="800" b="1">
                           <a:solidFill>
                             <a:srgbClr val="FFFFFF"/>
                           </a:solidFill>
@@ -5240,7 +5230,7 @@
                     <a:p>
                       <a:pPr algn="ctr"/>
                       <a:r>
-                        <a:rPr sz="900" b="1">
+                        <a:rPr sz="800" b="1">
                           <a:solidFill>
                             <a:srgbClr val="FFFFFF"/>
                           </a:solidFill>
@@ -5262,7 +5252,7 @@
                     <a:p>
                       <a:pPr algn="ctr"/>
                       <a:r>
-                        <a:rPr sz="900" b="1">
+                        <a:rPr sz="800" b="1">
                           <a:solidFill>
                             <a:srgbClr val="FFFFFF"/>
                           </a:solidFill>
@@ -5284,7 +5274,7 @@
                     <a:p>
                       <a:pPr algn="ctr"/>
                       <a:r>
-                        <a:rPr sz="900" b="1">
+                        <a:rPr sz="800" b="1">
                           <a:solidFill>
                             <a:srgbClr val="FFFFFF"/>
                           </a:solidFill>
@@ -5306,7 +5296,7 @@
                     <a:p>
                       <a:pPr algn="ctr"/>
                       <a:r>
-                        <a:rPr sz="900" b="1">
+                        <a:rPr sz="800" b="1">
                           <a:solidFill>
                             <a:srgbClr val="FFFFFF"/>
                           </a:solidFill>
@@ -5330,11 +5320,7 @@
                     <a:p>
                       <a:pPr algn="l"/>
                       <a:r>
-                        <a:rPr sz="900" b="0">
-                          <a:solidFill>
-                            <a:srgbClr val="374151"/>
-                          </a:solidFill>
-                        </a:rPr>
+                        <a:rPr sz="900" b="0"/>
                         <a:t>TTFT P90</a:t>
                       </a:r>
                     </a:p>
@@ -5352,11 +5338,7 @@
                     <a:p>
                       <a:pPr algn="ctr"/>
                       <a:r>
-                        <a:rPr sz="900" b="0">
-                          <a:solidFill>
-                            <a:srgbClr val="374151"/>
-                          </a:solidFill>
-                        </a:rPr>
+                        <a:rPr sz="900" b="0"/>
                         <a:t>880 ms</a:t>
                       </a:r>
                     </a:p>
@@ -5374,11 +5356,7 @@
                     <a:p>
                       <a:pPr algn="ctr"/>
                       <a:r>
-                        <a:rPr sz="900" b="0">
-                          <a:solidFill>
-                            <a:srgbClr val="374151"/>
-                          </a:solidFill>
-                        </a:rPr>
+                        <a:rPr sz="900" b="0"/>
                         <a:t>675 ms</a:t>
                       </a:r>
                     </a:p>
@@ -5396,11 +5374,7 @@
                     <a:p>
                       <a:pPr algn="ctr"/>
                       <a:r>
-                        <a:rPr sz="900" b="0">
-                          <a:solidFill>
-                            <a:srgbClr val="065F46"/>
-                          </a:solidFill>
-                        </a:rPr>
+                        <a:rPr sz="900" b="0"/>
                         <a:t>-23.3%</a:t>
                       </a:r>
                     </a:p>
@@ -5418,11 +5392,7 @@
                     <a:p>
                       <a:pPr algn="ctr"/>
                       <a:r>
-                        <a:rPr sz="900" b="0">
-                          <a:solidFill>
-                            <a:srgbClr val="374151"/>
-                          </a:solidFill>
-                        </a:rPr>
+                        <a:rPr sz="900" b="0"/>
                         <a:t>534 ms</a:t>
                       </a:r>
                     </a:p>
@@ -5440,11 +5410,7 @@
                     <a:p>
                       <a:pPr algn="ctr"/>
                       <a:r>
-                        <a:rPr sz="900" b="0">
-                          <a:solidFill>
-                            <a:srgbClr val="065F46"/>
-                          </a:solidFill>
-                        </a:rPr>
+                        <a:rPr sz="900" b="0"/>
                         <a:t>-39.3%</a:t>
                       </a:r>
                     </a:p>
@@ -5464,11 +5430,7 @@
                     <a:p>
                       <a:pPr algn="l"/>
                       <a:r>
-                        <a:rPr sz="900" b="0">
-                          <a:solidFill>
-                            <a:srgbClr val="374151"/>
-                          </a:solidFill>
-                        </a:rPr>
+                        <a:rPr sz="900" b="0"/>
                         <a:t>TTFT P99</a:t>
                       </a:r>
                     </a:p>
@@ -5486,11 +5448,7 @@
                     <a:p>
                       <a:pPr algn="ctr"/>
                       <a:r>
-                        <a:rPr sz="900" b="0">
-                          <a:solidFill>
-                            <a:srgbClr val="374151"/>
-                          </a:solidFill>
-                        </a:rPr>
+                        <a:rPr sz="900" b="0"/>
                         <a:t>1,592 ms</a:t>
                       </a:r>
                     </a:p>
@@ -5508,11 +5466,7 @@
                     <a:p>
                       <a:pPr algn="ctr"/>
                       <a:r>
-                        <a:rPr sz="900" b="0">
-                          <a:solidFill>
-                            <a:srgbClr val="374151"/>
-                          </a:solidFill>
-                        </a:rPr>
+                        <a:rPr sz="900" b="0"/>
                         <a:t>1,240 ms</a:t>
                       </a:r>
                     </a:p>
@@ -5530,11 +5484,7 @@
                     <a:p>
                       <a:pPr algn="ctr"/>
                       <a:r>
-                        <a:rPr sz="900" b="0">
-                          <a:solidFill>
-                            <a:srgbClr val="065F46"/>
-                          </a:solidFill>
-                        </a:rPr>
+                        <a:rPr sz="900" b="0"/>
                         <a:t>-22.1%</a:t>
                       </a:r>
                     </a:p>
@@ -5552,11 +5502,7 @@
                     <a:p>
                       <a:pPr algn="ctr"/>
                       <a:r>
-                        <a:rPr sz="900" b="0">
-                          <a:solidFill>
-                            <a:srgbClr val="374151"/>
-                          </a:solidFill>
-                        </a:rPr>
+                        <a:rPr sz="900" b="0"/>
                         <a:t>993 ms</a:t>
                       </a:r>
                     </a:p>
@@ -5574,11 +5520,7 @@
                     <a:p>
                       <a:pPr algn="ctr"/>
                       <a:r>
-                        <a:rPr sz="900" b="0">
-                          <a:solidFill>
-                            <a:srgbClr val="065F46"/>
-                          </a:solidFill>
-                        </a:rPr>
+                        <a:rPr sz="900" b="0"/>
                         <a:t>-37.6%</a:t>
                       </a:r>
                     </a:p>
@@ -5598,12 +5540,8 @@
                     <a:p>
                       <a:pPr algn="l"/>
                       <a:r>
-                        <a:rPr sz="900" b="0">
-                          <a:solidFill>
-                            <a:srgbClr val="374151"/>
-                          </a:solidFill>
-                        </a:rPr>
-                        <a:t>Throughput Mean</a:t>
+                        <a:rPr sz="900" b="0"/>
+                        <a:t>Throughput</a:t>
                       </a:r>
                     </a:p>
                   </a:txBody>
@@ -5620,12 +5558,8 @@
                     <a:p>
                       <a:pPr algn="ctr"/>
                       <a:r>
-                        <a:rPr sz="900" b="0">
-                          <a:solidFill>
-                            <a:srgbClr val="374151"/>
-                          </a:solidFill>
-                        </a:rPr>
-                        <a:t>18.3 req/s</a:t>
+                        <a:rPr sz="900" b="0"/>
+                        <a:t>31.2 req/s</a:t>
                       </a:r>
                     </a:p>
                   </a:txBody>
@@ -5642,12 +5576,8 @@
                     <a:p>
                       <a:pPr algn="ctr"/>
                       <a:r>
-                        <a:rPr sz="900" b="0">
-                          <a:solidFill>
-                            <a:srgbClr val="374151"/>
-                          </a:solidFill>
-                        </a:rPr>
-                        <a:t>28.8 req/s</a:t>
+                        <a:rPr sz="900" b="0"/>
+                        <a:t>22.5 req/s</a:t>
                       </a:r>
                     </a:p>
                   </a:txBody>
@@ -5664,12 +5594,8 @@
                     <a:p>
                       <a:pPr algn="ctr"/>
                       <a:r>
-                        <a:rPr sz="900" b="0">
-                          <a:solidFill>
-                            <a:srgbClr val="374151"/>
-                          </a:solidFill>
-                        </a:rPr>
-                        <a:t>+57.4%</a:t>
+                        <a:rPr sz="900" b="0"/>
+                        <a:t>-27.9%</a:t>
                       </a:r>
                     </a:p>
                   </a:txBody>
@@ -5686,12 +5612,8 @@
                     <a:p>
                       <a:pPr algn="ctr"/>
                       <a:r>
-                        <a:rPr sz="900" b="0">
-                          <a:solidFill>
-                            <a:srgbClr val="374151"/>
-                          </a:solidFill>
-                        </a:rPr>
-                        <a:t>42.0 req/s</a:t>
+                        <a:rPr sz="900" b="0"/>
+                        <a:t>22.6 req/s</a:t>
                       </a:r>
                     </a:p>
                   </a:txBody>
@@ -5708,12 +5630,8 @@
                     <a:p>
                       <a:pPr algn="ctr"/>
                       <a:r>
-                        <a:rPr sz="900" b="0">
-                          <a:solidFill>
-                            <a:srgbClr val="374151"/>
-                          </a:solidFill>
-                        </a:rPr>
-                        <a:t>+129.5%</a:t>
+                        <a:rPr sz="900" b="0"/>
+                        <a:t>-27.6%</a:t>
                       </a:r>
                     </a:p>
                   </a:txBody>
@@ -5732,11 +5650,7 @@
                     <a:p>
                       <a:pPr algn="l"/>
                       <a:r>
-                        <a:rPr sz="900" b="0">
-                          <a:solidFill>
-                            <a:srgbClr val="374151"/>
-                          </a:solidFill>
-                        </a:rPr>
+                        <a:rPr sz="900" b="0"/>
                         <a:t>ITL P90</a:t>
                       </a:r>
                     </a:p>
@@ -5754,11 +5668,7 @@
                     <a:p>
                       <a:pPr algn="ctr"/>
                       <a:r>
-                        <a:rPr sz="900" b="0">
-                          <a:solidFill>
-                            <a:srgbClr val="374151"/>
-                          </a:solidFill>
-                        </a:rPr>
+                        <a:rPr sz="900" b="0"/>
                         <a:t>18.6 ms</a:t>
                       </a:r>
                     </a:p>
@@ -5776,11 +5686,7 @@
                     <a:p>
                       <a:pPr algn="ctr"/>
                       <a:r>
-                        <a:rPr sz="900" b="0">
-                          <a:solidFill>
-                            <a:srgbClr val="374151"/>
-                          </a:solidFill>
-                        </a:rPr>
+                        <a:rPr sz="900" b="0"/>
                         <a:t>12.1 ms</a:t>
                       </a:r>
                     </a:p>
@@ -5798,11 +5704,7 @@
                     <a:p>
                       <a:pPr algn="ctr"/>
                       <a:r>
-                        <a:rPr sz="900" b="0">
-                          <a:solidFill>
-                            <a:srgbClr val="065F46"/>
-                          </a:solidFill>
-                        </a:rPr>
+                        <a:rPr sz="900" b="0"/>
                         <a:t>-34.9%</a:t>
                       </a:r>
                     </a:p>
@@ -5820,11 +5722,7 @@
                     <a:p>
                       <a:pPr algn="ctr"/>
                       <a:r>
-                        <a:rPr sz="900" b="0">
-                          <a:solidFill>
-                            <a:srgbClr val="374151"/>
-                          </a:solidFill>
-                        </a:rPr>
+                        <a:rPr sz="900" b="0"/>
                         <a:t>12.3 ms</a:t>
                       </a:r>
                     </a:p>
@@ -5842,11 +5740,7 @@
                     <a:p>
                       <a:pPr algn="ctr"/>
                       <a:r>
-                        <a:rPr sz="900" b="0">
-                          <a:solidFill>
-                            <a:srgbClr val="065F46"/>
-                          </a:solidFill>
-                        </a:rPr>
+                        <a:rPr sz="900" b="0"/>
                         <a:t>-33.9%</a:t>
                       </a:r>
                     </a:p>
@@ -5890,7 +5784,7 @@
                   <a:srgbClr val="374151"/>
                 </a:solidFill>
               </a:rPr>
-              <a:t>Aggregated — Best Config per Version</a:t>
+              <a:t>Aggregated — Best TTFT per Version</a:t>
             </a:r>
           </a:p>
         </p:txBody>
@@ -5905,7 +5799,7 @@
         </p:nvGraphicFramePr>
         <p:xfrm>
           <a:off x="457200" y="3566160"/>
-          <a:ext cx="7315200" cy="1463040"/>
+          <a:ext cx="7315200" cy="1645920"/>
         </p:xfrm>
         <a:graphic>
           <a:graphicData uri="http://schemas.openxmlformats.org/drawingml/2006/table">
@@ -5919,15 +5813,15 @@
                 <a:gridCol w="2286000"/>
                 <a:gridCol w="2286000"/>
               </a:tblGrid>
-              <a:tr h="365760">
-                <a:tc>
-                  <a:txBody>
-                    <a:bodyPr wrap="square"/>
-                    <a:lstStyle/>
-                    <a:p>
-                      <a:pPr algn="ctr"/>
-                      <a:r>
-                        <a:rPr sz="900" b="1">
+              <a:tr h="329184">
+                <a:tc>
+                  <a:txBody>
+                    <a:bodyPr wrap="square"/>
+                    <a:lstStyle/>
+                    <a:p>
+                      <a:pPr algn="ctr"/>
+                      <a:r>
+                        <a:rPr sz="800" b="1">
                           <a:solidFill>
                             <a:srgbClr val="FFFFFF"/>
                           </a:solidFill>
@@ -5949,7 +5843,7 @@
                     <a:p>
                       <a:pPr algn="ctr"/>
                       <a:r>
-                        <a:rPr sz="900" b="1">
+                        <a:rPr sz="800" b="1">
                           <a:solidFill>
                             <a:srgbClr val="FFFFFF"/>
                           </a:solidFill>
@@ -5971,7 +5865,7 @@
                     <a:p>
                       <a:pPr algn="ctr"/>
                       <a:r>
-                        <a:rPr sz="900" b="1">
+                        <a:rPr sz="800" b="1">
                           <a:solidFill>
                             <a:srgbClr val="FFFFFF"/>
                           </a:solidFill>
@@ -5993,12 +5887,12 @@
                     <a:p>
                       <a:pPr algn="ctr"/>
                       <a:r>
-                        <a:rPr sz="900" b="1">
+                        <a:rPr sz="800" b="1">
                           <a:solidFill>
                             <a:srgbClr val="FFFFFF"/>
                           </a:solidFill>
                         </a:rPr>
-                        <a:t>Throughput Mean</a:t>
+                        <a:t>Throughput</a:t>
                       </a:r>
                     </a:p>
                   </a:txBody>
@@ -6009,7 +5903,7 @@
                   </a:tcPr>
                 </a:tc>
               </a:tr>
-              <a:tr h="365760">
+              <a:tr h="329184">
                 <a:tc>
                   <a:txBody>
                     <a:bodyPr wrap="square"/>
@@ -6072,7 +5966,7 @@
                       <a:pPr algn="ctr"/>
                       <a:r>
                         <a:rPr sz="900" b="0"/>
-                        <a:t>6.2 req/s</a:t>
+                        <a:t>30.9 req/s</a:t>
                       </a:r>
                     </a:p>
                   </a:txBody>
@@ -6083,7 +5977,7 @@
                   </a:tcPr>
                 </a:tc>
               </a:tr>
-              <a:tr h="365760">
+              <a:tr h="329184">
                 <a:tc>
                   <a:txBody>
                     <a:bodyPr wrap="square"/>
@@ -6146,7 +6040,7 @@
                       <a:pPr algn="ctr"/>
                       <a:r>
                         <a:rPr sz="900" b="0"/>
-                        <a:t>17.5 req/s (+183%)</a:t>
+                        <a:t>24.6 req/s</a:t>
                       </a:r>
                     </a:p>
                   </a:txBody>
@@ -6157,7 +6051,7 @@
                   </a:tcPr>
                 </a:tc>
               </a:tr>
-              <a:tr h="365760">
+              <a:tr h="329184">
                 <a:tc>
                   <a:txBody>
                     <a:bodyPr wrap="square"/>
@@ -6220,13 +6114,87 @@
                       <a:pPr algn="ctr"/>
                       <a:r>
                         <a:rPr sz="900" b="0"/>
-                        <a:t>30.1 req/s (+386%)</a:t>
+                        <a:t>23.6 req/s</a:t>
                       </a:r>
                     </a:p>
                   </a:txBody>
                   <a:tcPr anchor="ctr">
                     <a:solidFill>
                       <a:srgbClr val="ffffff"/>
+                    </a:solidFill>
+                  </a:tcPr>
+                </a:tc>
+              </a:tr>
+              <a:tr h="329184">
+                <a:tc>
+                  <a:txBody>
+                    <a:bodyPr wrap="square"/>
+                    <a:lstStyle/>
+                    <a:p>
+                      <a:pPr algn="l"/>
+                      <a:r>
+                        <a:rPr sz="900" b="0"/>
+                        <a:t>3.4 Tuned+EPP</a:t>
+                      </a:r>
+                    </a:p>
+                  </a:txBody>
+                  <a:tcPr anchor="ctr">
+                    <a:solidFill>
+                      <a:srgbClr val="f8fafc"/>
+                    </a:solidFill>
+                  </a:tcPr>
+                </a:tc>
+                <a:tc>
+                  <a:txBody>
+                    <a:bodyPr wrap="square"/>
+                    <a:lstStyle/>
+                    <a:p>
+                      <a:pPr algn="ctr"/>
+                      <a:r>
+                        <a:rPr sz="900" b="0"/>
+                        <a:t>2x TP8</a:t>
+                      </a:r>
+                    </a:p>
+                  </a:txBody>
+                  <a:tcPr anchor="ctr">
+                    <a:solidFill>
+                      <a:srgbClr val="f8fafc"/>
+                    </a:solidFill>
+                  </a:tcPr>
+                </a:tc>
+                <a:tc>
+                  <a:txBody>
+                    <a:bodyPr wrap="square"/>
+                    <a:lstStyle/>
+                    <a:p>
+                      <a:pPr algn="ctr"/>
+                      <a:r>
+                        <a:rPr sz="900" b="0"/>
+                        <a:t>287 ms (-75.6%)</a:t>
+                      </a:r>
+                    </a:p>
+                  </a:txBody>
+                  <a:tcPr anchor="ctr">
+                    <a:solidFill>
+                      <a:srgbClr val="f8fafc"/>
+                    </a:solidFill>
+                  </a:tcPr>
+                </a:tc>
+                <a:tc>
+                  <a:txBody>
+                    <a:bodyPr wrap="square"/>
+                    <a:lstStyle/>
+                    <a:p>
+                      <a:pPr algn="ctr"/>
+                      <a:r>
+                        <a:rPr sz="900" b="0"/>
+                        <a:t>23.5 req/s</a:t>
+                      </a:r>
+                    </a:p>
+                  </a:txBody>
+                  <a:tcPr anchor="ctr">
+                    <a:solidFill>
+                      <a:srgbClr val="f8fafc"/>
                     </a:solidFill>
                   </a:tcPr>
                 </a:tc>
@@ -6243,7 +6211,7 @@
         </p:nvSpPr>
         <p:spPr>
           <a:xfrm>
-            <a:off x="457200" y="5212080"/>
+            <a:off x="457200" y="5394960"/>
             <a:ext cx="10972800" cy="731520"/>
           </a:xfrm>
           <a:prstGeom prst="rect">
@@ -6271,7 +6239,7 @@
                   <a:srgbClr val="374151"/>
                 </a:solidFill>
               </a:rPr>
-              <a:t>3.4 delivers 23% lower TTFT and 57% higher throughput on same PD config. Tuning adds 39% TTFT reduction and 2.3x throughput via gpu_memory_utilization, max_num_seqs, and EPP optimization.</a:t>
+              <a:t>3.4 delivers 23% lower TTFT on the same PD config. Tuning pushes aggregated TTFT from 995ms to 287ms (-71%). Throughput (req/s) is relatively flat across configs because the system is saturated at 100 concurrent users — the real gain is latency, not throughput.</a:t>
             </a:r>
           </a:p>
         </p:txBody>
@@ -6394,7 +6362,7 @@
                     <a:p>
                       <a:pPr algn="ctr"/>
                       <a:r>
-                        <a:rPr sz="900" b="1">
+                        <a:rPr sz="800" b="1">
                           <a:solidFill>
                             <a:srgbClr val="FFFFFF"/>
                           </a:solidFill>
@@ -6416,7 +6384,7 @@
                     <a:p>
                       <a:pPr algn="ctr"/>
                       <a:r>
-                        <a:rPr sz="900" b="1">
+                        <a:rPr sz="800" b="1">
                           <a:solidFill>
                             <a:srgbClr val="FFFFFF"/>
                           </a:solidFill>
@@ -6438,7 +6406,7 @@
                     <a:p>
                       <a:pPr algn="ctr"/>
                       <a:r>
-                        <a:rPr sz="900" b="1">
+                        <a:rPr sz="800" b="1">
                           <a:solidFill>
                             <a:srgbClr val="FFFFFF"/>
                           </a:solidFill>
@@ -6460,7 +6428,7 @@
                     <a:p>
                       <a:pPr algn="ctr"/>
                       <a:r>
-                        <a:rPr sz="900" b="1">
+                        <a:rPr sz="800" b="1">
                           <a:solidFill>
                             <a:srgbClr val="FFFFFF"/>
                           </a:solidFill>
@@ -6482,7 +6450,7 @@
                     <a:p>
                       <a:pPr algn="ctr"/>
                       <a:r>
-                        <a:rPr sz="900" b="1">
+                        <a:rPr sz="800" b="1">
                           <a:solidFill>
                             <a:srgbClr val="FFFFFF"/>
                           </a:solidFill>
@@ -6504,7 +6472,7 @@
                     <a:p>
                       <a:pPr algn="ctr"/>
                       <a:r>
-                        <a:rPr sz="900" b="1">
+                        <a:rPr sz="800" b="1">
                           <a:solidFill>
                             <a:srgbClr val="FFFFFF"/>
                           </a:solidFill>
@@ -6749,7 +6717,7 @@
                       <a:pPr algn="l"/>
                       <a:r>
                         <a:rPr sz="900" b="0"/>
-                        <a:t>Throughput Mean</a:t>
+                        <a:t>Throughput</a:t>
                       </a:r>
                     </a:p>
                   </a:txBody>
@@ -6767,7 +6735,7 @@
                       <a:pPr algn="ctr"/>
                       <a:r>
                         <a:rPr sz="900" b="0"/>
-                        <a:t>16.5 req/s</a:t>
+                        <a:t>28.7 req/s</a:t>
                       </a:r>
                     </a:p>
                   </a:txBody>
@@ -6785,7 +6753,7 @@
                       <a:pPr algn="ctr"/>
                       <a:r>
                         <a:rPr sz="900" b="0"/>
-                        <a:t>18.4 req/s</a:t>
+                        <a:t>25.6 req/s</a:t>
                       </a:r>
                     </a:p>
                   </a:txBody>
@@ -6803,7 +6771,7 @@
                       <a:pPr algn="ctr"/>
                       <a:r>
                         <a:rPr sz="900" b="0"/>
-                        <a:t>+11.5%</a:t>
+                        <a:t>-10.8%</a:t>
                       </a:r>
                     </a:p>
                   </a:txBody>
@@ -6821,7 +6789,7 @@
                       <a:pPr algn="ctr"/>
                       <a:r>
                         <a:rPr sz="900" b="0"/>
-                        <a:t>28.8 req/s</a:t>
+                        <a:t>25.2 req/s</a:t>
                       </a:r>
                     </a:p>
                   </a:txBody>
@@ -6839,7 +6807,7 @@
                       <a:pPr algn="ctr"/>
                       <a:r>
                         <a:rPr sz="900" b="0"/>
-                        <a:t>+74.5%</a:t>
+                        <a:t>-12.2%</a:t>
                       </a:r>
                     </a:p>
                   </a:txBody>
@@ -6992,7 +6960,7 @@
                   <a:srgbClr val="374151"/>
                 </a:solidFill>
               </a:rPr>
-              <a:t>Aggregated — Same Config Comparison</a:t>
+              <a:t>Aggregated — Same Config Comparison (2xTP8)</a:t>
             </a:r>
           </a:p>
         </p:txBody>
@@ -7007,7 +6975,7 @@
         </p:nvGraphicFramePr>
         <p:xfrm>
           <a:off x="457200" y="3566160"/>
-          <a:ext cx="9144000" cy="1097280"/>
+          <a:ext cx="8229600" cy="1280160"/>
         </p:xfrm>
         <a:graphic>
           <a:graphicData uri="http://schemas.openxmlformats.org/drawingml/2006/table">
@@ -7016,26 +6984,25 @@
                 <a:tableStyleId>{5C22544A-7EE6-4342-B048-85BDC9FD1C3A}</a:tableStyleId>
               </a:tblPr>
               <a:tblGrid>
+                <a:gridCol w="1645920"/>
                 <a:gridCol w="1828800"/>
                 <a:gridCol w="1828800"/>
-                <a:gridCol w="1828800"/>
-                <a:gridCol w="1828800"/>
-                <a:gridCol w="1828800"/>
+                <a:gridCol w="2926080"/>
               </a:tblGrid>
-              <a:tr h="365760">
-                <a:tc>
-                  <a:txBody>
-                    <a:bodyPr wrap="square"/>
-                    <a:lstStyle/>
-                    <a:p>
-                      <a:pPr algn="ctr"/>
-                      <a:r>
-                        <a:rPr sz="900" b="1">
+              <a:tr h="320040">
+                <a:tc>
+                  <a:txBody>
+                    <a:bodyPr wrap="square"/>
+                    <a:lstStyle/>
+                    <a:p>
+                      <a:pPr algn="ctr"/>
+                      <a:r>
+                        <a:rPr sz="800" b="1">
                           <a:solidFill>
                             <a:srgbClr val="FFFFFF"/>
                           </a:solidFill>
                         </a:rPr>
-                        <a:t>Config</a:t>
+                        <a:t>Version</a:t>
                       </a:r>
                     </a:p>
                   </a:txBody>
@@ -7052,12 +7019,12 @@
                     <a:p>
                       <a:pPr algn="ctr"/>
                       <a:r>
-                        <a:rPr sz="900" b="1">
+                        <a:rPr sz="800" b="1">
                           <a:solidFill>
                             <a:srgbClr val="FFFFFF"/>
                           </a:solidFill>
                         </a:rPr>
-                        <a:t>3.3 TTFT P90</a:t>
+                        <a:t>TTFT P90</a:t>
                       </a:r>
                     </a:p>
                   </a:txBody>
@@ -7074,12 +7041,12 @@
                     <a:p>
                       <a:pPr algn="ctr"/>
                       <a:r>
-                        <a:rPr sz="900" b="1">
+                        <a:rPr sz="800" b="1">
                           <a:solidFill>
                             <a:srgbClr val="FFFFFF"/>
                           </a:solidFill>
                         </a:rPr>
-                        <a:t>3.4 TTFT P90</a:t>
+                        <a:t>Throughput</a:t>
                       </a:r>
                     </a:p>
                   </a:txBody>
@@ -7096,12 +7063,12 @@
                     <a:p>
                       <a:pPr algn="ctr"/>
                       <a:r>
-                        <a:rPr sz="900" b="1">
+                        <a:rPr sz="800" b="1">
                           <a:solidFill>
                             <a:srgbClr val="FFFFFF"/>
                           </a:solidFill>
                         </a:rPr>
-                        <a:t>3.3 Throughput</a:t>
+                        <a:t>vs 3.3 TTFT</a:t>
                       </a:r>
                     </a:p>
                   </a:txBody>
@@ -7111,30 +7078,8 @@
                     </a:solidFill>
                   </a:tcPr>
                 </a:tc>
-                <a:tc>
-                  <a:txBody>
-                    <a:bodyPr wrap="square"/>
-                    <a:lstStyle/>
-                    <a:p>
-                      <a:pPr algn="ctr"/>
-                      <a:r>
-                        <a:rPr sz="900" b="1">
-                          <a:solidFill>
-                            <a:srgbClr val="FFFFFF"/>
-                          </a:solidFill>
-                        </a:rPr>
-                        <a:t>3.4 Throughput</a:t>
-                      </a:r>
-                    </a:p>
-                  </a:txBody>
-                  <a:tcPr anchor="ctr">
-                    <a:solidFill>
-                      <a:srgbClr val="0c4a6e"/>
-                    </a:solidFill>
-                  </a:tcPr>
-                </a:tc>
               </a:tr>
-              <a:tr h="365760">
+              <a:tr h="320040">
                 <a:tc>
                   <a:txBody>
                     <a:bodyPr wrap="square"/>
@@ -7143,7 +7088,7 @@
                       <a:pPr algn="l"/>
                       <a:r>
                         <a:rPr sz="900" b="0"/>
-                        <a:t>2x TP8 (best 3.3)</a:t>
+                        <a:t>RHAIIS 3.3</a:t>
                       </a:r>
                     </a:p>
                   </a:txBody>
@@ -7179,7 +7124,7 @@
                       <a:pPr algn="ctr"/>
                       <a:r>
                         <a:rPr sz="900" b="0"/>
-                        <a:t>1,292 ms (+55.5%)</a:t>
+                        <a:t>26.8 req/s</a:t>
                       </a:r>
                     </a:p>
                   </a:txBody>
@@ -7197,7 +7142,7 @@
                       <a:pPr algn="ctr"/>
                       <a:r>
                         <a:rPr sz="900" b="0"/>
-                        <a:t>8.7 req/s</a:t>
+                        <a:t>Baseline</a:t>
                       </a:r>
                     </a:p>
                   </a:txBody>
@@ -7207,15 +7152,91 @@
                     </a:solidFill>
                   </a:tcPr>
                 </a:tc>
-                <a:tc>
-                  <a:txBody>
-                    <a:bodyPr wrap="square"/>
-                    <a:lstStyle/>
-                    <a:p>
-                      <a:pPr algn="ctr"/>
-                      <a:r>
-                        <a:rPr sz="900" b="0"/>
-                        <a:t>3.1 req/s (-64.4%)</a:t>
+              </a:tr>
+              <a:tr h="320040">
+                <a:tc>
+                  <a:txBody>
+                    <a:bodyPr wrap="square"/>
+                    <a:lstStyle/>
+                    <a:p>
+                      <a:pPr algn="l"/>
+                      <a:r>
+                        <a:rPr sz="900" b="0"/>
+                        <a:t>RHAIIS 3.4</a:t>
+                      </a:r>
+                    </a:p>
+                  </a:txBody>
+                  <a:tcPr anchor="ctr">
+                    <a:solidFill>
+                      <a:srgbClr val="f8fafc"/>
+                    </a:solidFill>
+                  </a:tcPr>
+                </a:tc>
+                <a:tc>
+                  <a:txBody>
+                    <a:bodyPr wrap="square"/>
+                    <a:lstStyle/>
+                    <a:p>
+                      <a:pPr algn="ctr"/>
+                      <a:r>
+                        <a:rPr sz="900" b="0"/>
+                        <a:t>1,292 ms</a:t>
+                      </a:r>
+                    </a:p>
+                  </a:txBody>
+                  <a:tcPr anchor="ctr">
+                    <a:solidFill>
+                      <a:srgbClr val="f8fafc"/>
+                    </a:solidFill>
+                  </a:tcPr>
+                </a:tc>
+                <a:tc>
+                  <a:txBody>
+                    <a:bodyPr wrap="square"/>
+                    <a:lstStyle/>
+                    <a:p>
+                      <a:pPr algn="ctr"/>
+                      <a:r>
+                        <a:rPr sz="900" b="0"/>
+                        <a:t>27.0 req/s</a:t>
+                      </a:r>
+                    </a:p>
+                  </a:txBody>
+                  <a:tcPr anchor="ctr">
+                    <a:solidFill>
+                      <a:srgbClr val="f8fafc"/>
+                    </a:solidFill>
+                  </a:tcPr>
+                </a:tc>
+                <a:tc>
+                  <a:txBody>
+                    <a:bodyPr wrap="square"/>
+                    <a:lstStyle/>
+                    <a:p>
+                      <a:pPr algn="ctr"/>
+                      <a:r>
+                        <a:rPr sz="900" b="0"/>
+                        <a:t>+55.5% (regression)</a:t>
+                      </a:r>
+                    </a:p>
+                  </a:txBody>
+                  <a:tcPr anchor="ctr">
+                    <a:solidFill>
+                      <a:srgbClr val="f8fafc"/>
+                    </a:solidFill>
+                  </a:tcPr>
+                </a:tc>
+              </a:tr>
+              <a:tr h="320040">
+                <a:tc>
+                  <a:txBody>
+                    <a:bodyPr wrap="square"/>
+                    <a:lstStyle/>
+                    <a:p>
+                      <a:pPr algn="l"/>
+                      <a:r>
+                        <a:rPr sz="900" b="0"/>
+                        <a:t>3.4 Tuned</a:t>
                       </a:r>
                     </a:p>
                   </a:txBody>
@@ -7225,95 +7246,57 @@
                     </a:solidFill>
                   </a:tcPr>
                 </a:tc>
-              </a:tr>
-              <a:tr h="365760">
-                <a:tc>
-                  <a:txBody>
-                    <a:bodyPr wrap="square"/>
-                    <a:lstStyle/>
-                    <a:p>
-                      <a:pPr algn="l"/>
-                      <a:r>
-                        <a:rPr sz="900" b="0"/>
-                        <a:t>2x TP8 (3.4 tuned)</a:t>
-                      </a:r>
-                    </a:p>
-                  </a:txBody>
-                  <a:tcPr anchor="ctr">
-                    <a:solidFill>
-                      <a:srgbClr val="f8fafc"/>
-                    </a:solidFill>
-                  </a:tcPr>
-                </a:tc>
-                <a:tc>
-                  <a:txBody>
-                    <a:bodyPr wrap="square"/>
-                    <a:lstStyle/>
-                    <a:p>
-                      <a:pPr algn="ctr"/>
-                      <a:r>
-                        <a:rPr sz="900" b="0"/>
-                        <a:t/>
-                      </a:r>
-                    </a:p>
-                  </a:txBody>
-                  <a:tcPr anchor="ctr">
-                    <a:solidFill>
-                      <a:srgbClr val="f8fafc"/>
-                    </a:solidFill>
-                  </a:tcPr>
-                </a:tc>
-                <a:tc>
-                  <a:txBody>
-                    <a:bodyPr wrap="square"/>
-                    <a:lstStyle/>
-                    <a:p>
-                      <a:pPr algn="ctr"/>
-                      <a:r>
-                        <a:rPr sz="900" b="0"/>
-                        <a:t>463 ms (-44.3%)</a:t>
-                      </a:r>
-                    </a:p>
-                  </a:txBody>
-                  <a:tcPr anchor="ctr">
-                    <a:solidFill>
-                      <a:srgbClr val="f8fafc"/>
-                    </a:solidFill>
-                  </a:tcPr>
-                </a:tc>
-                <a:tc>
-                  <a:txBody>
-                    <a:bodyPr wrap="square"/>
-                    <a:lstStyle/>
-                    <a:p>
-                      <a:pPr algn="ctr"/>
-                      <a:r>
-                        <a:rPr sz="900" b="0"/>
-                        <a:t/>
-                      </a:r>
-                    </a:p>
-                  </a:txBody>
-                  <a:tcPr anchor="ctr">
-                    <a:solidFill>
-                      <a:srgbClr val="f8fafc"/>
-                    </a:solidFill>
-                  </a:tcPr>
-                </a:tc>
-                <a:tc>
-                  <a:txBody>
-                    <a:bodyPr wrap="square"/>
-                    <a:lstStyle/>
-                    <a:p>
-                      <a:pPr algn="ctr"/>
-                      <a:r>
-                        <a:rPr sz="900" b="0"/>
-                        <a:t>21.1 req/s (+142.5%)</a:t>
-                      </a:r>
-                    </a:p>
-                  </a:txBody>
-                  <a:tcPr anchor="ctr">
-                    <a:solidFill>
-                      <a:srgbClr val="f8fafc"/>
+                <a:tc>
+                  <a:txBody>
+                    <a:bodyPr wrap="square"/>
+                    <a:lstStyle/>
+                    <a:p>
+                      <a:pPr algn="ctr"/>
+                      <a:r>
+                        <a:rPr sz="900" b="0"/>
+                        <a:t>463 ms</a:t>
+                      </a:r>
+                    </a:p>
+                  </a:txBody>
+                  <a:tcPr anchor="ctr">
+                    <a:solidFill>
+                      <a:srgbClr val="ffffff"/>
+                    </a:solidFill>
+                  </a:tcPr>
+                </a:tc>
+                <a:tc>
+                  <a:txBody>
+                    <a:bodyPr wrap="square"/>
+                    <a:lstStyle/>
+                    <a:p>
+                      <a:pPr algn="ctr"/>
+                      <a:r>
+                        <a:rPr sz="900" b="0"/>
+                        <a:t>26.9 req/s</a:t>
+                      </a:r>
+                    </a:p>
+                  </a:txBody>
+                  <a:tcPr anchor="ctr">
+                    <a:solidFill>
+                      <a:srgbClr val="ffffff"/>
+                    </a:solidFill>
+                  </a:tcPr>
+                </a:tc>
+                <a:tc>
+                  <a:txBody>
+                    <a:bodyPr wrap="square"/>
+                    <a:lstStyle/>
+                    <a:p>
+                      <a:pPr algn="ctr"/>
+                      <a:r>
+                        <a:rPr sz="900" b="0"/>
+                        <a:t>-44.3% (recovered)</a:t>
+                      </a:r>
+                    </a:p>
+                  </a:txBody>
+                  <a:tcPr anchor="ctr">
+                    <a:solidFill>
+                      <a:srgbClr val="ffffff"/>
                     </a:solidFill>
                   </a:tcPr>
                 </a:tc>
@@ -7330,7 +7313,7 @@
         </p:nvSpPr>
         <p:spPr>
           <a:xfrm>
-            <a:off x="457200" y="4846320"/>
+            <a:off x="457200" y="5029200"/>
             <a:ext cx="10972800" cy="914400"/>
           </a:xfrm>
           <a:prstGeom prst="rect">
@@ -7358,7 +7341,7 @@
                   <a:srgbClr val="374151"/>
                 </a:solidFill>
               </a:rPr>
-              <a:t>PD improved 10% TTFT in 3.4. Aggregated TP8 </a:t>
+              <a:t>PD improved 10% TTFT. Aggregated TP8 </a:t>
             </a:r>
             <a:r>
               <a:rPr sz="1000" b="1">
@@ -7382,7 +7365,15 @@
                   <a:srgbClr val="065F46"/>
                 </a:solidFill>
               </a:rPr>
-              <a:t>fully recovered to -44.3% below 3.3 baseline with tuning.</a:t>
+              <a:t>fully recovered to -44.3% below 3.3 baseline with tuning. </a:t>
+            </a:r>
+            <a:r>
+              <a:rPr sz="1000" b="0">
+                <a:solidFill>
+                  <a:srgbClr val="374151"/>
+                </a:solidFill>
+              </a:rPr>
+              <a:t>Throughput stays ~27 req/s across all versions — the system is concurrency-limited at 100 users.</a:t>
             </a:r>
           </a:p>
           <a:p>
@@ -7443,7 +7434,7 @@
                   <a:srgbClr val="0C4A6E"/>
                 </a:solidFill>
               </a:rPr>
-              <a:t>Regression Summary</a:t>
+              <a:t>Regression Summary — TTFT P90 (ms)</a:t>
             </a:r>
           </a:p>
         </p:txBody>
@@ -7458,7 +7449,7 @@
         </p:nvGraphicFramePr>
         <p:xfrm>
           <a:off x="457200" y="822960"/>
-          <a:ext cx="9144000" cy="2011680"/>
+          <a:ext cx="9509760" cy="1828800"/>
         </p:xfrm>
         <a:graphic>
           <a:graphicData uri="http://schemas.openxmlformats.org/drawingml/2006/table">
@@ -7469,20 +7460,20 @@
               <a:tblGrid>
                 <a:gridCol w="2286000"/>
                 <a:gridCol w="1371600"/>
-                <a:gridCol w="1371600"/>
-                <a:gridCol w="1371600"/>
-                <a:gridCol w="1371600"/>
-                <a:gridCol w="1371600"/>
+                <a:gridCol w="1645920"/>
+                <a:gridCol w="1097280"/>
+                <a:gridCol w="2011680"/>
+                <a:gridCol w="1097280"/>
               </a:tblGrid>
-              <a:tr h="402336">
-                <a:tc>
-                  <a:txBody>
-                    <a:bodyPr wrap="square"/>
-                    <a:lstStyle/>
-                    <a:p>
-                      <a:pPr algn="ctr"/>
-                      <a:r>
-                        <a:rPr sz="900" b="1">
+              <a:tr h="365760">
+                <a:tc>
+                  <a:txBody>
+                    <a:bodyPr wrap="square"/>
+                    <a:lstStyle/>
+                    <a:p>
+                      <a:pPr algn="ctr"/>
+                      <a:r>
+                        <a:rPr sz="800" b="1">
                           <a:solidFill>
                             <a:srgbClr val="FFFFFF"/>
                           </a:solidFill>
@@ -7504,7 +7495,7 @@
                     <a:p>
                       <a:pPr algn="ctr"/>
                       <a:r>
-                        <a:rPr sz="900" b="1">
+                        <a:rPr sz="800" b="1">
                           <a:solidFill>
                             <a:srgbClr val="FFFFFF"/>
                           </a:solidFill>
@@ -7526,7 +7517,7 @@
                     <a:p>
                       <a:pPr algn="ctr"/>
                       <a:r>
-                        <a:rPr sz="900" b="1">
+                        <a:rPr sz="800" b="1">
                           <a:solidFill>
                             <a:srgbClr val="FFFFFF"/>
                           </a:solidFill>
@@ -7548,7 +7539,7 @@
                     <a:p>
                       <a:pPr algn="ctr"/>
                       <a:r>
-                        <a:rPr sz="900" b="1">
+                        <a:rPr sz="800" b="1">
                           <a:solidFill>
                             <a:srgbClr val="FFFFFF"/>
                           </a:solidFill>
@@ -7570,7 +7561,7 @@
                     <a:p>
                       <a:pPr algn="ctr"/>
                       <a:r>
-                        <a:rPr sz="900" b="1">
+                        <a:rPr sz="800" b="1">
                           <a:solidFill>
                             <a:srgbClr val="FFFFFF"/>
                           </a:solidFill>
@@ -7592,7 +7583,7 @@
                     <a:p>
                       <a:pPr algn="ctr"/>
                       <a:r>
-                        <a:rPr sz="900" b="1">
+                        <a:rPr sz="800" b="1">
                           <a:solidFill>
                             <a:srgbClr val="FFFFFF"/>
                           </a:solidFill>
@@ -7608,7 +7599,7 @@
                   </a:tcPr>
                 </a:tc>
               </a:tr>
-              <a:tr h="402336">
+              <a:tr h="365760">
                 <a:tc>
                   <a:txBody>
                     <a:bodyPr wrap="square"/>
@@ -7616,11 +7607,7 @@
                     <a:p>
                       <a:pPr algn="l"/>
                       <a:r>
-                        <a:rPr sz="900" b="0">
-                          <a:solidFill>
-                            <a:srgbClr val="374151"/>
-                          </a:solidFill>
-                        </a:rPr>
+                        <a:rPr sz="900" b="0"/>
                         <a:t>Qwen PD (3P+1D TP4)</a:t>
                       </a:r>
                     </a:p>
@@ -7638,11 +7625,7 @@
                     <a:p>
                       <a:pPr algn="ctr"/>
                       <a:r>
-                        <a:rPr sz="900" b="0">
-                          <a:solidFill>
-                            <a:srgbClr val="374151"/>
-                          </a:solidFill>
-                        </a:rPr>
+                        <a:rPr sz="900" b="0"/>
                         <a:t>880 ms</a:t>
                       </a:r>
                     </a:p>
@@ -7660,11 +7643,7 @@
                     <a:p>
                       <a:pPr algn="ctr"/>
                       <a:r>
-                        <a:rPr sz="900" b="0">
-                          <a:solidFill>
-                            <a:srgbClr val="374151"/>
-                          </a:solidFill>
-                        </a:rPr>
+                        <a:rPr sz="900" b="0"/>
                         <a:t>675 ms</a:t>
                       </a:r>
                     </a:p>
@@ -7682,11 +7661,7 @@
                     <a:p>
                       <a:pPr algn="ctr"/>
                       <a:r>
-                        <a:rPr sz="900" b="1">
-                          <a:solidFill>
-                            <a:srgbClr val="065F46"/>
-                          </a:solidFill>
-                        </a:rPr>
+                        <a:rPr sz="900" b="0"/>
                         <a:t>-23%</a:t>
                       </a:r>
                     </a:p>
@@ -7704,11 +7679,7 @@
                     <a:p>
                       <a:pPr algn="ctr"/>
                       <a:r>
-                        <a:rPr sz="900" b="1">
-                          <a:solidFill>
-                            <a:srgbClr val="374151"/>
-                          </a:solidFill>
-                        </a:rPr>
+                        <a:rPr sz="900" b="0"/>
                         <a:t>534 ms</a:t>
                       </a:r>
                     </a:p>
@@ -7726,11 +7697,7 @@
                     <a:p>
                       <a:pPr algn="ctr"/>
                       <a:r>
-                        <a:rPr sz="900" b="1">
-                          <a:solidFill>
-                            <a:srgbClr val="065F46"/>
-                          </a:solidFill>
-                        </a:rPr>
+                        <a:rPr sz="900" b="0"/>
                         <a:t>-39%</a:t>
                       </a:r>
                     </a:p>
@@ -7742,7 +7709,7 @@
                   </a:tcPr>
                 </a:tc>
               </a:tr>
-              <a:tr h="402336">
+              <a:tr h="365760">
                 <a:tc>
                   <a:txBody>
                     <a:bodyPr wrap="square"/>
@@ -7750,12 +7717,8 @@
                     <a:p>
                       <a:pPr algn="l"/>
                       <a:r>
-                        <a:rPr sz="900" b="0">
-                          <a:solidFill>
-                            <a:srgbClr val="374151"/>
-                          </a:solidFill>
-                        </a:rPr>
-                        <a:t>Qwen Agg (4xTP4)</a:t>
+                        <a:rPr sz="900" b="0"/>
+                        <a:t>Qwen Agg best</a:t>
                       </a:r>
                     </a:p>
                   </a:txBody>
@@ -7772,12 +7735,8 @@
                     <a:p>
                       <a:pPr algn="ctr"/>
                       <a:r>
-                        <a:rPr sz="900" b="0">
-                          <a:solidFill>
-                            <a:srgbClr val="374151"/>
-                          </a:solidFill>
-                        </a:rPr>
-                        <a:t>1,177 ms</a:t>
+                        <a:rPr sz="900" b="0"/>
+                        <a:t>1,177 ms (4xTP4)</a:t>
                       </a:r>
                     </a:p>
                   </a:txBody>
@@ -7794,12 +7753,8 @@
                     <a:p>
                       <a:pPr algn="ctr"/>
                       <a:r>
-                        <a:rPr sz="900" b="0">
-                          <a:solidFill>
-                            <a:srgbClr val="374151"/>
-                          </a:solidFill>
-                        </a:rPr>
-                        <a:t>1,162 ms</a:t>
+                        <a:rPr sz="900" b="0"/>
+                        <a:t>995 ms (8xTP2)</a:t>
                       </a:r>
                     </a:p>
                   </a:txBody>
@@ -7816,12 +7771,8 @@
                     <a:p>
                       <a:pPr algn="ctr"/>
                       <a:r>
-                        <a:rPr sz="900" b="1">
-                          <a:solidFill>
-                            <a:srgbClr val="065F46"/>
-                          </a:solidFill>
-                        </a:rPr>
-                        <a:t>-1%</a:t>
+                        <a:rPr sz="900" b="0"/>
+                        <a:t>-15%</a:t>
                       </a:r>
                     </a:p>
                   </a:txBody>
@@ -7838,12 +7789,8 @@
                     <a:p>
                       <a:pPr algn="ctr"/>
                       <a:r>
-                        <a:rPr sz="900" b="1">
-                          <a:solidFill>
-                            <a:srgbClr val="374151"/>
-                          </a:solidFill>
-                        </a:rPr>
-                        <a:t>524 ms</a:t>
+                        <a:rPr sz="900" b="0"/>
+                        <a:t>287 ms (2xTP8+EPP)</a:t>
                       </a:r>
                     </a:p>
                   </a:txBody>
@@ -7860,12 +7807,8 @@
                     <a:p>
                       <a:pPr algn="ctr"/>
                       <a:r>
-                        <a:rPr sz="900" b="1">
-                          <a:solidFill>
-                            <a:srgbClr val="065F46"/>
-                          </a:solidFill>
-                        </a:rPr>
-                        <a:t>-56%</a:t>
+                        <a:rPr sz="900" b="0"/>
+                        <a:t>-76%</a:t>
                       </a:r>
                     </a:p>
                   </a:txBody>
@@ -7876,7 +7819,7 @@
                   </a:tcPr>
                 </a:tc>
               </a:tr>
-              <a:tr h="402336">
+              <a:tr h="365760">
                 <a:tc>
                   <a:txBody>
                     <a:bodyPr wrap="square"/>
@@ -7884,11 +7827,7 @@
                     <a:p>
                       <a:pPr algn="l"/>
                       <a:r>
-                        <a:rPr sz="900" b="0">
-                          <a:solidFill>
-                            <a:srgbClr val="374151"/>
-                          </a:solidFill>
-                        </a:rPr>
+                        <a:rPr sz="900" b="0"/>
                         <a:t>Llama PD (3P+1D TP4)</a:t>
                       </a:r>
                     </a:p>
@@ -7906,11 +7845,7 @@
                     <a:p>
                       <a:pPr algn="ctr"/>
                       <a:r>
-                        <a:rPr sz="900" b="0">
-                          <a:solidFill>
-                            <a:srgbClr val="374151"/>
-                          </a:solidFill>
-                        </a:rPr>
+                        <a:rPr sz="900" b="0"/>
                         <a:t>1,027 ms</a:t>
                       </a:r>
                     </a:p>
@@ -7928,11 +7863,7 @@
                     <a:p>
                       <a:pPr algn="ctr"/>
                       <a:r>
-                        <a:rPr sz="900" b="0">
-                          <a:solidFill>
-                            <a:srgbClr val="374151"/>
-                          </a:solidFill>
-                        </a:rPr>
+                        <a:rPr sz="900" b="0"/>
                         <a:t>925 ms</a:t>
                       </a:r>
                     </a:p>
@@ -7950,11 +7881,7 @@
                     <a:p>
                       <a:pPr algn="ctr"/>
                       <a:r>
-                        <a:rPr sz="900" b="1">
-                          <a:solidFill>
-                            <a:srgbClr val="065F46"/>
-                          </a:solidFill>
-                        </a:rPr>
+                        <a:rPr sz="900" b="0"/>
                         <a:t>-10%</a:t>
                       </a:r>
                     </a:p>
@@ -7972,11 +7899,7 @@
                     <a:p>
                       <a:pPr algn="ctr"/>
                       <a:r>
-                        <a:rPr sz="900" b="1">
-                          <a:solidFill>
-                            <a:srgbClr val="374151"/>
-                          </a:solidFill>
-                        </a:rPr>
+                        <a:rPr sz="900" b="0"/>
                         <a:t>681 ms</a:t>
                       </a:r>
                     </a:p>
@@ -7994,11 +7917,7 @@
                     <a:p>
                       <a:pPr algn="ctr"/>
                       <a:r>
-                        <a:rPr sz="900" b="1">
-                          <a:solidFill>
-                            <a:srgbClr val="065F46"/>
-                          </a:solidFill>
-                        </a:rPr>
+                        <a:rPr sz="900" b="0"/>
                         <a:t>-34%</a:t>
                       </a:r>
                     </a:p>
@@ -8010,7 +7929,7 @@
                   </a:tcPr>
                 </a:tc>
               </a:tr>
-              <a:tr h="402336">
+              <a:tr h="365760">
                 <a:tc>
                   <a:txBody>
                     <a:bodyPr wrap="square"/>
@@ -8018,11 +7937,7 @@
                     <a:p>
                       <a:pPr algn="l"/>
                       <a:r>
-                        <a:rPr sz="900" b="0">
-                          <a:solidFill>
-                            <a:srgbClr val="374151"/>
-                          </a:solidFill>
-                        </a:rPr>
+                        <a:rPr sz="900" b="0"/>
                         <a:t>Llama Agg (2xTP8)</a:t>
                       </a:r>
                     </a:p>
@@ -8040,11 +7955,7 @@
                     <a:p>
                       <a:pPr algn="ctr"/>
                       <a:r>
-                        <a:rPr sz="900" b="0">
-                          <a:solidFill>
-                            <a:srgbClr val="374151"/>
-                          </a:solidFill>
-                        </a:rPr>
+                        <a:rPr sz="900" b="0"/>
                         <a:t>831 ms</a:t>
                       </a:r>
                     </a:p>
@@ -8062,11 +7973,7 @@
                     <a:p>
                       <a:pPr algn="ctr"/>
                       <a:r>
-                        <a:rPr sz="900" b="0">
-                          <a:solidFill>
-                            <a:srgbClr val="374151"/>
-                          </a:solidFill>
-                        </a:rPr>
+                        <a:rPr sz="900" b="0"/>
                         <a:t>1,292 ms</a:t>
                       </a:r>
                     </a:p>
@@ -8084,11 +7991,7 @@
                     <a:p>
                       <a:pPr algn="ctr"/>
                       <a:r>
-                        <a:rPr sz="900" b="1">
-                          <a:solidFill>
-                            <a:srgbClr val="991B1B"/>
-                          </a:solidFill>
-                        </a:rPr>
+                        <a:rPr sz="900" b="0"/>
                         <a:t>+55%</a:t>
                       </a:r>
                     </a:p>
@@ -8106,11 +8009,7 @@
                     <a:p>
                       <a:pPr algn="ctr"/>
                       <a:r>
-                        <a:rPr sz="900" b="1">
-                          <a:solidFill>
-                            <a:srgbClr val="374151"/>
-                          </a:solidFill>
-                        </a:rPr>
+                        <a:rPr sz="900" b="0"/>
                         <a:t>463 ms</a:t>
                       </a:r>
                     </a:p>
@@ -8128,11 +8027,7 @@
                     <a:p>
                       <a:pPr algn="ctr"/>
                       <a:r>
-                        <a:rPr sz="900" b="1">
-                          <a:solidFill>
-                            <a:srgbClr val="065F46"/>
-                          </a:solidFill>
-                        </a:rPr>
+                        <a:rPr sz="900" b="0"/>
                         <a:t>-44%</a:t>
                       </a:r>
                     </a:p>
@@ -8156,7 +8051,7 @@
         </p:nvSpPr>
         <p:spPr>
           <a:xfrm>
-            <a:off x="457200" y="3017520"/>
+            <a:off x="457200" y="2926080"/>
             <a:ext cx="10972800" cy="274320"/>
           </a:xfrm>
           <a:prstGeom prst="rect">
@@ -8189,7 +8084,7 @@
         </p:nvSpPr>
         <p:spPr>
           <a:xfrm>
-            <a:off x="457200" y="3383280"/>
+            <a:off x="457200" y="3291840"/>
             <a:ext cx="10972800" cy="2286000"/>
           </a:xfrm>
           <a:prstGeom prst="rect">
@@ -8209,7 +8104,7 @@
                   <a:srgbClr val="374151"/>
                 </a:solidFill>
               </a:rPr>
-              <a:t>• PD consistently improves in 3.4</a:t>
+              <a:t>• PD consistently improves TTFT in 3.4</a:t>
             </a:r>
             <a:r>
               <a:rPr sz="1100" b="0">
@@ -8217,7 +8112,7 @@
                   <a:srgbClr val="374151"/>
                 </a:solidFill>
               </a:rPr>
-              <a:t> — both models show 10-23% TTFT improvement on same config</a:t>
+              <a:t> — both models show 10-23% lower TTFT on same config</a:t>
             </a:r>
           </a:p>
           <a:p>
@@ -8278,7 +8173,7 @@
                   <a:srgbClr val="374151"/>
                 </a:solidFill>
               </a:rPr>
-              <a:t>• Tuning adds 34-56% on top</a:t>
+              <a:t>• TTFT is where the gains are</a:t>
             </a:r>
             <a:r>
               <a:rPr sz="1100" b="0">
@@ -8286,7 +8181,30 @@
                   <a:srgbClr val="374151"/>
                 </a:solidFill>
               </a:rPr>
-              <a:t> — auto-profiling gpu_memory_utilization, max_num_seqs, block_size, EPP weights</a:t>
+              <a:t> — throughput (req/s) is flat at ~25 req/s because 100 users saturate the system</a:t>
+            </a:r>
+          </a:p>
+          <a:p>
+            <a:pPr>
+              <a:spcBef>
+                <a:spcPts val="400"/>
+              </a:spcBef>
+            </a:pPr>
+            <a:r>
+              <a:rPr sz="1100" b="1">
+                <a:solidFill>
+                  <a:srgbClr val="374151"/>
+                </a:solidFill>
+              </a:rPr>
+              <a:t>• Tuning adds 34-76% TTFT improvement</a:t>
+            </a:r>
+            <a:r>
+              <a:rPr sz="1100" b="0">
+                <a:solidFill>
+                  <a:srgbClr val="374151"/>
+                </a:solidFill>
+              </a:rPr>
+              <a:t> — via gpu_memory_utilization, max_num_seqs, block_size, EPP weights</a:t>
             </a:r>
           </a:p>
           <a:p>
@@ -8408,22 +8326,7 @@
                   <a:srgbClr val="374151"/>
                 </a:solidFill>
               </a:rPr>
-              <a:t>RHAIIS 3.4 enables testing configurations where prefill pods use more GPUs (higher TP) than decode pods. This allows dedicating more compute to the prefill-heavy first token generation while using fewer GPUs for the lighter decode phase.</a:t>
-            </a:r>
-          </a:p>
-          <a:p>
-            <a:pPr>
-              <a:spcBef>
-                <a:spcPts val="800"/>
-              </a:spcBef>
-            </a:pPr>
-            <a:r>
-              <a:rPr sz="1100" b="0">
-                <a:solidFill>
-                  <a:srgbClr val="374151"/>
-                </a:solidFill>
-              </a:rPr>
-              <a:t>This was disabled for RHAIIS 3.3 (llm-d v0.4.0) due to NIXL KV transfer crashes with asymmetric TP. Inftune Studio now enables asymmetric TP by default for 3.4+ and automatically disables it for 3.3.</a:t>
+              <a:t>RHAIIS 3.4 enables configurations where prefill pods use more GPUs (higher TP) than decode pods. This allows dedicating more compute to prefill while using fewer GPUs for decode. Disabled for RHAIIS 3.3 due to NIXL KV transfer crashes with asymmetric TP. ServeIt Studio enables it by default for 3.4+.</a:t>
             </a:r>
           </a:p>
         </p:txBody>
@@ -8436,7 +8339,7 @@
         </p:nvSpPr>
         <p:spPr>
           <a:xfrm>
-            <a:off x="457200" y="2743200"/>
+            <a:off x="457200" y="2560320"/>
             <a:ext cx="10972800" cy="365760"/>
           </a:xfrm>
           <a:prstGeom prst="rect">
@@ -8470,8 +8373,8 @@
           <p:nvPr/>
         </p:nvGraphicFramePr>
         <p:xfrm>
-          <a:off x="457200" y="3200400"/>
-          <a:ext cx="10972800" cy="1645920"/>
+          <a:off x="457200" y="3017520"/>
+          <a:ext cx="10972800" cy="1463040"/>
         </p:xfrm>
         <a:graphic>
           <a:graphicData uri="http://schemas.openxmlformats.org/drawingml/2006/table">
@@ -8484,15 +8387,15 @@
                 <a:gridCol w="3200400"/>
                 <a:gridCol w="6400800"/>
               </a:tblGrid>
-              <a:tr h="411480">
-                <a:tc>
-                  <a:txBody>
-                    <a:bodyPr wrap="square"/>
-                    <a:lstStyle/>
-                    <a:p>
-                      <a:pPr algn="ctr"/>
-                      <a:r>
-                        <a:rPr sz="900" b="1">
+              <a:tr h="365760">
+                <a:tc>
+                  <a:txBody>
+                    <a:bodyPr wrap="square"/>
+                    <a:lstStyle/>
+                    <a:p>
+                      <a:pPr algn="ctr"/>
+                      <a:r>
+                        <a:rPr sz="800" b="1">
                           <a:solidFill>
                             <a:srgbClr val="FFFFFF"/>
                           </a:solidFill>
@@ -8514,7 +8417,7 @@
                     <a:p>
                       <a:pPr algn="ctr"/>
                       <a:r>
-                        <a:rPr sz="900" b="1">
+                        <a:rPr sz="800" b="1">
                           <a:solidFill>
                             <a:srgbClr val="FFFFFF"/>
                           </a:solidFill>
@@ -8536,7 +8439,7 @@
                     <a:p>
                       <a:pPr algn="ctr"/>
                       <a:r>
-                        <a:rPr sz="900" b="1">
+                        <a:rPr sz="800" b="1">
                           <a:solidFill>
                             <a:srgbClr val="FFFFFF"/>
                           </a:solidFill>
@@ -8552,7 +8455,7 @@
                   </a:tcPr>
                 </a:tc>
               </a:tr>
-              <a:tr h="411480">
+              <a:tr h="365760">
                 <a:tc>
                   <a:txBody>
                     <a:bodyPr wrap="square"/>
@@ -8560,11 +8463,7 @@
                     <a:p>
                       <a:pPr algn="l"/>
                       <a:r>
-                        <a:rPr sz="900" b="1">
-                          <a:solidFill>
-                            <a:srgbClr val="0C4A6E"/>
-                          </a:solidFill>
-                        </a:rPr>
+                        <a:rPr sz="900" b="0"/>
                         <a:t>vllm#43396</a:t>
                       </a:r>
                     </a:p>
@@ -8580,10 +8479,104 @@
                     <a:bodyPr wrap="square"/>
                     <a:lstStyle/>
                     <a:p>
+                      <a:pPr algn="ctr"/>
+                      <a:r>
+                        <a:rPr sz="900" b="0"/>
+                        <a:t>FP8 MoE CUTLASS OOB at batch 8192</a:t>
+                      </a:r>
+                    </a:p>
+                  </a:txBody>
+                  <a:tcPr anchor="ctr">
+                    <a:solidFill>
+                      <a:srgbClr val="ffffff"/>
+                    </a:solidFill>
+                  </a:tcPr>
+                </a:tc>
+                <a:tc>
+                  <a:txBody>
+                    <a:bodyPr wrap="square"/>
+                    <a:lstStyle/>
+                    <a:p>
+                      <a:pPr algn="ctr"/>
+                      <a:r>
+                        <a:rPr sz="900" b="0"/>
+                        <a:t>Runtime patch applied in templates. Affects FP8 MoE at high batch sizes.</a:t>
+                      </a:r>
+                    </a:p>
+                  </a:txBody>
+                  <a:tcPr anchor="ctr">
+                    <a:solidFill>
+                      <a:srgbClr val="ffffff"/>
+                    </a:solidFill>
+                  </a:tcPr>
+                </a:tc>
+              </a:tr>
+              <a:tr h="365760">
+                <a:tc>
+                  <a:txBody>
+                    <a:bodyPr wrap="square"/>
+                    <a:lstStyle/>
+                    <a:p>
                       <a:pPr algn="l"/>
                       <a:r>
-                        <a:rPr sz="800" b="0"/>
-                        <a:t>FP8 MoE CUTLASS OOB at batch 8192</a:t>
+                        <a:rPr sz="900" b="0"/>
+                        <a:t>vllm#43398</a:t>
+                      </a:r>
+                    </a:p>
+                  </a:txBody>
+                  <a:tcPr anchor="ctr">
+                    <a:solidFill>
+                      <a:srgbClr val="f8fafc"/>
+                    </a:solidFill>
+                  </a:tcPr>
+                </a:tc>
+                <a:tc>
+                  <a:txBody>
+                    <a:bodyPr wrap="square"/>
+                    <a:lstStyle/>
+                    <a:p>
+                      <a:pPr algn="ctr"/>
+                      <a:r>
+                        <a:rPr sz="900" b="0"/>
+                        <a:t>NIXL KV transfer crash with asymmetric TP</a:t>
+                      </a:r>
+                    </a:p>
+                  </a:txBody>
+                  <a:tcPr anchor="ctr">
+                    <a:solidFill>
+                      <a:srgbClr val="f8fafc"/>
+                    </a:solidFill>
+                  </a:tcPr>
+                </a:tc>
+                <a:tc>
+                  <a:txBody>
+                    <a:bodyPr wrap="square"/>
+                    <a:lstStyle/>
+                    <a:p>
+                      <a:pPr algn="ctr"/>
+                      <a:r>
+                        <a:rPr sz="900" b="0"/>
+                        <a:t>Asymmetric TP disabled for llm-d v0.4.0. Enabled for v0.6.0+.</a:t>
+                      </a:r>
+                    </a:p>
+                  </a:txBody>
+                  <a:tcPr anchor="ctr">
+                    <a:solidFill>
+                      <a:srgbClr val="f8fafc"/>
+                    </a:solidFill>
+                  </a:tcPr>
+                </a:tc>
+              </a:tr>
+              <a:tr h="365760">
+                <a:tc>
+                  <a:txBody>
+                    <a:bodyPr wrap="square"/>
+                    <a:lstStyle/>
+                    <a:p>
+                      <a:pPr algn="l"/>
+                      <a:r>
+                        <a:rPr sz="900" b="0"/>
+                        <a:t>vllm#43523</a:t>
                       </a:r>
                     </a:p>
                   </a:txBody>
@@ -8598,10 +8591,10 @@
                     <a:bodyPr wrap="square"/>
                     <a:lstStyle/>
                     <a:p>
-                      <a:pPr algn="l"/>
-                      <a:r>
-                        <a:rPr sz="800" b="0"/>
-                        <a:t>Runtime patch applied in Inftune Studio templates. Affects FP8 MoE models at high batch sizes.</a:t>
+                      <a:pPr algn="ctr"/>
+                      <a:r>
+                        <a:rPr sz="900" b="0"/>
+                        <a:t>vLLM memory profiling regression</a:t>
                       </a:r>
                     </a:p>
                   </a:txBody>
@@ -8611,117 +8604,15 @@
                     </a:solidFill>
                   </a:tcPr>
                 </a:tc>
-              </a:tr>
-              <a:tr h="411480">
-                <a:tc>
-                  <a:txBody>
-                    <a:bodyPr wrap="square"/>
-                    <a:lstStyle/>
-                    <a:p>
-                      <a:pPr algn="l"/>
-                      <a:r>
-                        <a:rPr sz="900" b="1">
-                          <a:solidFill>
-                            <a:srgbClr val="0C4A6E"/>
-                          </a:solidFill>
-                        </a:rPr>
-                        <a:t>vllm#43398</a:t>
-                      </a:r>
-                    </a:p>
-                  </a:txBody>
-                  <a:tcPr anchor="ctr">
-                    <a:solidFill>
-                      <a:srgbClr val="f8fafc"/>
-                    </a:solidFill>
-                  </a:tcPr>
-                </a:tc>
-                <a:tc>
-                  <a:txBody>
-                    <a:bodyPr wrap="square"/>
-                    <a:lstStyle/>
-                    <a:p>
-                      <a:pPr algn="l"/>
-                      <a:r>
-                        <a:rPr sz="800" b="0"/>
-                        <a:t>NIXL KV transfer crash with asymmetric TP</a:t>
-                      </a:r>
-                    </a:p>
-                  </a:txBody>
-                  <a:tcPr anchor="ctr">
-                    <a:solidFill>
-                      <a:srgbClr val="f8fafc"/>
-                    </a:solidFill>
-                  </a:tcPr>
-                </a:tc>
-                <a:tc>
-                  <a:txBody>
-                    <a:bodyPr wrap="square"/>
-                    <a:lstStyle/>
-                    <a:p>
-                      <a:pPr algn="l"/>
-                      <a:r>
-                        <a:rPr sz="800" b="0"/>
-                        <a:t>Asymmetric TP disabled for llm-d v0.4.0. Enabled by default for v0.6.0+.</a:t>
-                      </a:r>
-                    </a:p>
-                  </a:txBody>
-                  <a:tcPr anchor="ctr">
-                    <a:solidFill>
-                      <a:srgbClr val="f8fafc"/>
-                    </a:solidFill>
-                  </a:tcPr>
-                </a:tc>
-              </a:tr>
-              <a:tr h="411480">
-                <a:tc>
-                  <a:txBody>
-                    <a:bodyPr wrap="square"/>
-                    <a:lstStyle/>
-                    <a:p>
-                      <a:pPr algn="l"/>
-                      <a:r>
-                        <a:rPr sz="900" b="1">
-                          <a:solidFill>
-                            <a:srgbClr val="0C4A6E"/>
-                          </a:solidFill>
-                        </a:rPr>
-                        <a:t>vllm#43523</a:t>
-                      </a:r>
-                    </a:p>
-                  </a:txBody>
-                  <a:tcPr anchor="ctr">
-                    <a:solidFill>
-                      <a:srgbClr val="ffffff"/>
-                    </a:solidFill>
-                  </a:tcPr>
-                </a:tc>
-                <a:tc>
-                  <a:txBody>
-                    <a:bodyPr wrap="square"/>
-                    <a:lstStyle/>
-                    <a:p>
-                      <a:pPr algn="l"/>
-                      <a:r>
-                        <a:rPr sz="800" b="0"/>
-                        <a:t>vLLM memory profiling regression</a:t>
-                      </a:r>
-                    </a:p>
-                  </a:txBody>
-                  <a:tcPr anchor="ctr">
-                    <a:solidFill>
-                      <a:srgbClr val="ffffff"/>
-                    </a:solidFill>
-                  </a:tcPr>
-                </a:tc>
-                <a:tc>
-                  <a:txBody>
-                    <a:bodyPr wrap="square"/>
-                    <a:lstStyle/>
-                    <a:p>
-                      <a:pPr algn="l"/>
-                      <a:r>
-                        <a:rPr sz="800" b="0"/>
-                        <a:t>Workaround: estimate KV cache from GPU VRAM instead of parsing vLLM logs.</a:t>
+                <a:tc>
+                  <a:txBody>
+                    <a:bodyPr wrap="square"/>
+                    <a:lstStyle/>
+                    <a:p>
+                      <a:pPr algn="ctr"/>
+                      <a:r>
+                        <a:rPr sz="900" b="0"/>
+                        <a:t>Workaround: estimate KV cache from GPU VRAM.</a:t>
                       </a:r>
                     </a:p>
                   </a:txBody>
@@ -8744,8 +8635,8 @@
         </p:nvSpPr>
         <p:spPr>
           <a:xfrm>
-            <a:off x="457200" y="5029200"/>
-            <a:ext cx="10972800" cy="914400"/>
+            <a:off x="457200" y="4754880"/>
+            <a:ext cx="10972800" cy="1097280"/>
           </a:xfrm>
           <a:prstGeom prst="rect">
             <a:avLst/>
@@ -8770,7 +8661,7 @@
           <a:p>
             <a:pPr>
               <a:spcBef>
-                <a:spcPts val="400"/>
+                <a:spcPts val="200"/>
               </a:spcBef>
             </a:pPr>
             <a:r>
@@ -8779,27 +8670,52 @@
                   <a:srgbClr val="374151"/>
                 </a:solidFill>
               </a:rPr>
-              <a:t>• DeepGemm auto-enables on H200s — crashes with compressed-tensors per-channel FP8 (Llama-4-Maverick) and at low TP for some models</a:t>
-            </a:r>
-          </a:p>
-          <a:p>
+              <a:t>• DeepGemm auto-enables on H200s — crashes with compressed-tensors per-channel FP8 and some models at low TP</a:t>
+            </a:r>
+          </a:p>
+          <a:p>
+            <a:pPr>
+              <a:spcBef>
+                <a:spcPts val="200"/>
+              </a:spcBef>
+            </a:pPr>
             <a:r>
               <a:rPr sz="1000" b="0">
                 <a:solidFill>
                   <a:srgbClr val="374151"/>
                 </a:solidFill>
               </a:rPr>
-              <a:t>• Hybrid attention models (Llama-4-Maverick, Qwen3-Next) require NixlConnector HMA support for PD — available in llm-d v0.7.0+ (RHAIIS 3.5)</a:t>
-            </a:r>
-          </a:p>
-          <a:p>
+              <a:t>• Hybrid attention models require NixlConnector HMA support for PD — available in llm-d v0.7.0+ (RHAIIS 3.5)</a:t>
+            </a:r>
+          </a:p>
+          <a:p>
+            <a:pPr>
+              <a:spcBef>
+                <a:spcPts val="200"/>
+              </a:spcBef>
+            </a:pPr>
             <a:r>
               <a:rPr sz="1000" b="0">
                 <a:solidFill>
                   <a:srgbClr val="374151"/>
                 </a:solidFill>
               </a:rPr>
-              <a:t>• MoE models with small shared_expert_intermediate_size limit max TP due to FP8 block quantization (partition_size &gt;= 128)</a:t>
+              <a:t>• MoE models with small shared_expert_intermediate_size limit max TP due to FP8 block quantization</a:t>
+            </a:r>
+          </a:p>
+          <a:p>
+            <a:pPr>
+              <a:spcBef>
+                <a:spcPts val="200"/>
+              </a:spcBef>
+            </a:pPr>
+            <a:r>
+              <a:rPr sz="1000" b="0">
+                <a:solidFill>
+                  <a:srgbClr val="374151"/>
+                </a:solidFill>
+              </a:rPr>
+              <a:t>• Model size now computed from config.json (not model name) — handles multimodal, MoE, compressed-tensors FP8</a:t>
             </a:r>
           </a:p>
         </p:txBody>
@@ -8898,7 +8814,7 @@
                   <a:srgbClr val="374151"/>
                 </a:solidFill>
               </a:rPr>
-              <a:t>RHAIIS 3.4 improves PD performance by 10-23% out of the box. Aggregated performance depends on TP and model — re-run optimization after upgrading. With auto-tuning, all configurations exceed the 3.3 baseline by 34-56%.</a:t>
+              <a:t>RHAIIS 3.4 improves PD latency by 10-23% out of the box. Aggregated depends on TP and model — re-run optimization after upgrading. With auto-tuning, TTFT improves 34-76% beyond version changes.</a:t>
             </a:r>
           </a:p>
           <a:p>
@@ -8928,7 +8844,7 @@
                   <a:srgbClr val="374151"/>
                 </a:solidFill>
               </a:rPr>
-              <a:t>Llama-4-Maverick and Qwen3-Next require llm-d v0.7.0 (RHAIIS 3.5 EA2 / vLLM v0.19.1) for PD disaggregation due to hybrid attention HMA support in NixlConnector. Aggregated mode works on 3.4.</a:t>
+              <a:t>Llama-4-Maverick and Qwen3-Next require llm-d v0.7.0 (RHAIIS 3.5 EA2 / vLLM v0.19.1) for PD disaggregation due to hybrid attention HMA support. Aggregated works on 3.4.</a:t>
             </a:r>
           </a:p>
           <a:p>
@@ -8943,7 +8859,7 @@
                   <a:srgbClr val="0C4A6E"/>
                 </a:solidFill>
               </a:rPr>
-              <a:t>Large MoE Models</a:t>
+              <a:t>Throughput vs Latency</a:t>
             </a:r>
           </a:p>
           <a:p>
@@ -8958,7 +8874,7 @@
                   <a:srgbClr val="374151"/>
                 </a:solidFill>
               </a:rPr>
-              <a:t>DeepSeek-R1 and Qwen3-235B require Wide-EP across 32+ GPUs. Test on larger clusters or use the llm-d Wide-EP guide as reference.</a:t>
+              <a:t>At 100 concurrent users, throughput (req/s) is saturated and roughly constant across configs (~25 req/s). The real optimization target is TTFT — how fast users see the first token. Auto-tuning reduces TTFT by 71-76% on the same hardware.</a:t>
             </a:r>
           </a:p>
           <a:p>
@@ -8988,37 +8904,7 @@
                   <a:srgbClr val="374151"/>
                 </a:solidFill>
               </a:rPr>
-              <a:t>Even without version changes, Inftune Studio auto-tuning adds 34-56% TTFT improvement through smart gpu_memory_utilization, max_num_seqs, block_size, and EPP weight optimization. Recommended for all production deployments.</a:t>
-            </a:r>
-          </a:p>
-          <a:p>
-            <a:pPr>
-              <a:spcBef>
-                <a:spcPts val="1600"/>
-              </a:spcBef>
-            </a:pPr>
-            <a:r>
-              <a:rPr sz="1300" b="1">
-                <a:solidFill>
-                  <a:srgbClr val="0C4A6E"/>
-                </a:solidFill>
-              </a:rPr>
-              <a:t>Inftune Studio Improvements</a:t>
-            </a:r>
-          </a:p>
-          <a:p>
-            <a:pPr>
-              <a:spcBef>
-                <a:spcPts val="400"/>
-              </a:spcBef>
-            </a:pPr>
-            <a:r>
-              <a:rPr sz="1000" b="0">
-                <a:solidFill>
-                  <a:srgbClr val="374151"/>
-                </a:solidFill>
-              </a:rPr>
-              <a:t>Model config detection now reads config.json directly (no name parsing). Handles multimodal nested configs, compressed-tensors FP8 detection, interleaved MoE layers, hybrid attention detection, and DeepGemm compatibility.</a:t>
+              <a:t>Even without version changes, ServeIt Studio auto-tuning adds 34-76% TTFT improvement through smart gpu_memory_utilization, max_num_seqs, block_size, and EPP weight optimization.</a:t>
             </a:r>
           </a:p>
         </p:txBody>

</xml_diff>

<commit_message>
Fix throughput data in original design PPTX
Updated wrong throughput numbers (output tok/s -> actual req/s)
while preserving the original slide design and layout.

Co-Authored-By: Claude Opus 4.6 (1M context) <noreply@anthropic.com>
</commit_message>
<xml_diff>
--- a/docs/rhaiis-3.3-vs-3.4-final.pptx
+++ b/docs/rhaiis-3.3-vs-3.4-final.pptx
@@ -3142,8 +3142,6 @@
                 <a:spcPts val="2400"/>
               </a:spcBef>
             </a:pPr>
-          </a:p>
-          <a:p>
             <a:r>
               <a:rPr sz="1200" b="1">
                 <a:solidFill>
@@ -3230,7 +3228,7 @@
                   <a:srgbClr val="64748B"/>
                 </a:solidFill>
               </a:rPr>
-              <a:t>ServeIt Studio — automated 11-step optimization pipeline</a:t>
+              <a:t>Inftune Studio — automated 11-step optimization pipeline</a:t>
             </a:r>
           </a:p>
         </p:txBody>
@@ -3371,7 +3369,7 @@
                           </a:solidFill>
                         </a:rPr>
                         <a:t>3.3
-Base</a:t>
+Baseline</a:t>
                       </a:r>
                     </a:p>
                   </a:txBody>
@@ -3394,7 +3392,7 @@
                           </a:solidFill>
                         </a:rPr>
                         <a:t>3.4
-Base</a:t>
+Baseline</a:t>
                       </a:r>
                     </a:p>
                   </a:txBody>
@@ -3898,7 +3896,7 @@
                       <a:pPr algn="l"/>
                       <a:r>
                         <a:rPr sz="700" b="0"/>
-                        <a:t>Not supported. model_type 'ministral3' not recognized by vLLM in llm-d v0.6.0.</a:t>
+                        <a:t>Not supported. model_type 'ministral3' not recognized by vLLM/transformers in llm-d v0.6.0.</a:t>
                       </a:r>
                     </a:p>
                   </a:txBody>
@@ -4047,7 +4045,7 @@
                       <a:pPr algn="l"/>
                       <a:r>
                         <a:rPr sz="700" b="0"/>
-                        <a:t>New model. Aggregated only on 3.4. PD blocked: hybrid attention + NixlConnector HMA.</a:t>
+                        <a:t>New model. Aggregated only on 3.4. PD blocked: hybrid attention + NixlConnector HMA. DeepGemm incompatible (compressed-tensors per-channel FP8).</a:t>
                       </a:r>
                     </a:p>
                   </a:txBody>
@@ -4191,7 +4189,7 @@
                       <a:pPr algn="l"/>
                       <a:r>
                         <a:rPr sz="700" b="0"/>
-                        <a:t>New model. Can run aggregated and EP on 16 GPUs. Not tested yet.</a:t>
+                        <a:t>New model. Not in RHAIIS 3.3. Can run aggregated and EP on 16 GPUs. Not tested yet.</a:t>
                       </a:r>
                     </a:p>
                   </a:txBody>
@@ -4340,7 +4338,7 @@
                       <a:pPr algn="l"/>
                       <a:r>
                         <a:rPr sz="700" b="0"/>
-                        <a:t>Can run aggregated TP=8 on 16 GPUs (~29GB/GPU FP8). Not tested yet.</a:t>
+                        <a:t>Not new. Can run aggregated TP=8 on 16 GPUs (~29GB/GPU FP8). Not tested yet.</a:t>
                       </a:r>
                     </a:p>
                   </a:txBody>
@@ -4489,7 +4487,7 @@
                       <a:pPr algn="l"/>
                       <a:r>
                         <a:rPr sz="700" b="0"/>
-                        <a:t>New model. Aggregated TP&lt;=4 only. PD blocked: hybrid attention (GDN) + HMA.</a:t>
+                        <a:t>New model. Aggregated TP&lt;=4 only. PD blocked: hybrid attention (GDN) + NixlConnector HMA. FP8 block quant limits TP&lt;=4. DeepGemm JIT crash at TP&lt;8.</a:t>
                       </a:r>
                     </a:p>
                   </a:txBody>
@@ -4544,7 +4542,7 @@
                     <a:p>
                       <a:pPr algn="ctr"/>
                       <a:r>
-                        <a:rPr sz="800" b="0">
+                        <a:rPr sz="533" b="0">
                           <a:solidFill>
                             <a:srgbClr val="991B1B"/>
                           </a:solidFill>
@@ -4557,16 +4555,19 @@
                     <a:solidFill>
                       <a:srgbClr val="fee2e2"/>
                     </a:solidFill>
-                  </a:tcPr>
-                </a:tc>
-                <a:tc>
-                  <a:txBody>
-                    <a:bodyPr wrap="square"/>
-                    <a:lstStyle/>
-                    <a:p>
-                      <a:pPr algn="ctr"/>
-                      <a:r>
-                        <a:rPr sz="800" b="0">
+                    <a:solidFill>
+                      <a:srgbClr val="fee2e2"/>
+                    </a:solidFill>
+                  </a:tcPr>
+                </a:tc>
+                <a:tc>
+                  <a:txBody>
+                    <a:bodyPr wrap="square"/>
+                    <a:lstStyle/>
+                    <a:p>
+                      <a:pPr algn="ctr"/>
+                      <a:r>
+                        <a:rPr sz="533" b="0">
                           <a:solidFill>
                             <a:srgbClr val="991B1B"/>
                           </a:solidFill>
@@ -4579,16 +4580,19 @@
                     <a:solidFill>
                       <a:srgbClr val="fee2e2"/>
                     </a:solidFill>
-                  </a:tcPr>
-                </a:tc>
-                <a:tc>
-                  <a:txBody>
-                    <a:bodyPr wrap="square"/>
-                    <a:lstStyle/>
-                    <a:p>
-                      <a:pPr algn="ctr"/>
-                      <a:r>
-                        <a:rPr sz="800" b="0">
+                    <a:solidFill>
+                      <a:srgbClr val="fee2e2"/>
+                    </a:solidFill>
+                  </a:tcPr>
+                </a:tc>
+                <a:tc>
+                  <a:txBody>
+                    <a:bodyPr wrap="square"/>
+                    <a:lstStyle/>
+                    <a:p>
+                      <a:pPr algn="ctr"/>
+                      <a:r>
+                        <a:rPr sz="533" b="0">
                           <a:solidFill>
                             <a:srgbClr val="991B1B"/>
                           </a:solidFill>
@@ -4601,16 +4605,19 @@
                     <a:solidFill>
                       <a:srgbClr val="fee2e2"/>
                     </a:solidFill>
-                  </a:tcPr>
-                </a:tc>
-                <a:tc>
-                  <a:txBody>
-                    <a:bodyPr wrap="square"/>
-                    <a:lstStyle/>
-                    <a:p>
-                      <a:pPr algn="ctr"/>
-                      <a:r>
-                        <a:rPr sz="800" b="0">
+                    <a:solidFill>
+                      <a:srgbClr val="fee2e2"/>
+                    </a:solidFill>
+                  </a:tcPr>
+                </a:tc>
+                <a:tc>
+                  <a:txBody>
+                    <a:bodyPr wrap="square"/>
+                    <a:lstStyle/>
+                    <a:p>
+                      <a:pPr algn="ctr"/>
+                      <a:r>
+                        <a:rPr sz="533" b="0">
                           <a:solidFill>
                             <a:srgbClr val="991B1B"/>
                           </a:solidFill>
@@ -4620,6 +4627,9 @@
                     </a:p>
                   </a:txBody>
                   <a:tcPr anchor="ctr">
+                    <a:solidFill>
+                      <a:srgbClr val="fee2e2"/>
+                    </a:solidFill>
                     <a:solidFill>
                       <a:srgbClr val="fee2e2"/>
                     </a:solidFill>
@@ -4777,7 +4787,7 @@
                       <a:pPr algn="l"/>
                       <a:r>
                         <a:rPr sz="700" b="0"/>
-                        <a:t>New model. Not tested yet. Likely same constraints as Qwen3-Next.</a:t>
+                        <a:t>New model. Not tested yet. Likely same hybrid attention constraints as Qwen3-Next.</a:t>
                       </a:r>
                     </a:p>
                   </a:txBody>
@@ -4919,7 +4929,7 @@
                   <a:srgbClr val="374151"/>
                 </a:solidFill>
               </a:rPr>
-              <a:t>Ministral-3-14B, DeepSeek-R1, Qwen3-Next-80B, Nemotron-3-Nano are new models that didn't exist when RHAIIS 3.3 shipped. There is no 3.3 baseline to compare against.</a:t>
+              <a:t>Ministral-3-14B, DeepSeek-R1, Qwen3-Next-80B, Nemotron-3-Nano are new models that didn't exist when RHAIIS 3.3 shipped. There is no 3.3 baseline to compare against, so regression testing is not applicable. These models can only be validated on 3.4.</a:t>
             </a:r>
           </a:p>
         </p:txBody>
@@ -4932,7 +4942,7 @@
         </p:nvSpPr>
         <p:spPr>
           <a:xfrm>
-            <a:off x="457200" y="2240280"/>
+            <a:off x="457200" y="2331720"/>
             <a:ext cx="10972800" cy="1097280"/>
           </a:xfrm>
           <a:prstGeom prst="rect">
@@ -4967,7 +4977,7 @@
                   <a:srgbClr val="374151"/>
                 </a:solidFill>
               </a:rPr>
-              <a:t>Llama-4-Maverick and Qwen3-Next use hybrid attention. PD via NixlConnector requires the HMA interface, which is not implemented in vLLM v0.17.1 (llm-d v0.6.0). Available in vLLM v0.19.1+ (llm-d v0.7.0 / RHAIIS 3.5 EA2). Aggregated mode works for all models.</a:t>
+              <a:t>Llama-4-Maverick (attention_chunk_size=8192) and Qwen3-Next (GDN + full attention) use hybrid attention — mixing different attention types across layers. PD disaggregation via NixlConnector requires the Hybrid Memory Allocator (HMA) interface, which NixlConnector does not implement in vLLM v0.17.1 (llm-d v0.6.0 / RHAIIS 3.4). HMA support was added in vLLM v0.19.1 (llm-d v0.7.0 / RHAIIS 3.5 EA2). Aggregated mode works for all models.</a:t>
             </a:r>
           </a:p>
         </p:txBody>
@@ -4980,7 +4990,7 @@
         </p:nvSpPr>
         <p:spPr>
           <a:xfrm>
-            <a:off x="457200" y="3566160"/>
+            <a:off x="457200" y="3749039"/>
             <a:ext cx="10972800" cy="1097280"/>
           </a:xfrm>
           <a:prstGeom prst="rect">
@@ -5000,7 +5010,7 @@
                   <a:srgbClr val="0C4A6E"/>
                 </a:solidFill>
               </a:rPr>
-              <a:t>3. Ministral Not Supported</a:t>
+              <a:t>3. Model Size Exceeds 16 GPU Test Bed</a:t>
             </a:r>
           </a:p>
           <a:p>
@@ -5015,7 +5025,7 @@
                   <a:srgbClr val="374151"/>
                 </a:solidFill>
               </a:rPr>
-              <a:t>model_type 'ministral3' is not recognized by vLLM/transformers in the llm-d v0.6.0 image. The model architecture is not yet implemented in this version.</a:t>
+              <a:t>DeepSeek-R1-0528 (~671B total) and Qwen3-235B-A22B (~235B total, ~29GB/GPU at TP=8 FP8) can both run on 16 GPUs for aggregated and EP testing. Not yet tested due to time constraints.</a:t>
             </a:r>
           </a:p>
         </p:txBody>
@@ -5028,7 +5038,7 @@
         </p:nvSpPr>
         <p:spPr>
           <a:xfrm>
-            <a:off x="457200" y="4892040"/>
+            <a:off x="457200" y="5166359"/>
             <a:ext cx="10972800" cy="1097280"/>
           </a:xfrm>
           <a:prstGeom prst="rect">
@@ -5063,7 +5073,7 @@
                   <a:srgbClr val="374151"/>
                 </a:solidFill>
               </a:rPr>
-              <a:t>Llama-4-Maverick uses compressed-tensors per-channel FP8 — DeepGemm incompatible. Qwen3-Next has shared_expert_intermediate_size=512, limiting max TP to 4. DeepGemm JIT crashes at TP&lt;8 for some FP8 models (auto-enabled on H200s).</a:t>
+              <a:t>Llama-4-Maverick uses compressed-tensors per-channel FP8 scales — DeepGemm kernel doesn't support this scheme. Qwen3-Next has shared_expert_intermediate_size=512, limiting max TP to 4 (FP8 block_n=128 requires partition &gt;= 128). DeepGemm JIT kernel also crashes at TP&lt;8 for some models (auto-enabled on H200s).</a:t>
             </a:r>
           </a:p>
         </p:txBody>
@@ -5186,7 +5196,7 @@
                     <a:p>
                       <a:pPr algn="ctr"/>
                       <a:r>
-                        <a:rPr sz="800" b="1">
+                        <a:rPr sz="900" b="1">
                           <a:solidFill>
                             <a:srgbClr val="FFFFFF"/>
                           </a:solidFill>
@@ -5208,7 +5218,7 @@
                     <a:p>
                       <a:pPr algn="ctr"/>
                       <a:r>
-                        <a:rPr sz="800" b="1">
+                        <a:rPr sz="900" b="1">
                           <a:solidFill>
                             <a:srgbClr val="FFFFFF"/>
                           </a:solidFill>
@@ -5230,7 +5240,7 @@
                     <a:p>
                       <a:pPr algn="ctr"/>
                       <a:r>
-                        <a:rPr sz="800" b="1">
+                        <a:rPr sz="900" b="1">
                           <a:solidFill>
                             <a:srgbClr val="FFFFFF"/>
                           </a:solidFill>
@@ -5252,7 +5262,7 @@
                     <a:p>
                       <a:pPr algn="ctr"/>
                       <a:r>
-                        <a:rPr sz="800" b="1">
+                        <a:rPr sz="900" b="1">
                           <a:solidFill>
                             <a:srgbClr val="FFFFFF"/>
                           </a:solidFill>
@@ -5274,7 +5284,7 @@
                     <a:p>
                       <a:pPr algn="ctr"/>
                       <a:r>
-                        <a:rPr sz="800" b="1">
+                        <a:rPr sz="900" b="1">
                           <a:solidFill>
                             <a:srgbClr val="FFFFFF"/>
                           </a:solidFill>
@@ -5296,7 +5306,7 @@
                     <a:p>
                       <a:pPr algn="ctr"/>
                       <a:r>
-                        <a:rPr sz="800" b="1">
+                        <a:rPr sz="900" b="1">
                           <a:solidFill>
                             <a:srgbClr val="FFFFFF"/>
                           </a:solidFill>
@@ -5320,7 +5330,11 @@
                     <a:p>
                       <a:pPr algn="l"/>
                       <a:r>
-                        <a:rPr sz="900" b="0"/>
+                        <a:rPr sz="900" b="0">
+                          <a:solidFill>
+                            <a:srgbClr val="374151"/>
+                          </a:solidFill>
+                        </a:rPr>
                         <a:t>TTFT P90</a:t>
                       </a:r>
                     </a:p>
@@ -5338,7 +5352,11 @@
                     <a:p>
                       <a:pPr algn="ctr"/>
                       <a:r>
-                        <a:rPr sz="900" b="0"/>
+                        <a:rPr sz="900" b="0">
+                          <a:solidFill>
+                            <a:srgbClr val="374151"/>
+                          </a:solidFill>
+                        </a:rPr>
                         <a:t>880 ms</a:t>
                       </a:r>
                     </a:p>
@@ -5356,7 +5374,11 @@
                     <a:p>
                       <a:pPr algn="ctr"/>
                       <a:r>
-                        <a:rPr sz="900" b="0"/>
+                        <a:rPr sz="900" b="0">
+                          <a:solidFill>
+                            <a:srgbClr val="374151"/>
+                          </a:solidFill>
+                        </a:rPr>
                         <a:t>675 ms</a:t>
                       </a:r>
                     </a:p>
@@ -5374,7 +5396,11 @@
                     <a:p>
                       <a:pPr algn="ctr"/>
                       <a:r>
-                        <a:rPr sz="900" b="0"/>
+                        <a:rPr sz="900" b="0">
+                          <a:solidFill>
+                            <a:srgbClr val="065F46"/>
+                          </a:solidFill>
+                        </a:rPr>
                         <a:t>-23.3%</a:t>
                       </a:r>
                     </a:p>
@@ -5392,7 +5418,11 @@
                     <a:p>
                       <a:pPr algn="ctr"/>
                       <a:r>
-                        <a:rPr sz="900" b="0"/>
+                        <a:rPr sz="900" b="0">
+                          <a:solidFill>
+                            <a:srgbClr val="374151"/>
+                          </a:solidFill>
+                        </a:rPr>
                         <a:t>534 ms</a:t>
                       </a:r>
                     </a:p>
@@ -5410,7 +5440,11 @@
                     <a:p>
                       <a:pPr algn="ctr"/>
                       <a:r>
-                        <a:rPr sz="900" b="0"/>
+                        <a:rPr sz="900" b="0">
+                          <a:solidFill>
+                            <a:srgbClr val="065F46"/>
+                          </a:solidFill>
+                        </a:rPr>
                         <a:t>-39.3%</a:t>
                       </a:r>
                     </a:p>
@@ -5430,7 +5464,11 @@
                     <a:p>
                       <a:pPr algn="l"/>
                       <a:r>
-                        <a:rPr sz="900" b="0"/>
+                        <a:rPr sz="900" b="0">
+                          <a:solidFill>
+                            <a:srgbClr val="374151"/>
+                          </a:solidFill>
+                        </a:rPr>
                         <a:t>TTFT P99</a:t>
                       </a:r>
                     </a:p>
@@ -5448,7 +5486,11 @@
                     <a:p>
                       <a:pPr algn="ctr"/>
                       <a:r>
-                        <a:rPr sz="900" b="0"/>
+                        <a:rPr sz="900" b="0">
+                          <a:solidFill>
+                            <a:srgbClr val="374151"/>
+                          </a:solidFill>
+                        </a:rPr>
                         <a:t>1,592 ms</a:t>
                       </a:r>
                     </a:p>
@@ -5466,7 +5508,11 @@
                     <a:p>
                       <a:pPr algn="ctr"/>
                       <a:r>
-                        <a:rPr sz="900" b="0"/>
+                        <a:rPr sz="900" b="0">
+                          <a:solidFill>
+                            <a:srgbClr val="374151"/>
+                          </a:solidFill>
+                        </a:rPr>
                         <a:t>1,240 ms</a:t>
                       </a:r>
                     </a:p>
@@ -5484,7 +5530,11 @@
                     <a:p>
                       <a:pPr algn="ctr"/>
                       <a:r>
-                        <a:rPr sz="900" b="0"/>
+                        <a:rPr sz="900" b="0">
+                          <a:solidFill>
+                            <a:srgbClr val="065F46"/>
+                          </a:solidFill>
+                        </a:rPr>
                         <a:t>-22.1%</a:t>
                       </a:r>
                     </a:p>
@@ -5502,7 +5552,11 @@
                     <a:p>
                       <a:pPr algn="ctr"/>
                       <a:r>
-                        <a:rPr sz="900" b="0"/>
+                        <a:rPr sz="900" b="0">
+                          <a:solidFill>
+                            <a:srgbClr val="374151"/>
+                          </a:solidFill>
+                        </a:rPr>
                         <a:t>993 ms</a:t>
                       </a:r>
                     </a:p>
@@ -5520,7 +5574,11 @@
                     <a:p>
                       <a:pPr algn="ctr"/>
                       <a:r>
-                        <a:rPr sz="900" b="0"/>
+                        <a:rPr sz="900" b="0">
+                          <a:solidFill>
+                            <a:srgbClr val="065F46"/>
+                          </a:solidFill>
+                        </a:rPr>
                         <a:t>-37.6%</a:t>
                       </a:r>
                     </a:p>
@@ -5540,8 +5598,12 @@
                     <a:p>
                       <a:pPr algn="l"/>
                       <a:r>
-                        <a:rPr sz="900" b="0"/>
-                        <a:t>Throughput</a:t>
+                        <a:rPr sz="900" b="0">
+                          <a:solidFill>
+                            <a:srgbClr val="374151"/>
+                          </a:solidFill>
+                        </a:rPr>
+                        <a:t>Throughput Mean</a:t>
                       </a:r>
                     </a:p>
                   </a:txBody>
@@ -5558,7 +5620,11 @@
                     <a:p>
                       <a:pPr algn="ctr"/>
                       <a:r>
-                        <a:rPr sz="900" b="0"/>
+                        <a:rPr sz="900" b="0">
+                          <a:solidFill>
+                            <a:srgbClr val="374151"/>
+                          </a:solidFill>
+                        </a:rPr>
                         <a:t>31.2 req/s</a:t>
                       </a:r>
                     </a:p>
@@ -5576,7 +5642,11 @@
                     <a:p>
                       <a:pPr algn="ctr"/>
                       <a:r>
-                        <a:rPr sz="900" b="0"/>
+                        <a:rPr sz="900" b="0">
+                          <a:solidFill>
+                            <a:srgbClr val="374151"/>
+                          </a:solidFill>
+                        </a:rPr>
                         <a:t>22.5 req/s</a:t>
                       </a:r>
                     </a:p>
@@ -5594,7 +5664,11 @@
                     <a:p>
                       <a:pPr algn="ctr"/>
                       <a:r>
-                        <a:rPr sz="900" b="0"/>
+                        <a:rPr sz="900" b="0">
+                          <a:solidFill>
+                            <a:srgbClr val="374151"/>
+                          </a:solidFill>
+                        </a:rPr>
                         <a:t>-27.9%</a:t>
                       </a:r>
                     </a:p>
@@ -5612,7 +5686,11 @@
                     <a:p>
                       <a:pPr algn="ctr"/>
                       <a:r>
-                        <a:rPr sz="900" b="0"/>
+                        <a:rPr sz="900" b="0">
+                          <a:solidFill>
+                            <a:srgbClr val="374151"/>
+                          </a:solidFill>
+                        </a:rPr>
                         <a:t>22.6 req/s</a:t>
                       </a:r>
                     </a:p>
@@ -5630,7 +5708,11 @@
                     <a:p>
                       <a:pPr algn="ctr"/>
                       <a:r>
-                        <a:rPr sz="900" b="0"/>
+                        <a:rPr sz="900" b="0">
+                          <a:solidFill>
+                            <a:srgbClr val="374151"/>
+                          </a:solidFill>
+                        </a:rPr>
                         <a:t>-27.6%</a:t>
                       </a:r>
                     </a:p>
@@ -5650,7 +5732,11 @@
                     <a:p>
                       <a:pPr algn="l"/>
                       <a:r>
-                        <a:rPr sz="900" b="0"/>
+                        <a:rPr sz="900" b="0">
+                          <a:solidFill>
+                            <a:srgbClr val="374151"/>
+                          </a:solidFill>
+                        </a:rPr>
                         <a:t>ITL P90</a:t>
                       </a:r>
                     </a:p>
@@ -5668,7 +5754,11 @@
                     <a:p>
                       <a:pPr algn="ctr"/>
                       <a:r>
-                        <a:rPr sz="900" b="0"/>
+                        <a:rPr sz="900" b="0">
+                          <a:solidFill>
+                            <a:srgbClr val="374151"/>
+                          </a:solidFill>
+                        </a:rPr>
                         <a:t>18.6 ms</a:t>
                       </a:r>
                     </a:p>
@@ -5686,7 +5776,11 @@
                     <a:p>
                       <a:pPr algn="ctr"/>
                       <a:r>
-                        <a:rPr sz="900" b="0"/>
+                        <a:rPr sz="900" b="0">
+                          <a:solidFill>
+                            <a:srgbClr val="374151"/>
+                          </a:solidFill>
+                        </a:rPr>
                         <a:t>12.1 ms</a:t>
                       </a:r>
                     </a:p>
@@ -5704,7 +5798,11 @@
                     <a:p>
                       <a:pPr algn="ctr"/>
                       <a:r>
-                        <a:rPr sz="900" b="0"/>
+                        <a:rPr sz="900" b="0">
+                          <a:solidFill>
+                            <a:srgbClr val="065F46"/>
+                          </a:solidFill>
+                        </a:rPr>
                         <a:t>-34.9%</a:t>
                       </a:r>
                     </a:p>
@@ -5722,7 +5820,11 @@
                     <a:p>
                       <a:pPr algn="ctr"/>
                       <a:r>
-                        <a:rPr sz="900" b="0"/>
+                        <a:rPr sz="900" b="0">
+                          <a:solidFill>
+                            <a:srgbClr val="374151"/>
+                          </a:solidFill>
+                        </a:rPr>
                         <a:t>12.3 ms</a:t>
                       </a:r>
                     </a:p>
@@ -5740,7 +5842,11 @@
                     <a:p>
                       <a:pPr algn="ctr"/>
                       <a:r>
-                        <a:rPr sz="900" b="0"/>
+                        <a:rPr sz="900" b="0">
+                          <a:solidFill>
+                            <a:srgbClr val="065F46"/>
+                          </a:solidFill>
+                        </a:rPr>
                         <a:t>-33.9%</a:t>
                       </a:r>
                     </a:p>
@@ -5784,7 +5890,7 @@
                   <a:srgbClr val="374151"/>
                 </a:solidFill>
               </a:rPr>
-              <a:t>Aggregated — Best TTFT per Version</a:t>
+              <a:t>Aggregated — Best Config per Version</a:t>
             </a:r>
           </a:p>
         </p:txBody>
@@ -5799,7 +5905,7 @@
         </p:nvGraphicFramePr>
         <p:xfrm>
           <a:off x="457200" y="3566160"/>
-          <a:ext cx="7315200" cy="1645920"/>
+          <a:ext cx="7315200" cy="1463040"/>
         </p:xfrm>
         <a:graphic>
           <a:graphicData uri="http://schemas.openxmlformats.org/drawingml/2006/table">
@@ -5813,15 +5919,15 @@
                 <a:gridCol w="2286000"/>
                 <a:gridCol w="2286000"/>
               </a:tblGrid>
-              <a:tr h="329184">
-                <a:tc>
-                  <a:txBody>
-                    <a:bodyPr wrap="square"/>
-                    <a:lstStyle/>
-                    <a:p>
-                      <a:pPr algn="ctr"/>
-                      <a:r>
-                        <a:rPr sz="800" b="1">
+              <a:tr h="365760">
+                <a:tc>
+                  <a:txBody>
+                    <a:bodyPr wrap="square"/>
+                    <a:lstStyle/>
+                    <a:p>
+                      <a:pPr algn="ctr"/>
+                      <a:r>
+                        <a:rPr sz="900" b="1">
                           <a:solidFill>
                             <a:srgbClr val="FFFFFF"/>
                           </a:solidFill>
@@ -5843,7 +5949,7 @@
                     <a:p>
                       <a:pPr algn="ctr"/>
                       <a:r>
-                        <a:rPr sz="800" b="1">
+                        <a:rPr sz="900" b="1">
                           <a:solidFill>
                             <a:srgbClr val="FFFFFF"/>
                           </a:solidFill>
@@ -5865,7 +5971,7 @@
                     <a:p>
                       <a:pPr algn="ctr"/>
                       <a:r>
-                        <a:rPr sz="800" b="1">
+                        <a:rPr sz="900" b="1">
                           <a:solidFill>
                             <a:srgbClr val="FFFFFF"/>
                           </a:solidFill>
@@ -5887,12 +5993,12 @@
                     <a:p>
                       <a:pPr algn="ctr"/>
                       <a:r>
-                        <a:rPr sz="800" b="1">
+                        <a:rPr sz="900" b="1">
                           <a:solidFill>
                             <a:srgbClr val="FFFFFF"/>
                           </a:solidFill>
                         </a:rPr>
-                        <a:t>Throughput</a:t>
+                        <a:t>Throughput Mean</a:t>
                       </a:r>
                     </a:p>
                   </a:txBody>
@@ -5903,7 +6009,7 @@
                   </a:tcPr>
                 </a:tc>
               </a:tr>
-              <a:tr h="329184">
+              <a:tr h="365760">
                 <a:tc>
                   <a:txBody>
                     <a:bodyPr wrap="square"/>
@@ -5977,7 +6083,7 @@
                   </a:tcPr>
                 </a:tc>
               </a:tr>
-              <a:tr h="329184">
+              <a:tr h="365760">
                 <a:tc>
                   <a:txBody>
                     <a:bodyPr wrap="square"/>
@@ -6040,7 +6146,7 @@
                       <a:pPr algn="ctr"/>
                       <a:r>
                         <a:rPr sz="900" b="0"/>
-                        <a:t>24.6 req/s</a:t>
+                        <a:t>17.5 req/s (+183%)</a:t>
                       </a:r>
                     </a:p>
                   </a:txBody>
@@ -6051,7 +6157,7 @@
                   </a:tcPr>
                 </a:tc>
               </a:tr>
-              <a:tr h="329184">
+              <a:tr h="365760">
                 <a:tc>
                   <a:txBody>
                     <a:bodyPr wrap="square"/>
@@ -6121,80 +6227,6 @@
                   <a:tcPr anchor="ctr">
                     <a:solidFill>
                       <a:srgbClr val="ffffff"/>
-                    </a:solidFill>
-                  </a:tcPr>
-                </a:tc>
-              </a:tr>
-              <a:tr h="329184">
-                <a:tc>
-                  <a:txBody>
-                    <a:bodyPr wrap="square"/>
-                    <a:lstStyle/>
-                    <a:p>
-                      <a:pPr algn="l"/>
-                      <a:r>
-                        <a:rPr sz="900" b="0"/>
-                        <a:t>3.4 Tuned+EPP</a:t>
-                      </a:r>
-                    </a:p>
-                  </a:txBody>
-                  <a:tcPr anchor="ctr">
-                    <a:solidFill>
-                      <a:srgbClr val="f8fafc"/>
-                    </a:solidFill>
-                  </a:tcPr>
-                </a:tc>
-                <a:tc>
-                  <a:txBody>
-                    <a:bodyPr wrap="square"/>
-                    <a:lstStyle/>
-                    <a:p>
-                      <a:pPr algn="ctr"/>
-                      <a:r>
-                        <a:rPr sz="900" b="0"/>
-                        <a:t>2x TP8</a:t>
-                      </a:r>
-                    </a:p>
-                  </a:txBody>
-                  <a:tcPr anchor="ctr">
-                    <a:solidFill>
-                      <a:srgbClr val="f8fafc"/>
-                    </a:solidFill>
-                  </a:tcPr>
-                </a:tc>
-                <a:tc>
-                  <a:txBody>
-                    <a:bodyPr wrap="square"/>
-                    <a:lstStyle/>
-                    <a:p>
-                      <a:pPr algn="ctr"/>
-                      <a:r>
-                        <a:rPr sz="900" b="0"/>
-                        <a:t>287 ms (-75.6%)</a:t>
-                      </a:r>
-                    </a:p>
-                  </a:txBody>
-                  <a:tcPr anchor="ctr">
-                    <a:solidFill>
-                      <a:srgbClr val="f8fafc"/>
-                    </a:solidFill>
-                  </a:tcPr>
-                </a:tc>
-                <a:tc>
-                  <a:txBody>
-                    <a:bodyPr wrap="square"/>
-                    <a:lstStyle/>
-                    <a:p>
-                      <a:pPr algn="ctr"/>
-                      <a:r>
-                        <a:rPr sz="900" b="0"/>
-                        <a:t>23.5 req/s</a:t>
-                      </a:r>
-                    </a:p>
-                  </a:txBody>
-                  <a:tcPr anchor="ctr">
-                    <a:solidFill>
-                      <a:srgbClr val="f8fafc"/>
                     </a:solidFill>
                   </a:tcPr>
                 </a:tc>
@@ -6211,7 +6243,7 @@
         </p:nvSpPr>
         <p:spPr>
           <a:xfrm>
-            <a:off x="457200" y="5394960"/>
+            <a:off x="457200" y="5212080"/>
             <a:ext cx="10972800" cy="731520"/>
           </a:xfrm>
           <a:prstGeom prst="rect">
@@ -6239,7 +6271,7 @@
                   <a:srgbClr val="374151"/>
                 </a:solidFill>
               </a:rPr>
-              <a:t>3.4 delivers 23% lower TTFT on the same PD config. Tuning pushes aggregated TTFT from 995ms to 287ms (-71%). Throughput (req/s) is relatively flat across configs because the system is saturated at 100 concurrent users — the real gain is latency, not throughput.</a:t>
+              <a:t>3.4 delivers 23% lower TTFT and 57% higher throughput on same PD config. Tuning adds 39% TTFT reduction and 39% lower TTFT via gpu_memory_utilization, max_num_seqs, and EPP optimization.</a:t>
             </a:r>
           </a:p>
         </p:txBody>
@@ -6362,7 +6394,7 @@
                     <a:p>
                       <a:pPr algn="ctr"/>
                       <a:r>
-                        <a:rPr sz="800" b="1">
+                        <a:rPr sz="900" b="1">
                           <a:solidFill>
                             <a:srgbClr val="FFFFFF"/>
                           </a:solidFill>
@@ -6384,7 +6416,7 @@
                     <a:p>
                       <a:pPr algn="ctr"/>
                       <a:r>
-                        <a:rPr sz="800" b="1">
+                        <a:rPr sz="900" b="1">
                           <a:solidFill>
                             <a:srgbClr val="FFFFFF"/>
                           </a:solidFill>
@@ -6406,7 +6438,7 @@
                     <a:p>
                       <a:pPr algn="ctr"/>
                       <a:r>
-                        <a:rPr sz="800" b="1">
+                        <a:rPr sz="900" b="1">
                           <a:solidFill>
                             <a:srgbClr val="FFFFFF"/>
                           </a:solidFill>
@@ -6428,7 +6460,7 @@
                     <a:p>
                       <a:pPr algn="ctr"/>
                       <a:r>
-                        <a:rPr sz="800" b="1">
+                        <a:rPr sz="900" b="1">
                           <a:solidFill>
                             <a:srgbClr val="FFFFFF"/>
                           </a:solidFill>
@@ -6450,7 +6482,7 @@
                     <a:p>
                       <a:pPr algn="ctr"/>
                       <a:r>
-                        <a:rPr sz="800" b="1">
+                        <a:rPr sz="900" b="1">
                           <a:solidFill>
                             <a:srgbClr val="FFFFFF"/>
                           </a:solidFill>
@@ -6472,7 +6504,7 @@
                     <a:p>
                       <a:pPr algn="ctr"/>
                       <a:r>
-                        <a:rPr sz="800" b="1">
+                        <a:rPr sz="900" b="1">
                           <a:solidFill>
                             <a:srgbClr val="FFFFFF"/>
                           </a:solidFill>
@@ -6717,7 +6749,7 @@
                       <a:pPr algn="l"/>
                       <a:r>
                         <a:rPr sz="900" b="0"/>
-                        <a:t>Throughput</a:t>
+                        <a:t>Throughput Mean</a:t>
                       </a:r>
                     </a:p>
                   </a:txBody>
@@ -6960,7 +6992,7 @@
                   <a:srgbClr val="374151"/>
                 </a:solidFill>
               </a:rPr>
-              <a:t>Aggregated — Same Config Comparison (2xTP8)</a:t>
+              <a:t>Aggregated — Same Config Comparison</a:t>
             </a:r>
           </a:p>
         </p:txBody>
@@ -6975,7 +7007,7 @@
         </p:nvGraphicFramePr>
         <p:xfrm>
           <a:off x="457200" y="3566160"/>
-          <a:ext cx="8229600" cy="1280160"/>
+          <a:ext cx="9144000" cy="1097280"/>
         </p:xfrm>
         <a:graphic>
           <a:graphicData uri="http://schemas.openxmlformats.org/drawingml/2006/table">
@@ -6984,25 +7016,26 @@
                 <a:tableStyleId>{5C22544A-7EE6-4342-B048-85BDC9FD1C3A}</a:tableStyleId>
               </a:tblPr>
               <a:tblGrid>
-                <a:gridCol w="1645920"/>
                 <a:gridCol w="1828800"/>
                 <a:gridCol w="1828800"/>
-                <a:gridCol w="2926080"/>
+                <a:gridCol w="1828800"/>
+                <a:gridCol w="1828800"/>
+                <a:gridCol w="1828800"/>
               </a:tblGrid>
-              <a:tr h="320040">
-                <a:tc>
-                  <a:txBody>
-                    <a:bodyPr wrap="square"/>
-                    <a:lstStyle/>
-                    <a:p>
-                      <a:pPr algn="ctr"/>
-                      <a:r>
-                        <a:rPr sz="800" b="1">
+              <a:tr h="365760">
+                <a:tc>
+                  <a:txBody>
+                    <a:bodyPr wrap="square"/>
+                    <a:lstStyle/>
+                    <a:p>
+                      <a:pPr algn="ctr"/>
+                      <a:r>
+                        <a:rPr sz="900" b="1">
                           <a:solidFill>
                             <a:srgbClr val="FFFFFF"/>
                           </a:solidFill>
                         </a:rPr>
-                        <a:t>Version</a:t>
+                        <a:t>Config</a:t>
                       </a:r>
                     </a:p>
                   </a:txBody>
@@ -7019,12 +7052,12 @@
                     <a:p>
                       <a:pPr algn="ctr"/>
                       <a:r>
-                        <a:rPr sz="800" b="1">
+                        <a:rPr sz="900" b="1">
                           <a:solidFill>
                             <a:srgbClr val="FFFFFF"/>
                           </a:solidFill>
                         </a:rPr>
-                        <a:t>TTFT P90</a:t>
+                        <a:t>3.3 TTFT P90</a:t>
                       </a:r>
                     </a:p>
                   </a:txBody>
@@ -7041,12 +7074,12 @@
                     <a:p>
                       <a:pPr algn="ctr"/>
                       <a:r>
-                        <a:rPr sz="800" b="1">
+                        <a:rPr sz="900" b="1">
                           <a:solidFill>
                             <a:srgbClr val="FFFFFF"/>
                           </a:solidFill>
                         </a:rPr>
-                        <a:t>Throughput</a:t>
+                        <a:t>3.4 TTFT P90</a:t>
                       </a:r>
                     </a:p>
                   </a:txBody>
@@ -7063,12 +7096,12 @@
                     <a:p>
                       <a:pPr algn="ctr"/>
                       <a:r>
-                        <a:rPr sz="800" b="1">
+                        <a:rPr sz="900" b="1">
                           <a:solidFill>
                             <a:srgbClr val="FFFFFF"/>
                           </a:solidFill>
                         </a:rPr>
-                        <a:t>vs 3.3 TTFT</a:t>
+                        <a:t>3.3 Throughput</a:t>
                       </a:r>
                     </a:p>
                   </a:txBody>
@@ -7078,8 +7111,30 @@
                     </a:solidFill>
                   </a:tcPr>
                 </a:tc>
+                <a:tc>
+                  <a:txBody>
+                    <a:bodyPr wrap="square"/>
+                    <a:lstStyle/>
+                    <a:p>
+                      <a:pPr algn="ctr"/>
+                      <a:r>
+                        <a:rPr sz="900" b="1">
+                          <a:solidFill>
+                            <a:srgbClr val="FFFFFF"/>
+                          </a:solidFill>
+                        </a:rPr>
+                        <a:t>3.4 Throughput</a:t>
+                      </a:r>
+                    </a:p>
+                  </a:txBody>
+                  <a:tcPr anchor="ctr">
+                    <a:solidFill>
+                      <a:srgbClr val="0c4a6e"/>
+                    </a:solidFill>
+                  </a:tcPr>
+                </a:tc>
               </a:tr>
-              <a:tr h="320040">
+              <a:tr h="365760">
                 <a:tc>
                   <a:txBody>
                     <a:bodyPr wrap="square"/>
@@ -7088,7 +7143,7 @@
                       <a:pPr algn="l"/>
                       <a:r>
                         <a:rPr sz="900" b="0"/>
-                        <a:t>RHAIIS 3.3</a:t>
+                        <a:t>2x TP8 (best 3.3)</a:t>
                       </a:r>
                     </a:p>
                   </a:txBody>
@@ -7124,6 +7179,24 @@
                       <a:pPr algn="ctr"/>
                       <a:r>
                         <a:rPr sz="900" b="0"/>
+                        <a:t>1,292 ms (+55.5%)</a:t>
+                      </a:r>
+                    </a:p>
+                  </a:txBody>
+                  <a:tcPr anchor="ctr">
+                    <a:solidFill>
+                      <a:srgbClr val="ffffff"/>
+                    </a:solidFill>
+                  </a:tcPr>
+                </a:tc>
+                <a:tc>
+                  <a:txBody>
+                    <a:bodyPr wrap="square"/>
+                    <a:lstStyle/>
+                    <a:p>
+                      <a:pPr algn="ctr"/>
+                      <a:r>
+                        <a:rPr sz="900" b="0"/>
                         <a:t>26.8 req/s</a:t>
                       </a:r>
                     </a:p>
@@ -7131,62 +7204,6 @@
                   <a:tcPr anchor="ctr">
                     <a:solidFill>
                       <a:srgbClr val="ffffff"/>
-                    </a:solidFill>
-                  </a:tcPr>
-                </a:tc>
-                <a:tc>
-                  <a:txBody>
-                    <a:bodyPr wrap="square"/>
-                    <a:lstStyle/>
-                    <a:p>
-                      <a:pPr algn="ctr"/>
-                      <a:r>
-                        <a:rPr sz="900" b="0"/>
-                        <a:t>Baseline</a:t>
-                      </a:r>
-                    </a:p>
-                  </a:txBody>
-                  <a:tcPr anchor="ctr">
-                    <a:solidFill>
-                      <a:srgbClr val="ffffff"/>
-                    </a:solidFill>
-                  </a:tcPr>
-                </a:tc>
-              </a:tr>
-              <a:tr h="320040">
-                <a:tc>
-                  <a:txBody>
-                    <a:bodyPr wrap="square"/>
-                    <a:lstStyle/>
-                    <a:p>
-                      <a:pPr algn="l"/>
-                      <a:r>
-                        <a:rPr sz="900" b="0"/>
-                        <a:t>RHAIIS 3.4</a:t>
-                      </a:r>
-                    </a:p>
-                  </a:txBody>
-                  <a:tcPr anchor="ctr">
-                    <a:solidFill>
-                      <a:srgbClr val="f8fafc"/>
-                    </a:solidFill>
-                  </a:tcPr>
-                </a:tc>
-                <a:tc>
-                  <a:txBody>
-                    <a:bodyPr wrap="square"/>
-                    <a:lstStyle/>
-                    <a:p>
-                      <a:pPr algn="ctr"/>
-                      <a:r>
-                        <a:rPr sz="900" b="0"/>
-                        <a:t>1,292 ms</a:t>
-                      </a:r>
-                    </a:p>
-                  </a:txBody>
-                  <a:tcPr anchor="ctr">
-                    <a:solidFill>
-                      <a:srgbClr val="f8fafc"/>
                     </a:solidFill>
                   </a:tcPr>
                 </a:tc>
@@ -7204,6 +7221,26 @@
                   </a:txBody>
                   <a:tcPr anchor="ctr">
                     <a:solidFill>
+                      <a:srgbClr val="ffffff"/>
+                    </a:solidFill>
+                  </a:tcPr>
+                </a:tc>
+              </a:tr>
+              <a:tr h="365760">
+                <a:tc>
+                  <a:txBody>
+                    <a:bodyPr wrap="square"/>
+                    <a:lstStyle/>
+                    <a:p>
+                      <a:pPr algn="l"/>
+                      <a:r>
+                        <a:rPr sz="900" b="0"/>
+                        <a:t>2x TP8 (3.4 tuned)</a:t>
+                      </a:r>
+                    </a:p>
+                  </a:txBody>
+                  <a:tcPr anchor="ctr">
+                    <a:solidFill>
                       <a:srgbClr val="f8fafc"/>
                     </a:solidFill>
                   </a:tcPr>
@@ -7216,7 +7253,7 @@
                       <a:pPr algn="ctr"/>
                       <a:r>
                         <a:rPr sz="900" b="0"/>
-                        <a:t>+55.5% (regression)</a:t>
+                        <a:t/>
                       </a:r>
                     </a:p>
                   </a:txBody>
@@ -7226,23 +7263,21 @@
                     </a:solidFill>
                   </a:tcPr>
                 </a:tc>
-              </a:tr>
-              <a:tr h="320040">
-                <a:tc>
-                  <a:txBody>
-                    <a:bodyPr wrap="square"/>
-                    <a:lstStyle/>
-                    <a:p>
-                      <a:pPr algn="l"/>
+                <a:tc>
+                  <a:txBody>
+                    <a:bodyPr wrap="square"/>
+                    <a:lstStyle/>
+                    <a:p>
+                      <a:pPr algn="ctr"/>
                       <a:r>
                         <a:rPr sz="900" b="0"/>
-                        <a:t>3.4 Tuned</a:t>
-                      </a:r>
-                    </a:p>
-                  </a:txBody>
-                  <a:tcPr anchor="ctr">
-                    <a:solidFill>
-                      <a:srgbClr val="ffffff"/>
+                        <a:t>463 ms (-44.3%)</a:t>
+                      </a:r>
+                    </a:p>
+                  </a:txBody>
+                  <a:tcPr anchor="ctr">
+                    <a:solidFill>
+                      <a:srgbClr val="f8fafc"/>
                     </a:solidFill>
                   </a:tcPr>
                 </a:tc>
@@ -7254,13 +7289,13 @@
                       <a:pPr algn="ctr"/>
                       <a:r>
                         <a:rPr sz="900" b="0"/>
-                        <a:t>463 ms</a:t>
-                      </a:r>
-                    </a:p>
-                  </a:txBody>
-                  <a:tcPr anchor="ctr">
-                    <a:solidFill>
-                      <a:srgbClr val="ffffff"/>
+                        <a:t/>
+                      </a:r>
+                    </a:p>
+                  </a:txBody>
+                  <a:tcPr anchor="ctr">
+                    <a:solidFill>
+                      <a:srgbClr val="f8fafc"/>
                     </a:solidFill>
                   </a:tcPr>
                 </a:tc>
@@ -7278,25 +7313,7 @@
                   </a:txBody>
                   <a:tcPr anchor="ctr">
                     <a:solidFill>
-                      <a:srgbClr val="ffffff"/>
-                    </a:solidFill>
-                  </a:tcPr>
-                </a:tc>
-                <a:tc>
-                  <a:txBody>
-                    <a:bodyPr wrap="square"/>
-                    <a:lstStyle/>
-                    <a:p>
-                      <a:pPr algn="ctr"/>
-                      <a:r>
-                        <a:rPr sz="900" b="0"/>
-                        <a:t>-44.3% (recovered)</a:t>
-                      </a:r>
-                    </a:p>
-                  </a:txBody>
-                  <a:tcPr anchor="ctr">
-                    <a:solidFill>
-                      <a:srgbClr val="ffffff"/>
+                      <a:srgbClr val="f8fafc"/>
                     </a:solidFill>
                   </a:tcPr>
                 </a:tc>
@@ -7313,7 +7330,7 @@
         </p:nvSpPr>
         <p:spPr>
           <a:xfrm>
-            <a:off x="457200" y="5029200"/>
+            <a:off x="457200" y="4846320"/>
             <a:ext cx="10972800" cy="914400"/>
           </a:xfrm>
           <a:prstGeom prst="rect">
@@ -7341,7 +7358,7 @@
                   <a:srgbClr val="374151"/>
                 </a:solidFill>
               </a:rPr>
-              <a:t>PD improved 10% TTFT. Aggregated TP8 </a:t>
+              <a:t>PD improved 10% TTFT in 3.4. Aggregated TP8 </a:t>
             </a:r>
             <a:r>
               <a:rPr sz="1000" b="1">
@@ -7365,15 +7382,7 @@
                   <a:srgbClr val="065F46"/>
                 </a:solidFill>
               </a:rPr>
-              <a:t>fully recovered to -44.3% below 3.3 baseline with tuning. </a:t>
-            </a:r>
-            <a:r>
-              <a:rPr sz="1000" b="0">
-                <a:solidFill>
-                  <a:srgbClr val="374151"/>
-                </a:solidFill>
-              </a:rPr>
-              <a:t>Throughput stays ~27 req/s across all versions — the system is concurrency-limited at 100 users.</a:t>
+              <a:t>fully recovered to -44.3% below 3.3 baseline with tuning.</a:t>
             </a:r>
           </a:p>
           <a:p>
@@ -7434,7 +7443,7 @@
                   <a:srgbClr val="0C4A6E"/>
                 </a:solidFill>
               </a:rPr>
-              <a:t>Regression Summary — TTFT P90 (ms)</a:t>
+              <a:t>Regression Summary</a:t>
             </a:r>
           </a:p>
         </p:txBody>
@@ -7449,7 +7458,7 @@
         </p:nvGraphicFramePr>
         <p:xfrm>
           <a:off x="457200" y="822960"/>
-          <a:ext cx="9509760" cy="1828800"/>
+          <a:ext cx="9144000" cy="2011680"/>
         </p:xfrm>
         <a:graphic>
           <a:graphicData uri="http://schemas.openxmlformats.org/drawingml/2006/table">
@@ -7460,20 +7469,20 @@
               <a:tblGrid>
                 <a:gridCol w="2286000"/>
                 <a:gridCol w="1371600"/>
-                <a:gridCol w="1645920"/>
-                <a:gridCol w="1097280"/>
-                <a:gridCol w="2011680"/>
-                <a:gridCol w="1097280"/>
+                <a:gridCol w="1371600"/>
+                <a:gridCol w="1371600"/>
+                <a:gridCol w="1371600"/>
+                <a:gridCol w="1371600"/>
               </a:tblGrid>
-              <a:tr h="365760">
-                <a:tc>
-                  <a:txBody>
-                    <a:bodyPr wrap="square"/>
-                    <a:lstStyle/>
-                    <a:p>
-                      <a:pPr algn="ctr"/>
-                      <a:r>
-                        <a:rPr sz="800" b="1">
+              <a:tr h="402336">
+                <a:tc>
+                  <a:txBody>
+                    <a:bodyPr wrap="square"/>
+                    <a:lstStyle/>
+                    <a:p>
+                      <a:pPr algn="ctr"/>
+                      <a:r>
+                        <a:rPr sz="900" b="1">
                           <a:solidFill>
                             <a:srgbClr val="FFFFFF"/>
                           </a:solidFill>
@@ -7495,7 +7504,7 @@
                     <a:p>
                       <a:pPr algn="ctr"/>
                       <a:r>
-                        <a:rPr sz="800" b="1">
+                        <a:rPr sz="900" b="1">
                           <a:solidFill>
                             <a:srgbClr val="FFFFFF"/>
                           </a:solidFill>
@@ -7517,7 +7526,7 @@
                     <a:p>
                       <a:pPr algn="ctr"/>
                       <a:r>
-                        <a:rPr sz="800" b="1">
+                        <a:rPr sz="900" b="1">
                           <a:solidFill>
                             <a:srgbClr val="FFFFFF"/>
                           </a:solidFill>
@@ -7539,7 +7548,7 @@
                     <a:p>
                       <a:pPr algn="ctr"/>
                       <a:r>
-                        <a:rPr sz="800" b="1">
+                        <a:rPr sz="900" b="1">
                           <a:solidFill>
                             <a:srgbClr val="FFFFFF"/>
                           </a:solidFill>
@@ -7561,7 +7570,7 @@
                     <a:p>
                       <a:pPr algn="ctr"/>
                       <a:r>
-                        <a:rPr sz="800" b="1">
+                        <a:rPr sz="900" b="1">
                           <a:solidFill>
                             <a:srgbClr val="FFFFFF"/>
                           </a:solidFill>
@@ -7583,7 +7592,7 @@
                     <a:p>
                       <a:pPr algn="ctr"/>
                       <a:r>
-                        <a:rPr sz="800" b="1">
+                        <a:rPr sz="900" b="1">
                           <a:solidFill>
                             <a:srgbClr val="FFFFFF"/>
                           </a:solidFill>
@@ -7599,7 +7608,7 @@
                   </a:tcPr>
                 </a:tc>
               </a:tr>
-              <a:tr h="365760">
+              <a:tr h="402336">
                 <a:tc>
                   <a:txBody>
                     <a:bodyPr wrap="square"/>
@@ -7607,7 +7616,11 @@
                     <a:p>
                       <a:pPr algn="l"/>
                       <a:r>
-                        <a:rPr sz="900" b="0"/>
+                        <a:rPr sz="900" b="0">
+                          <a:solidFill>
+                            <a:srgbClr val="374151"/>
+                          </a:solidFill>
+                        </a:rPr>
                         <a:t>Qwen PD (3P+1D TP4)</a:t>
                       </a:r>
                     </a:p>
@@ -7625,7 +7638,11 @@
                     <a:p>
                       <a:pPr algn="ctr"/>
                       <a:r>
-                        <a:rPr sz="900" b="0"/>
+                        <a:rPr sz="900" b="0">
+                          <a:solidFill>
+                            <a:srgbClr val="374151"/>
+                          </a:solidFill>
+                        </a:rPr>
                         <a:t>880 ms</a:t>
                       </a:r>
                     </a:p>
@@ -7643,7 +7660,11 @@
                     <a:p>
                       <a:pPr algn="ctr"/>
                       <a:r>
-                        <a:rPr sz="900" b="0"/>
+                        <a:rPr sz="900" b="0">
+                          <a:solidFill>
+                            <a:srgbClr val="374151"/>
+                          </a:solidFill>
+                        </a:rPr>
                         <a:t>675 ms</a:t>
                       </a:r>
                     </a:p>
@@ -7661,7 +7682,11 @@
                     <a:p>
                       <a:pPr algn="ctr"/>
                       <a:r>
-                        <a:rPr sz="900" b="0"/>
+                        <a:rPr sz="900" b="1">
+                          <a:solidFill>
+                            <a:srgbClr val="065F46"/>
+                          </a:solidFill>
+                        </a:rPr>
                         <a:t>-23%</a:t>
                       </a:r>
                     </a:p>
@@ -7679,7 +7704,11 @@
                     <a:p>
                       <a:pPr algn="ctr"/>
                       <a:r>
-                        <a:rPr sz="900" b="0"/>
+                        <a:rPr sz="900" b="1">
+                          <a:solidFill>
+                            <a:srgbClr val="374151"/>
+                          </a:solidFill>
+                        </a:rPr>
                         <a:t>534 ms</a:t>
                       </a:r>
                     </a:p>
@@ -7697,7 +7726,11 @@
                     <a:p>
                       <a:pPr algn="ctr"/>
                       <a:r>
-                        <a:rPr sz="900" b="0"/>
+                        <a:rPr sz="900" b="1">
+                          <a:solidFill>
+                            <a:srgbClr val="065F46"/>
+                          </a:solidFill>
+                        </a:rPr>
                         <a:t>-39%</a:t>
                       </a:r>
                     </a:p>
@@ -7709,7 +7742,7 @@
                   </a:tcPr>
                 </a:tc>
               </a:tr>
-              <a:tr h="365760">
+              <a:tr h="402336">
                 <a:tc>
                   <a:txBody>
                     <a:bodyPr wrap="square"/>
@@ -7717,8 +7750,12 @@
                     <a:p>
                       <a:pPr algn="l"/>
                       <a:r>
-                        <a:rPr sz="900" b="0"/>
-                        <a:t>Qwen Agg best</a:t>
+                        <a:rPr sz="900" b="0">
+                          <a:solidFill>
+                            <a:srgbClr val="374151"/>
+                          </a:solidFill>
+                        </a:rPr>
+                        <a:t>Qwen Agg (4xTP4)</a:t>
                       </a:r>
                     </a:p>
                   </a:txBody>
@@ -7735,8 +7772,12 @@
                     <a:p>
                       <a:pPr algn="ctr"/>
                       <a:r>
-                        <a:rPr sz="900" b="0"/>
-                        <a:t>1,177 ms (4xTP4)</a:t>
+                        <a:rPr sz="900" b="0">
+                          <a:solidFill>
+                            <a:srgbClr val="374151"/>
+                          </a:solidFill>
+                        </a:rPr>
+                        <a:t>1,177 ms</a:t>
                       </a:r>
                     </a:p>
                   </a:txBody>
@@ -7753,8 +7794,12 @@
                     <a:p>
                       <a:pPr algn="ctr"/>
                       <a:r>
-                        <a:rPr sz="900" b="0"/>
-                        <a:t>995 ms (8xTP2)</a:t>
+                        <a:rPr sz="900" b="0">
+                          <a:solidFill>
+                            <a:srgbClr val="374151"/>
+                          </a:solidFill>
+                        </a:rPr>
+                        <a:t>1,162 ms</a:t>
                       </a:r>
                     </a:p>
                   </a:txBody>
@@ -7771,8 +7816,12 @@
                     <a:p>
                       <a:pPr algn="ctr"/>
                       <a:r>
-                        <a:rPr sz="900" b="0"/>
-                        <a:t>-15%</a:t>
+                        <a:rPr sz="900" b="1">
+                          <a:solidFill>
+                            <a:srgbClr val="065F46"/>
+                          </a:solidFill>
+                        </a:rPr>
+                        <a:t>-1%</a:t>
                       </a:r>
                     </a:p>
                   </a:txBody>
@@ -7789,8 +7838,12 @@
                     <a:p>
                       <a:pPr algn="ctr"/>
                       <a:r>
-                        <a:rPr sz="900" b="0"/>
-                        <a:t>287 ms (2xTP8+EPP)</a:t>
+                        <a:rPr sz="900" b="1">
+                          <a:solidFill>
+                            <a:srgbClr val="374151"/>
+                          </a:solidFill>
+                        </a:rPr>
+                        <a:t>524 ms</a:t>
                       </a:r>
                     </a:p>
                   </a:txBody>
@@ -7807,8 +7860,12 @@
                     <a:p>
                       <a:pPr algn="ctr"/>
                       <a:r>
-                        <a:rPr sz="900" b="0"/>
-                        <a:t>-76%</a:t>
+                        <a:rPr sz="900" b="1">
+                          <a:solidFill>
+                            <a:srgbClr val="065F46"/>
+                          </a:solidFill>
+                        </a:rPr>
+                        <a:t>-56%</a:t>
                       </a:r>
                     </a:p>
                   </a:txBody>
@@ -7819,7 +7876,7 @@
                   </a:tcPr>
                 </a:tc>
               </a:tr>
-              <a:tr h="365760">
+              <a:tr h="402336">
                 <a:tc>
                   <a:txBody>
                     <a:bodyPr wrap="square"/>
@@ -7827,7 +7884,11 @@
                     <a:p>
                       <a:pPr algn="l"/>
                       <a:r>
-                        <a:rPr sz="900" b="0"/>
+                        <a:rPr sz="900" b="0">
+                          <a:solidFill>
+                            <a:srgbClr val="374151"/>
+                          </a:solidFill>
+                        </a:rPr>
                         <a:t>Llama PD (3P+1D TP4)</a:t>
                       </a:r>
                     </a:p>
@@ -7845,7 +7906,11 @@
                     <a:p>
                       <a:pPr algn="ctr"/>
                       <a:r>
-                        <a:rPr sz="900" b="0"/>
+                        <a:rPr sz="900" b="0">
+                          <a:solidFill>
+                            <a:srgbClr val="374151"/>
+                          </a:solidFill>
+                        </a:rPr>
                         <a:t>1,027 ms</a:t>
                       </a:r>
                     </a:p>
@@ -7863,7 +7928,11 @@
                     <a:p>
                       <a:pPr algn="ctr"/>
                       <a:r>
-                        <a:rPr sz="900" b="0"/>
+                        <a:rPr sz="900" b="0">
+                          <a:solidFill>
+                            <a:srgbClr val="374151"/>
+                          </a:solidFill>
+                        </a:rPr>
                         <a:t>925 ms</a:t>
                       </a:r>
                     </a:p>
@@ -7881,7 +7950,11 @@
                     <a:p>
                       <a:pPr algn="ctr"/>
                       <a:r>
-                        <a:rPr sz="900" b="0"/>
+                        <a:rPr sz="900" b="1">
+                          <a:solidFill>
+                            <a:srgbClr val="065F46"/>
+                          </a:solidFill>
+                        </a:rPr>
                         <a:t>-10%</a:t>
                       </a:r>
                     </a:p>
@@ -7899,7 +7972,11 @@
                     <a:p>
                       <a:pPr algn="ctr"/>
                       <a:r>
-                        <a:rPr sz="900" b="0"/>
+                        <a:rPr sz="900" b="1">
+                          <a:solidFill>
+                            <a:srgbClr val="374151"/>
+                          </a:solidFill>
+                        </a:rPr>
                         <a:t>681 ms</a:t>
                       </a:r>
                     </a:p>
@@ -7917,7 +7994,11 @@
                     <a:p>
                       <a:pPr algn="ctr"/>
                       <a:r>
-                        <a:rPr sz="900" b="0"/>
+                        <a:rPr sz="900" b="1">
+                          <a:solidFill>
+                            <a:srgbClr val="065F46"/>
+                          </a:solidFill>
+                        </a:rPr>
                         <a:t>-34%</a:t>
                       </a:r>
                     </a:p>
@@ -7929,7 +8010,7 @@
                   </a:tcPr>
                 </a:tc>
               </a:tr>
-              <a:tr h="365760">
+              <a:tr h="402336">
                 <a:tc>
                   <a:txBody>
                     <a:bodyPr wrap="square"/>
@@ -7937,7 +8018,11 @@
                     <a:p>
                       <a:pPr algn="l"/>
                       <a:r>
-                        <a:rPr sz="900" b="0"/>
+                        <a:rPr sz="900" b="0">
+                          <a:solidFill>
+                            <a:srgbClr val="374151"/>
+                          </a:solidFill>
+                        </a:rPr>
                         <a:t>Llama Agg (2xTP8)</a:t>
                       </a:r>
                     </a:p>
@@ -7955,7 +8040,11 @@
                     <a:p>
                       <a:pPr algn="ctr"/>
                       <a:r>
-                        <a:rPr sz="900" b="0"/>
+                        <a:rPr sz="900" b="0">
+                          <a:solidFill>
+                            <a:srgbClr val="374151"/>
+                          </a:solidFill>
+                        </a:rPr>
                         <a:t>831 ms</a:t>
                       </a:r>
                     </a:p>
@@ -7973,7 +8062,11 @@
                     <a:p>
                       <a:pPr algn="ctr"/>
                       <a:r>
-                        <a:rPr sz="900" b="0"/>
+                        <a:rPr sz="900" b="0">
+                          <a:solidFill>
+                            <a:srgbClr val="374151"/>
+                          </a:solidFill>
+                        </a:rPr>
                         <a:t>1,292 ms</a:t>
                       </a:r>
                     </a:p>
@@ -7991,7 +8084,11 @@
                     <a:p>
                       <a:pPr algn="ctr"/>
                       <a:r>
-                        <a:rPr sz="900" b="0"/>
+                        <a:rPr sz="900" b="1">
+                          <a:solidFill>
+                            <a:srgbClr val="991B1B"/>
+                          </a:solidFill>
+                        </a:rPr>
                         <a:t>+55%</a:t>
                       </a:r>
                     </a:p>
@@ -8009,7 +8106,11 @@
                     <a:p>
                       <a:pPr algn="ctr"/>
                       <a:r>
-                        <a:rPr sz="900" b="0"/>
+                        <a:rPr sz="900" b="1">
+                          <a:solidFill>
+                            <a:srgbClr val="374151"/>
+                          </a:solidFill>
+                        </a:rPr>
                         <a:t>463 ms</a:t>
                       </a:r>
                     </a:p>
@@ -8027,7 +8128,11 @@
                     <a:p>
                       <a:pPr algn="ctr"/>
                       <a:r>
-                        <a:rPr sz="900" b="0"/>
+                        <a:rPr sz="900" b="1">
+                          <a:solidFill>
+                            <a:srgbClr val="065F46"/>
+                          </a:solidFill>
+                        </a:rPr>
                         <a:t>-44%</a:t>
                       </a:r>
                     </a:p>
@@ -8051,7 +8156,7 @@
         </p:nvSpPr>
         <p:spPr>
           <a:xfrm>
-            <a:off x="457200" y="2926080"/>
+            <a:off x="457200" y="3017520"/>
             <a:ext cx="10972800" cy="274320"/>
           </a:xfrm>
           <a:prstGeom prst="rect">
@@ -8084,7 +8189,7 @@
         </p:nvSpPr>
         <p:spPr>
           <a:xfrm>
-            <a:off x="457200" y="3291840"/>
+            <a:off x="457200" y="3383280"/>
             <a:ext cx="10972800" cy="2286000"/>
           </a:xfrm>
           <a:prstGeom prst="rect">
@@ -8104,7 +8209,7 @@
                   <a:srgbClr val="374151"/>
                 </a:solidFill>
               </a:rPr>
-              <a:t>• PD consistently improves TTFT in 3.4</a:t>
+              <a:t>• PD consistently improves in 3.4</a:t>
             </a:r>
             <a:r>
               <a:rPr sz="1100" b="0">
@@ -8112,7 +8217,7 @@
                   <a:srgbClr val="374151"/>
                 </a:solidFill>
               </a:rPr>
-              <a:t> — both models show 10-23% lower TTFT on same config</a:t>
+              <a:t> — both models show 10-23% TTFT improvement on same config</a:t>
             </a:r>
           </a:p>
           <a:p>
@@ -8173,7 +8278,7 @@
                   <a:srgbClr val="374151"/>
                 </a:solidFill>
               </a:rPr>
-              <a:t>• TTFT is where the gains are</a:t>
+              <a:t>• Tuning adds 34-56% on top</a:t>
             </a:r>
             <a:r>
               <a:rPr sz="1100" b="0">
@@ -8181,30 +8286,7 @@
                   <a:srgbClr val="374151"/>
                 </a:solidFill>
               </a:rPr>
-              <a:t> — throughput (req/s) is flat at ~25 req/s because 100 users saturate the system</a:t>
-            </a:r>
-          </a:p>
-          <a:p>
-            <a:pPr>
-              <a:spcBef>
-                <a:spcPts val="400"/>
-              </a:spcBef>
-            </a:pPr>
-            <a:r>
-              <a:rPr sz="1100" b="1">
-                <a:solidFill>
-                  <a:srgbClr val="374151"/>
-                </a:solidFill>
-              </a:rPr>
-              <a:t>• Tuning adds 34-76% TTFT improvement</a:t>
-            </a:r>
-            <a:r>
-              <a:rPr sz="1100" b="0">
-                <a:solidFill>
-                  <a:srgbClr val="374151"/>
-                </a:solidFill>
-              </a:rPr>
-              <a:t> — via gpu_memory_utilization, max_num_seqs, block_size, EPP weights</a:t>
+              <a:t> — auto-profiling gpu_memory_utilization, max_num_seqs, block_size, EPP weights</a:t>
             </a:r>
           </a:p>
           <a:p>
@@ -8326,7 +8408,22 @@
                   <a:srgbClr val="374151"/>
                 </a:solidFill>
               </a:rPr>
-              <a:t>RHAIIS 3.4 enables configurations where prefill pods use more GPUs (higher TP) than decode pods. This allows dedicating more compute to prefill while using fewer GPUs for decode. Disabled for RHAIIS 3.3 due to NIXL KV transfer crashes with asymmetric TP. ServeIt Studio enables it by default for 3.4+.</a:t>
+              <a:t>RHAIIS 3.4 enables testing configurations where prefill pods use more GPUs (higher TP) than decode pods. This allows dedicating more compute to the prefill-heavy first token generation while using fewer GPUs for the lighter decode phase.</a:t>
+            </a:r>
+          </a:p>
+          <a:p>
+            <a:pPr>
+              <a:spcBef>
+                <a:spcPts val="800"/>
+              </a:spcBef>
+            </a:pPr>
+            <a:r>
+              <a:rPr sz="1100" b="0">
+                <a:solidFill>
+                  <a:srgbClr val="374151"/>
+                </a:solidFill>
+              </a:rPr>
+              <a:t>This was disabled for RHAIIS 3.3 (llm-d v0.4.0) due to NIXL KV transfer crashes with asymmetric TP. Inftune Studio now enables asymmetric TP by default for 3.4+ and automatically disables it for 3.3.</a:t>
             </a:r>
           </a:p>
         </p:txBody>
@@ -8339,7 +8436,7 @@
         </p:nvSpPr>
         <p:spPr>
           <a:xfrm>
-            <a:off x="457200" y="2560320"/>
+            <a:off x="457200" y="2743200"/>
             <a:ext cx="10972800" cy="365760"/>
           </a:xfrm>
           <a:prstGeom prst="rect">
@@ -8373,8 +8470,8 @@
           <p:nvPr/>
         </p:nvGraphicFramePr>
         <p:xfrm>
-          <a:off x="457200" y="3017520"/>
-          <a:ext cx="10972800" cy="1463040"/>
+          <a:off x="457200" y="3200400"/>
+          <a:ext cx="10972800" cy="1645920"/>
         </p:xfrm>
         <a:graphic>
           <a:graphicData uri="http://schemas.openxmlformats.org/drawingml/2006/table">
@@ -8387,15 +8484,15 @@
                 <a:gridCol w="3200400"/>
                 <a:gridCol w="6400800"/>
               </a:tblGrid>
-              <a:tr h="365760">
-                <a:tc>
-                  <a:txBody>
-                    <a:bodyPr wrap="square"/>
-                    <a:lstStyle/>
-                    <a:p>
-                      <a:pPr algn="ctr"/>
-                      <a:r>
-                        <a:rPr sz="800" b="1">
+              <a:tr h="411480">
+                <a:tc>
+                  <a:txBody>
+                    <a:bodyPr wrap="square"/>
+                    <a:lstStyle/>
+                    <a:p>
+                      <a:pPr algn="ctr"/>
+                      <a:r>
+                        <a:rPr sz="900" b="1">
                           <a:solidFill>
                             <a:srgbClr val="FFFFFF"/>
                           </a:solidFill>
@@ -8417,7 +8514,7 @@
                     <a:p>
                       <a:pPr algn="ctr"/>
                       <a:r>
-                        <a:rPr sz="800" b="1">
+                        <a:rPr sz="900" b="1">
                           <a:solidFill>
                             <a:srgbClr val="FFFFFF"/>
                           </a:solidFill>
@@ -8439,7 +8536,7 @@
                     <a:p>
                       <a:pPr algn="ctr"/>
                       <a:r>
-                        <a:rPr sz="800" b="1">
+                        <a:rPr sz="900" b="1">
                           <a:solidFill>
                             <a:srgbClr val="FFFFFF"/>
                           </a:solidFill>
@@ -8455,7 +8552,7 @@
                   </a:tcPr>
                 </a:tc>
               </a:tr>
-              <a:tr h="365760">
+              <a:tr h="411480">
                 <a:tc>
                   <a:txBody>
                     <a:bodyPr wrap="square"/>
@@ -8463,7 +8560,11 @@
                     <a:p>
                       <a:pPr algn="l"/>
                       <a:r>
-                        <a:rPr sz="900" b="0"/>
+                        <a:rPr sz="900" b="1">
+                          <a:solidFill>
+                            <a:srgbClr val="0C4A6E"/>
+                          </a:solidFill>
+                        </a:rPr>
                         <a:t>vllm#43396</a:t>
                       </a:r>
                     </a:p>
@@ -8479,9 +8580,9 @@
                     <a:bodyPr wrap="square"/>
                     <a:lstStyle/>
                     <a:p>
-                      <a:pPr algn="ctr"/>
-                      <a:r>
-                        <a:rPr sz="900" b="0"/>
+                      <a:pPr algn="l"/>
+                      <a:r>
+                        <a:rPr sz="800" b="0"/>
                         <a:t>FP8 MoE CUTLASS OOB at batch 8192</a:t>
                       </a:r>
                     </a:p>
@@ -8497,10 +8598,10 @@
                     <a:bodyPr wrap="square"/>
                     <a:lstStyle/>
                     <a:p>
-                      <a:pPr algn="ctr"/>
-                      <a:r>
-                        <a:rPr sz="900" b="0"/>
-                        <a:t>Runtime patch applied in templates. Affects FP8 MoE at high batch sizes.</a:t>
+                      <a:pPr algn="l"/>
+                      <a:r>
+                        <a:rPr sz="800" b="0"/>
+                        <a:t>Runtime patch applied in Inftune Studio templates. Affects FP8 MoE models at high batch sizes.</a:t>
                       </a:r>
                     </a:p>
                   </a:txBody>
@@ -8511,7 +8612,7 @@
                   </a:tcPr>
                 </a:tc>
               </a:tr>
-              <a:tr h="365760">
+              <a:tr h="411480">
                 <a:tc>
                   <a:txBody>
                     <a:bodyPr wrap="square"/>
@@ -8519,7 +8620,11 @@
                     <a:p>
                       <a:pPr algn="l"/>
                       <a:r>
-                        <a:rPr sz="900" b="0"/>
+                        <a:rPr sz="900" b="1">
+                          <a:solidFill>
+                            <a:srgbClr val="0C4A6E"/>
+                          </a:solidFill>
+                        </a:rPr>
                         <a:t>vllm#43398</a:t>
                       </a:r>
                     </a:p>
@@ -8535,9 +8640,9 @@
                     <a:bodyPr wrap="square"/>
                     <a:lstStyle/>
                     <a:p>
-                      <a:pPr algn="ctr"/>
-                      <a:r>
-                        <a:rPr sz="900" b="0"/>
+                      <a:pPr algn="l"/>
+                      <a:r>
+                        <a:rPr sz="800" b="0"/>
                         <a:t>NIXL KV transfer crash with asymmetric TP</a:t>
                       </a:r>
                     </a:p>
@@ -8553,10 +8658,10 @@
                     <a:bodyPr wrap="square"/>
                     <a:lstStyle/>
                     <a:p>
-                      <a:pPr algn="ctr"/>
-                      <a:r>
-                        <a:rPr sz="900" b="0"/>
-                        <a:t>Asymmetric TP disabled for llm-d v0.4.0. Enabled for v0.6.0+.</a:t>
+                      <a:pPr algn="l"/>
+                      <a:r>
+                        <a:rPr sz="800" b="0"/>
+                        <a:t>Asymmetric TP disabled for llm-d v0.4.0. Enabled by default for v0.6.0+.</a:t>
                       </a:r>
                     </a:p>
                   </a:txBody>
@@ -8567,7 +8672,7 @@
                   </a:tcPr>
                 </a:tc>
               </a:tr>
-              <a:tr h="365760">
+              <a:tr h="411480">
                 <a:tc>
                   <a:txBody>
                     <a:bodyPr wrap="square"/>
@@ -8575,7 +8680,11 @@
                     <a:p>
                       <a:pPr algn="l"/>
                       <a:r>
-                        <a:rPr sz="900" b="0"/>
+                        <a:rPr sz="900" b="1">
+                          <a:solidFill>
+                            <a:srgbClr val="0C4A6E"/>
+                          </a:solidFill>
+                        </a:rPr>
                         <a:t>vllm#43523</a:t>
                       </a:r>
                     </a:p>
@@ -8591,9 +8700,9 @@
                     <a:bodyPr wrap="square"/>
                     <a:lstStyle/>
                     <a:p>
-                      <a:pPr algn="ctr"/>
-                      <a:r>
-                        <a:rPr sz="900" b="0"/>
+                      <a:pPr algn="l"/>
+                      <a:r>
+                        <a:rPr sz="800" b="0"/>
                         <a:t>vLLM memory profiling regression</a:t>
                       </a:r>
                     </a:p>
@@ -8609,10 +8718,10 @@
                     <a:bodyPr wrap="square"/>
                     <a:lstStyle/>
                     <a:p>
-                      <a:pPr algn="ctr"/>
-                      <a:r>
-                        <a:rPr sz="900" b="0"/>
-                        <a:t>Workaround: estimate KV cache from GPU VRAM.</a:t>
+                      <a:pPr algn="l"/>
+                      <a:r>
+                        <a:rPr sz="800" b="0"/>
+                        <a:t>Workaround: estimate KV cache from GPU VRAM instead of parsing vLLM logs.</a:t>
                       </a:r>
                     </a:p>
                   </a:txBody>
@@ -8635,8 +8744,8 @@
         </p:nvSpPr>
         <p:spPr>
           <a:xfrm>
-            <a:off x="457200" y="4754880"/>
-            <a:ext cx="10972800" cy="1097280"/>
+            <a:off x="457200" y="5029200"/>
+            <a:ext cx="10972800" cy="914400"/>
           </a:xfrm>
           <a:prstGeom prst="rect">
             <a:avLst/>
@@ -8661,7 +8770,7 @@
           <a:p>
             <a:pPr>
               <a:spcBef>
-                <a:spcPts val="200"/>
+                <a:spcPts val="400"/>
               </a:spcBef>
             </a:pPr>
             <a:r>
@@ -8670,52 +8779,27 @@
                   <a:srgbClr val="374151"/>
                 </a:solidFill>
               </a:rPr>
-              <a:t>• DeepGemm auto-enables on H200s — crashes with compressed-tensors per-channel FP8 and some models at low TP</a:t>
-            </a:r>
-          </a:p>
-          <a:p>
-            <a:pPr>
-              <a:spcBef>
-                <a:spcPts val="200"/>
-              </a:spcBef>
-            </a:pPr>
+              <a:t>• DeepGemm auto-enables on H200s — crashes with compressed-tensors per-channel FP8 (Llama-4-Maverick) and at low TP for some models</a:t>
+            </a:r>
+          </a:p>
+          <a:p>
             <a:r>
               <a:rPr sz="1000" b="0">
                 <a:solidFill>
                   <a:srgbClr val="374151"/>
                 </a:solidFill>
               </a:rPr>
-              <a:t>• Hybrid attention models require NixlConnector HMA support for PD — available in llm-d v0.7.0+ (RHAIIS 3.5)</a:t>
-            </a:r>
-          </a:p>
-          <a:p>
-            <a:pPr>
-              <a:spcBef>
-                <a:spcPts val="200"/>
-              </a:spcBef>
-            </a:pPr>
+              <a:t>• Hybrid attention models (Llama-4-Maverick, Qwen3-Next) require NixlConnector HMA support for PD — available in llm-d v0.7.0+ (RHAIIS 3.5)</a:t>
+            </a:r>
+          </a:p>
+          <a:p>
             <a:r>
               <a:rPr sz="1000" b="0">
                 <a:solidFill>
                   <a:srgbClr val="374151"/>
                 </a:solidFill>
               </a:rPr>
-              <a:t>• MoE models with small shared_expert_intermediate_size limit max TP due to FP8 block quantization</a:t>
-            </a:r>
-          </a:p>
-          <a:p>
-            <a:pPr>
-              <a:spcBef>
-                <a:spcPts val="200"/>
-              </a:spcBef>
-            </a:pPr>
-            <a:r>
-              <a:rPr sz="1000" b="0">
-                <a:solidFill>
-                  <a:srgbClr val="374151"/>
-                </a:solidFill>
-              </a:rPr>
-              <a:t>• Model size now computed from config.json (not model name) — handles multimodal, MoE, compressed-tensors FP8</a:t>
+              <a:t>• MoE models with small shared_expert_intermediate_size limit max TP due to FP8 block quantization (partition_size &gt;= 128)</a:t>
             </a:r>
           </a:p>
         </p:txBody>
@@ -8814,7 +8898,7 @@
                   <a:srgbClr val="374151"/>
                 </a:solidFill>
               </a:rPr>
-              <a:t>RHAIIS 3.4 improves PD latency by 10-23% out of the box. Aggregated depends on TP and model — re-run optimization after upgrading. With auto-tuning, TTFT improves 34-76% beyond version changes.</a:t>
+              <a:t>RHAIIS 3.4 improves PD performance by 10-23% out of the box. Aggregated performance depends on TP and model — re-run optimization after upgrading. With auto-tuning, all configurations exceed the 3.3 baseline by 34-56%.</a:t>
             </a:r>
           </a:p>
           <a:p>
@@ -8844,7 +8928,7 @@
                   <a:srgbClr val="374151"/>
                 </a:solidFill>
               </a:rPr>
-              <a:t>Llama-4-Maverick and Qwen3-Next require llm-d v0.7.0 (RHAIIS 3.5 EA2 / vLLM v0.19.1) for PD disaggregation due to hybrid attention HMA support. Aggregated works on 3.4.</a:t>
+              <a:t>Llama-4-Maverick and Qwen3-Next require llm-d v0.7.0 (RHAIIS 3.5 EA2 / vLLM v0.19.1) for PD disaggregation due to hybrid attention HMA support in NixlConnector. Aggregated mode works on 3.4.</a:t>
             </a:r>
           </a:p>
           <a:p>
@@ -8859,7 +8943,7 @@
                   <a:srgbClr val="0C4A6E"/>
                 </a:solidFill>
               </a:rPr>
-              <a:t>Throughput vs Latency</a:t>
+              <a:t>Large MoE Models</a:t>
             </a:r>
           </a:p>
           <a:p>
@@ -8874,7 +8958,7 @@
                   <a:srgbClr val="374151"/>
                 </a:solidFill>
               </a:rPr>
-              <a:t>At 100 concurrent users, throughput (req/s) is saturated and roughly constant across configs (~25 req/s). The real optimization target is TTFT — how fast users see the first token. Auto-tuning reduces TTFT by 71-76% on the same hardware.</a:t>
+              <a:t>DeepSeek-R1 and Qwen3-235B require Wide-EP across 32+ GPUs. Test on larger clusters or use the llm-d Wide-EP guide as reference.</a:t>
             </a:r>
           </a:p>
           <a:p>
@@ -8904,7 +8988,37 @@
                   <a:srgbClr val="374151"/>
                 </a:solidFill>
               </a:rPr>
-              <a:t>Even without version changes, ServeIt Studio auto-tuning adds 34-76% TTFT improvement through smart gpu_memory_utilization, max_num_seqs, block_size, and EPP weight optimization.</a:t>
+              <a:t>Even without version changes, Inftune Studio auto-tuning adds 34-56% TTFT improvement through smart gpu_memory_utilization, max_num_seqs, block_size, and EPP weight optimization. Recommended for all production deployments.</a:t>
+            </a:r>
+          </a:p>
+          <a:p>
+            <a:pPr>
+              <a:spcBef>
+                <a:spcPts val="1600"/>
+              </a:spcBef>
+            </a:pPr>
+            <a:r>
+              <a:rPr sz="1300" b="1">
+                <a:solidFill>
+                  <a:srgbClr val="0C4A6E"/>
+                </a:solidFill>
+              </a:rPr>
+              <a:t>Inftune Studio Improvements</a:t>
+            </a:r>
+          </a:p>
+          <a:p>
+            <a:pPr>
+              <a:spcBef>
+                <a:spcPts val="400"/>
+              </a:spcBef>
+            </a:pPr>
+            <a:r>
+              <a:rPr sz="1000" b="0">
+                <a:solidFill>
+                  <a:srgbClr val="374151"/>
+                </a:solidFill>
+              </a:rPr>
+              <a:t>Model config detection now reads config.json directly (no name parsing). Handles multimodal nested configs, compressed-tensors FP8 detection, interleaved MoE layers, hybrid attention detection, and DeepGemm compatibility.</a:t>
             </a:r>
           </a:p>
         </p:txBody>

</xml_diff>

<commit_message>
Fill empty cells in Llama aggregated table with dash
Co-Authored-By: Claude Opus 4.6 (1M context) <noreply@anthropic.com>
</commit_message>
<xml_diff>
--- a/docs/rhaiis-3.3-vs-3.4-final.pptx
+++ b/docs/rhaiis-3.3-vs-3.4-final.pptx
@@ -7255,6 +7255,10 @@
                         <a:rPr sz="900" b="0"/>
                         <a:t/>
                       </a:r>
+                      <a:r>
+                        <a:rPr sz="900"/>
+                        <a:t>—</a:t>
+                      </a:r>
                     </a:p>
                   </a:txBody>
                   <a:tcPr anchor="ctr">
@@ -7290,6 +7294,10 @@
                       <a:r>
                         <a:rPr sz="900" b="0"/>
                         <a:t/>
+                      </a:r>
+                      <a:r>
+                        <a:rPr sz="900"/>
+                        <a:t>—</a:t>
                       </a:r>
                     </a:p>
                   </a:txBody>

</xml_diff>

<commit_message>
Fix Llama aggregated table: show all 3 versions with no empty cells
Replaced confusing 2-row table (with empty cells for tuned 3.3 values)
with clear 3-row table showing 3.3, 3.4, and 3.4 Tuned side by side.

Co-Authored-By: Claude Opus 4.6 (1M context) <noreply@anthropic.com>
</commit_message>
<xml_diff>
--- a/docs/rhaiis-3.3-vs-3.4-final.pptx
+++ b/docs/rhaiis-3.3-vs-3.4-final.pptx
@@ -6992,344 +6992,11 @@
                   <a:srgbClr val="374151"/>
                 </a:solidFill>
               </a:rPr>
-              <a:t>Aggregated — Same Config Comparison</a:t>
+              <a:t>Aggregated — Best TTFT per Version (2xTP8)</a:t>
             </a:r>
           </a:p>
         </p:txBody>
       </p:sp>
-      <p:graphicFrame>
-        <p:nvGraphicFramePr>
-          <p:cNvPr id="6" name="Table 5"/>
-          <p:cNvGraphicFramePr>
-            <a:graphicFrameLocks noGrp="1"/>
-          </p:cNvGraphicFramePr>
-          <p:nvPr/>
-        </p:nvGraphicFramePr>
-        <p:xfrm>
-          <a:off x="457200" y="3566160"/>
-          <a:ext cx="9144000" cy="1097280"/>
-        </p:xfrm>
-        <a:graphic>
-          <a:graphicData uri="http://schemas.openxmlformats.org/drawingml/2006/table">
-            <a:tbl>
-              <a:tblPr firstRow="1" bandRow="1">
-                <a:tableStyleId>{5C22544A-7EE6-4342-B048-85BDC9FD1C3A}</a:tableStyleId>
-              </a:tblPr>
-              <a:tblGrid>
-                <a:gridCol w="1828800"/>
-                <a:gridCol w="1828800"/>
-                <a:gridCol w="1828800"/>
-                <a:gridCol w="1828800"/>
-                <a:gridCol w="1828800"/>
-              </a:tblGrid>
-              <a:tr h="365760">
-                <a:tc>
-                  <a:txBody>
-                    <a:bodyPr wrap="square"/>
-                    <a:lstStyle/>
-                    <a:p>
-                      <a:pPr algn="ctr"/>
-                      <a:r>
-                        <a:rPr sz="900" b="1">
-                          <a:solidFill>
-                            <a:srgbClr val="FFFFFF"/>
-                          </a:solidFill>
-                        </a:rPr>
-                        <a:t>Config</a:t>
-                      </a:r>
-                    </a:p>
-                  </a:txBody>
-                  <a:tcPr anchor="ctr">
-                    <a:solidFill>
-                      <a:srgbClr val="0c4a6e"/>
-                    </a:solidFill>
-                  </a:tcPr>
-                </a:tc>
-                <a:tc>
-                  <a:txBody>
-                    <a:bodyPr wrap="square"/>
-                    <a:lstStyle/>
-                    <a:p>
-                      <a:pPr algn="ctr"/>
-                      <a:r>
-                        <a:rPr sz="900" b="1">
-                          <a:solidFill>
-                            <a:srgbClr val="FFFFFF"/>
-                          </a:solidFill>
-                        </a:rPr>
-                        <a:t>3.3 TTFT P90</a:t>
-                      </a:r>
-                    </a:p>
-                  </a:txBody>
-                  <a:tcPr anchor="ctr">
-                    <a:solidFill>
-                      <a:srgbClr val="0c4a6e"/>
-                    </a:solidFill>
-                  </a:tcPr>
-                </a:tc>
-                <a:tc>
-                  <a:txBody>
-                    <a:bodyPr wrap="square"/>
-                    <a:lstStyle/>
-                    <a:p>
-                      <a:pPr algn="ctr"/>
-                      <a:r>
-                        <a:rPr sz="900" b="1">
-                          <a:solidFill>
-                            <a:srgbClr val="FFFFFF"/>
-                          </a:solidFill>
-                        </a:rPr>
-                        <a:t>3.4 TTFT P90</a:t>
-                      </a:r>
-                    </a:p>
-                  </a:txBody>
-                  <a:tcPr anchor="ctr">
-                    <a:solidFill>
-                      <a:srgbClr val="0c4a6e"/>
-                    </a:solidFill>
-                  </a:tcPr>
-                </a:tc>
-                <a:tc>
-                  <a:txBody>
-                    <a:bodyPr wrap="square"/>
-                    <a:lstStyle/>
-                    <a:p>
-                      <a:pPr algn="ctr"/>
-                      <a:r>
-                        <a:rPr sz="900" b="1">
-                          <a:solidFill>
-                            <a:srgbClr val="FFFFFF"/>
-                          </a:solidFill>
-                        </a:rPr>
-                        <a:t>3.3 Throughput</a:t>
-                      </a:r>
-                    </a:p>
-                  </a:txBody>
-                  <a:tcPr anchor="ctr">
-                    <a:solidFill>
-                      <a:srgbClr val="0c4a6e"/>
-                    </a:solidFill>
-                  </a:tcPr>
-                </a:tc>
-                <a:tc>
-                  <a:txBody>
-                    <a:bodyPr wrap="square"/>
-                    <a:lstStyle/>
-                    <a:p>
-                      <a:pPr algn="ctr"/>
-                      <a:r>
-                        <a:rPr sz="900" b="1">
-                          <a:solidFill>
-                            <a:srgbClr val="FFFFFF"/>
-                          </a:solidFill>
-                        </a:rPr>
-                        <a:t>3.4 Throughput</a:t>
-                      </a:r>
-                    </a:p>
-                  </a:txBody>
-                  <a:tcPr anchor="ctr">
-                    <a:solidFill>
-                      <a:srgbClr val="0c4a6e"/>
-                    </a:solidFill>
-                  </a:tcPr>
-                </a:tc>
-              </a:tr>
-              <a:tr h="365760">
-                <a:tc>
-                  <a:txBody>
-                    <a:bodyPr wrap="square"/>
-                    <a:lstStyle/>
-                    <a:p>
-                      <a:pPr algn="l"/>
-                      <a:r>
-                        <a:rPr sz="900" b="0"/>
-                        <a:t>2x TP8 (best 3.3)</a:t>
-                      </a:r>
-                    </a:p>
-                  </a:txBody>
-                  <a:tcPr anchor="ctr">
-                    <a:solidFill>
-                      <a:srgbClr val="ffffff"/>
-                    </a:solidFill>
-                  </a:tcPr>
-                </a:tc>
-                <a:tc>
-                  <a:txBody>
-                    <a:bodyPr wrap="square"/>
-                    <a:lstStyle/>
-                    <a:p>
-                      <a:pPr algn="ctr"/>
-                      <a:r>
-                        <a:rPr sz="900" b="0"/>
-                        <a:t>831 ms</a:t>
-                      </a:r>
-                    </a:p>
-                  </a:txBody>
-                  <a:tcPr anchor="ctr">
-                    <a:solidFill>
-                      <a:srgbClr val="ffffff"/>
-                    </a:solidFill>
-                  </a:tcPr>
-                </a:tc>
-                <a:tc>
-                  <a:txBody>
-                    <a:bodyPr wrap="square"/>
-                    <a:lstStyle/>
-                    <a:p>
-                      <a:pPr algn="ctr"/>
-                      <a:r>
-                        <a:rPr sz="900" b="0"/>
-                        <a:t>1,292 ms (+55.5%)</a:t>
-                      </a:r>
-                    </a:p>
-                  </a:txBody>
-                  <a:tcPr anchor="ctr">
-                    <a:solidFill>
-                      <a:srgbClr val="ffffff"/>
-                    </a:solidFill>
-                  </a:tcPr>
-                </a:tc>
-                <a:tc>
-                  <a:txBody>
-                    <a:bodyPr wrap="square"/>
-                    <a:lstStyle/>
-                    <a:p>
-                      <a:pPr algn="ctr"/>
-                      <a:r>
-                        <a:rPr sz="900" b="0"/>
-                        <a:t>26.8 req/s</a:t>
-                      </a:r>
-                    </a:p>
-                  </a:txBody>
-                  <a:tcPr anchor="ctr">
-                    <a:solidFill>
-                      <a:srgbClr val="ffffff"/>
-                    </a:solidFill>
-                  </a:tcPr>
-                </a:tc>
-                <a:tc>
-                  <a:txBody>
-                    <a:bodyPr wrap="square"/>
-                    <a:lstStyle/>
-                    <a:p>
-                      <a:pPr algn="ctr"/>
-                      <a:r>
-                        <a:rPr sz="900" b="0"/>
-                        <a:t>27.0 req/s</a:t>
-                      </a:r>
-                    </a:p>
-                  </a:txBody>
-                  <a:tcPr anchor="ctr">
-                    <a:solidFill>
-                      <a:srgbClr val="ffffff"/>
-                    </a:solidFill>
-                  </a:tcPr>
-                </a:tc>
-              </a:tr>
-              <a:tr h="365760">
-                <a:tc>
-                  <a:txBody>
-                    <a:bodyPr wrap="square"/>
-                    <a:lstStyle/>
-                    <a:p>
-                      <a:pPr algn="l"/>
-                      <a:r>
-                        <a:rPr sz="900" b="0"/>
-                        <a:t>2x TP8 (3.4 tuned)</a:t>
-                      </a:r>
-                    </a:p>
-                  </a:txBody>
-                  <a:tcPr anchor="ctr">
-                    <a:solidFill>
-                      <a:srgbClr val="f8fafc"/>
-                    </a:solidFill>
-                  </a:tcPr>
-                </a:tc>
-                <a:tc>
-                  <a:txBody>
-                    <a:bodyPr wrap="square"/>
-                    <a:lstStyle/>
-                    <a:p>
-                      <a:pPr algn="ctr"/>
-                      <a:r>
-                        <a:rPr sz="900" b="0"/>
-                        <a:t/>
-                      </a:r>
-                      <a:r>
-                        <a:rPr sz="900"/>
-                        <a:t>—</a:t>
-                      </a:r>
-                    </a:p>
-                  </a:txBody>
-                  <a:tcPr anchor="ctr">
-                    <a:solidFill>
-                      <a:srgbClr val="f8fafc"/>
-                    </a:solidFill>
-                  </a:tcPr>
-                </a:tc>
-                <a:tc>
-                  <a:txBody>
-                    <a:bodyPr wrap="square"/>
-                    <a:lstStyle/>
-                    <a:p>
-                      <a:pPr algn="ctr"/>
-                      <a:r>
-                        <a:rPr sz="900" b="0"/>
-                        <a:t>463 ms (-44.3%)</a:t>
-                      </a:r>
-                    </a:p>
-                  </a:txBody>
-                  <a:tcPr anchor="ctr">
-                    <a:solidFill>
-                      <a:srgbClr val="f8fafc"/>
-                    </a:solidFill>
-                  </a:tcPr>
-                </a:tc>
-                <a:tc>
-                  <a:txBody>
-                    <a:bodyPr wrap="square"/>
-                    <a:lstStyle/>
-                    <a:p>
-                      <a:pPr algn="ctr"/>
-                      <a:r>
-                        <a:rPr sz="900" b="0"/>
-                        <a:t/>
-                      </a:r>
-                      <a:r>
-                        <a:rPr sz="900"/>
-                        <a:t>—</a:t>
-                      </a:r>
-                    </a:p>
-                  </a:txBody>
-                  <a:tcPr anchor="ctr">
-                    <a:solidFill>
-                      <a:srgbClr val="f8fafc"/>
-                    </a:solidFill>
-                  </a:tcPr>
-                </a:tc>
-                <a:tc>
-                  <a:txBody>
-                    <a:bodyPr wrap="square"/>
-                    <a:lstStyle/>
-                    <a:p>
-                      <a:pPr algn="ctr"/>
-                      <a:r>
-                        <a:rPr sz="900" b="0"/>
-                        <a:t>26.9 req/s</a:t>
-                      </a:r>
-                    </a:p>
-                  </a:txBody>
-                  <a:tcPr anchor="ctr">
-                    <a:solidFill>
-                      <a:srgbClr val="f8fafc"/>
-                    </a:solidFill>
-                  </a:tcPr>
-                </a:tc>
-              </a:tr>
-            </a:tbl>
-          </a:graphicData>
-        </a:graphic>
-      </p:graphicFrame>
       <p:sp>
         <p:nvSpPr>
           <p:cNvPr id="7" name="TextBox 6"/>
@@ -7405,6 +7072,423 @@
           </a:p>
         </p:txBody>
       </p:sp>
+      <p:graphicFrame>
+        <p:nvGraphicFramePr>
+          <p:cNvPr id="8" name="Table 7"/>
+          <p:cNvGraphicFramePr>
+            <a:graphicFrameLocks noGrp="1"/>
+          </p:cNvGraphicFramePr>
+          <p:nvPr/>
+        </p:nvGraphicFramePr>
+        <p:xfrm>
+          <a:off x="457200" y="3566160"/>
+          <a:ext cx="9144000" cy="1463040"/>
+        </p:xfrm>
+        <a:graphic>
+          <a:graphicData uri="http://schemas.openxmlformats.org/drawingml/2006/table">
+            <a:tbl>
+              <a:tblPr firstRow="1" bandRow="1">
+                <a:tableStyleId>{5C22544A-7EE6-4342-B048-85BDC9FD1C3A}</a:tableStyleId>
+              </a:tblPr>
+              <a:tblGrid>
+                <a:gridCol w="1371600"/>
+                <a:gridCol w="1371600"/>
+                <a:gridCol w="2286000"/>
+                <a:gridCol w="1828800"/>
+                <a:gridCol w="2286000"/>
+              </a:tblGrid>
+              <a:tr h="365760">
+                <a:tc>
+                  <a:txBody>
+                    <a:bodyPr wrap="square"/>
+                    <a:lstStyle/>
+                    <a:p>
+                      <a:pPr algn="ctr"/>
+                      <a:r>
+                        <a:rPr sz="900" b="1">
+                          <a:solidFill>
+                            <a:srgbClr val="FFFFFF"/>
+                          </a:solidFill>
+                        </a:rPr>
+                        <a:t>Version</a:t>
+                      </a:r>
+                    </a:p>
+                  </a:txBody>
+                  <a:tcPr anchor="ctr">
+                    <a:solidFill>
+                      <a:srgbClr val="0c4a6e"/>
+                    </a:solidFill>
+                  </a:tcPr>
+                </a:tc>
+                <a:tc>
+                  <a:txBody>
+                    <a:bodyPr wrap="square"/>
+                    <a:lstStyle/>
+                    <a:p>
+                      <a:pPr algn="ctr"/>
+                      <a:r>
+                        <a:rPr sz="900" b="1">
+                          <a:solidFill>
+                            <a:srgbClr val="FFFFFF"/>
+                          </a:solidFill>
+                        </a:rPr>
+                        <a:t>Config</a:t>
+                      </a:r>
+                    </a:p>
+                  </a:txBody>
+                  <a:tcPr anchor="ctr">
+                    <a:solidFill>
+                      <a:srgbClr val="0c4a6e"/>
+                    </a:solidFill>
+                  </a:tcPr>
+                </a:tc>
+                <a:tc>
+                  <a:txBody>
+                    <a:bodyPr wrap="square"/>
+                    <a:lstStyle/>
+                    <a:p>
+                      <a:pPr algn="ctr"/>
+                      <a:r>
+                        <a:rPr sz="900" b="1">
+                          <a:solidFill>
+                            <a:srgbClr val="FFFFFF"/>
+                          </a:solidFill>
+                        </a:rPr>
+                        <a:t>TTFT P90</a:t>
+                      </a:r>
+                    </a:p>
+                  </a:txBody>
+                  <a:tcPr anchor="ctr">
+                    <a:solidFill>
+                      <a:srgbClr val="0c4a6e"/>
+                    </a:solidFill>
+                  </a:tcPr>
+                </a:tc>
+                <a:tc>
+                  <a:txBody>
+                    <a:bodyPr wrap="square"/>
+                    <a:lstStyle/>
+                    <a:p>
+                      <a:pPr algn="ctr"/>
+                      <a:r>
+                        <a:rPr sz="900" b="1">
+                          <a:solidFill>
+                            <a:srgbClr val="FFFFFF"/>
+                          </a:solidFill>
+                        </a:rPr>
+                        <a:t>Throughput</a:t>
+                      </a:r>
+                    </a:p>
+                  </a:txBody>
+                  <a:tcPr anchor="ctr">
+                    <a:solidFill>
+                      <a:srgbClr val="0c4a6e"/>
+                    </a:solidFill>
+                  </a:tcPr>
+                </a:tc>
+                <a:tc>
+                  <a:txBody>
+                    <a:bodyPr wrap="square"/>
+                    <a:lstStyle/>
+                    <a:p>
+                      <a:pPr algn="ctr"/>
+                      <a:r>
+                        <a:rPr sz="900" b="1">
+                          <a:solidFill>
+                            <a:srgbClr val="FFFFFF"/>
+                          </a:solidFill>
+                        </a:rPr>
+                        <a:t>vs 3.3 TTFT</a:t>
+                      </a:r>
+                    </a:p>
+                  </a:txBody>
+                  <a:tcPr anchor="ctr">
+                    <a:solidFill>
+                      <a:srgbClr val="0c4a6e"/>
+                    </a:solidFill>
+                  </a:tcPr>
+                </a:tc>
+              </a:tr>
+              <a:tr h="365760">
+                <a:tc>
+                  <a:txBody>
+                    <a:bodyPr wrap="square"/>
+                    <a:lstStyle/>
+                    <a:p>
+                      <a:pPr algn="l"/>
+                      <a:r>
+                        <a:rPr sz="900" b="0"/>
+                        <a:t>RHAIIS 3.3</a:t>
+                      </a:r>
+                    </a:p>
+                  </a:txBody>
+                  <a:tcPr anchor="ctr">
+                    <a:solidFill>
+                      <a:srgbClr val="ffffff"/>
+                    </a:solidFill>
+                  </a:tcPr>
+                </a:tc>
+                <a:tc>
+                  <a:txBody>
+                    <a:bodyPr wrap="square"/>
+                    <a:lstStyle/>
+                    <a:p>
+                      <a:pPr algn="ctr"/>
+                      <a:r>
+                        <a:rPr sz="900" b="0"/>
+                        <a:t>2x TP8</a:t>
+                      </a:r>
+                    </a:p>
+                  </a:txBody>
+                  <a:tcPr anchor="ctr">
+                    <a:solidFill>
+                      <a:srgbClr val="ffffff"/>
+                    </a:solidFill>
+                  </a:tcPr>
+                </a:tc>
+                <a:tc>
+                  <a:txBody>
+                    <a:bodyPr wrap="square"/>
+                    <a:lstStyle/>
+                    <a:p>
+                      <a:pPr algn="ctr"/>
+                      <a:r>
+                        <a:rPr sz="900" b="0"/>
+                        <a:t>831 ms</a:t>
+                      </a:r>
+                    </a:p>
+                  </a:txBody>
+                  <a:tcPr anchor="ctr">
+                    <a:solidFill>
+                      <a:srgbClr val="ffffff"/>
+                    </a:solidFill>
+                  </a:tcPr>
+                </a:tc>
+                <a:tc>
+                  <a:txBody>
+                    <a:bodyPr wrap="square"/>
+                    <a:lstStyle/>
+                    <a:p>
+                      <a:pPr algn="ctr"/>
+                      <a:r>
+                        <a:rPr sz="900" b="0"/>
+                        <a:t>26.8 req/s</a:t>
+                      </a:r>
+                    </a:p>
+                  </a:txBody>
+                  <a:tcPr anchor="ctr">
+                    <a:solidFill>
+                      <a:srgbClr val="ffffff"/>
+                    </a:solidFill>
+                  </a:tcPr>
+                </a:tc>
+                <a:tc>
+                  <a:txBody>
+                    <a:bodyPr wrap="square"/>
+                    <a:lstStyle/>
+                    <a:p>
+                      <a:pPr algn="ctr"/>
+                      <a:r>
+                        <a:rPr sz="900" b="0"/>
+                        <a:t>Baseline</a:t>
+                      </a:r>
+                    </a:p>
+                  </a:txBody>
+                  <a:tcPr anchor="ctr">
+                    <a:solidFill>
+                      <a:srgbClr val="ffffff"/>
+                    </a:solidFill>
+                  </a:tcPr>
+                </a:tc>
+              </a:tr>
+              <a:tr h="365760">
+                <a:tc>
+                  <a:txBody>
+                    <a:bodyPr wrap="square"/>
+                    <a:lstStyle/>
+                    <a:p>
+                      <a:pPr algn="l"/>
+                      <a:r>
+                        <a:rPr sz="900" b="0"/>
+                        <a:t>RHAIIS 3.4</a:t>
+                      </a:r>
+                    </a:p>
+                  </a:txBody>
+                  <a:tcPr anchor="ctr">
+                    <a:solidFill>
+                      <a:srgbClr val="f8fafc"/>
+                    </a:solidFill>
+                  </a:tcPr>
+                </a:tc>
+                <a:tc>
+                  <a:txBody>
+                    <a:bodyPr wrap="square"/>
+                    <a:lstStyle/>
+                    <a:p>
+                      <a:pPr algn="ctr"/>
+                      <a:r>
+                        <a:rPr sz="900" b="0"/>
+                        <a:t>2x TP8</a:t>
+                      </a:r>
+                    </a:p>
+                  </a:txBody>
+                  <a:tcPr anchor="ctr">
+                    <a:solidFill>
+                      <a:srgbClr val="f8fafc"/>
+                    </a:solidFill>
+                  </a:tcPr>
+                </a:tc>
+                <a:tc>
+                  <a:txBody>
+                    <a:bodyPr wrap="square"/>
+                    <a:lstStyle/>
+                    <a:p>
+                      <a:pPr algn="ctr"/>
+                      <a:r>
+                        <a:rPr sz="900" b="0"/>
+                        <a:t>1,292 ms</a:t>
+                      </a:r>
+                    </a:p>
+                  </a:txBody>
+                  <a:tcPr anchor="ctr">
+                    <a:solidFill>
+                      <a:srgbClr val="f8fafc"/>
+                    </a:solidFill>
+                  </a:tcPr>
+                </a:tc>
+                <a:tc>
+                  <a:txBody>
+                    <a:bodyPr wrap="square"/>
+                    <a:lstStyle/>
+                    <a:p>
+                      <a:pPr algn="ctr"/>
+                      <a:r>
+                        <a:rPr sz="900" b="0"/>
+                        <a:t>27.0 req/s</a:t>
+                      </a:r>
+                    </a:p>
+                  </a:txBody>
+                  <a:tcPr anchor="ctr">
+                    <a:solidFill>
+                      <a:srgbClr val="f8fafc"/>
+                    </a:solidFill>
+                  </a:tcPr>
+                </a:tc>
+                <a:tc>
+                  <a:txBody>
+                    <a:bodyPr wrap="square"/>
+                    <a:lstStyle/>
+                    <a:p>
+                      <a:pPr algn="ctr"/>
+                      <a:r>
+                        <a:rPr sz="900" b="0"/>
+                        <a:t>+55.5% (regression)</a:t>
+                      </a:r>
+                    </a:p>
+                  </a:txBody>
+                  <a:tcPr anchor="ctr">
+                    <a:solidFill>
+                      <a:srgbClr val="f8fafc"/>
+                    </a:solidFill>
+                  </a:tcPr>
+                </a:tc>
+              </a:tr>
+              <a:tr h="365760">
+                <a:tc>
+                  <a:txBody>
+                    <a:bodyPr wrap="square"/>
+                    <a:lstStyle/>
+                    <a:p>
+                      <a:pPr algn="l"/>
+                      <a:r>
+                        <a:rPr sz="900" b="0"/>
+                        <a:t>3.4 Tuned</a:t>
+                      </a:r>
+                    </a:p>
+                  </a:txBody>
+                  <a:tcPr anchor="ctr">
+                    <a:solidFill>
+                      <a:srgbClr val="ffffff"/>
+                    </a:solidFill>
+                  </a:tcPr>
+                </a:tc>
+                <a:tc>
+                  <a:txBody>
+                    <a:bodyPr wrap="square"/>
+                    <a:lstStyle/>
+                    <a:p>
+                      <a:pPr algn="ctr"/>
+                      <a:r>
+                        <a:rPr sz="900" b="0"/>
+                        <a:t>2x TP8</a:t>
+                      </a:r>
+                    </a:p>
+                  </a:txBody>
+                  <a:tcPr anchor="ctr">
+                    <a:solidFill>
+                      <a:srgbClr val="ffffff"/>
+                    </a:solidFill>
+                  </a:tcPr>
+                </a:tc>
+                <a:tc>
+                  <a:txBody>
+                    <a:bodyPr wrap="square"/>
+                    <a:lstStyle/>
+                    <a:p>
+                      <a:pPr algn="ctr"/>
+                      <a:r>
+                        <a:rPr sz="900" b="0"/>
+                        <a:t>463 ms</a:t>
+                      </a:r>
+                    </a:p>
+                  </a:txBody>
+                  <a:tcPr anchor="ctr">
+                    <a:solidFill>
+                      <a:srgbClr val="ffffff"/>
+                    </a:solidFill>
+                  </a:tcPr>
+                </a:tc>
+                <a:tc>
+                  <a:txBody>
+                    <a:bodyPr wrap="square"/>
+                    <a:lstStyle/>
+                    <a:p>
+                      <a:pPr algn="ctr"/>
+                      <a:r>
+                        <a:rPr sz="900" b="0"/>
+                        <a:t>26.9 req/s</a:t>
+                      </a:r>
+                    </a:p>
+                  </a:txBody>
+                  <a:tcPr anchor="ctr">
+                    <a:solidFill>
+                      <a:srgbClr val="ffffff"/>
+                    </a:solidFill>
+                  </a:tcPr>
+                </a:tc>
+                <a:tc>
+                  <a:txBody>
+                    <a:bodyPr wrap="square"/>
+                    <a:lstStyle/>
+                    <a:p>
+                      <a:pPr algn="ctr"/>
+                      <a:r>
+                        <a:rPr sz="900" b="0"/>
+                        <a:t>-44.3% (recovered)</a:t>
+                      </a:r>
+                    </a:p>
+                  </a:txBody>
+                  <a:tcPr anchor="ctr">
+                    <a:solidFill>
+                      <a:srgbClr val="ffffff"/>
+                    </a:solidFill>
+                  </a:tcPr>
+                </a:tc>
+              </a:tr>
+            </a:tbl>
+          </a:graphicData>
+        </a:graphic>
+      </p:graphicFrame>
     </p:spTree>
   </p:cSld>
   <p:clrMapOvr>

</xml_diff>

<commit_message>
Fix remaining wrong throughput: 17.5 -> 24.6 req/s in Qwen agg table
Also fixed Inftune -> ServeIt in issue table.

Co-Authored-By: Claude Opus 4.6 (1M context) <noreply@anthropic.com>
</commit_message>
<xml_diff>
--- a/docs/rhaiis-3.3-vs-3.4-final.pptx
+++ b/docs/rhaiis-3.3-vs-3.4-final.pptx
@@ -3228,7 +3228,7 @@
                   <a:srgbClr val="64748B"/>
                 </a:solidFill>
               </a:rPr>
-              <a:t>Inftune Studio — automated 11-step optimization pipeline</a:t>
+              <a:t>ServeIt Studio — automated 11-step optimization pipeline</a:t>
             </a:r>
           </a:p>
         </p:txBody>
@@ -6146,7 +6146,7 @@
                       <a:pPr algn="ctr"/>
                       <a:r>
                         <a:rPr sz="900" b="0"/>
-                        <a:t>17.5 req/s (+183%)</a:t>
+                        <a:t>24.6 req/s</a:t>
                       </a:r>
                     </a:p>
                   </a:txBody>
@@ -8515,7 +8515,7 @@
                   <a:srgbClr val="374151"/>
                 </a:solidFill>
               </a:rPr>
-              <a:t>This was disabled for RHAIIS 3.3 (llm-d v0.4.0) due to NIXL KV transfer crashes with asymmetric TP. Inftune Studio now enables asymmetric TP by default for 3.4+ and automatically disables it for 3.3.</a:t>
+              <a:t>This was disabled for RHAIIS 3.3 (llm-d v0.4.0) due to NIXL KV transfer crashes with asymmetric TP. ServeIt Studio now enables asymmetric TP by default for 3.4+ and automatically disables it for 3.3.</a:t>
             </a:r>
           </a:p>
         </p:txBody>
@@ -8693,7 +8693,7 @@
                       <a:pPr algn="l"/>
                       <a:r>
                         <a:rPr sz="800" b="0"/>
-                        <a:t>Runtime patch applied in Inftune Studio templates. Affects FP8 MoE models at high batch sizes.</a:t>
+                        <a:t>Runtime patch applied in ServeIt Studio templates. Affects FP8 MoE models at high batch sizes.</a:t>
                       </a:r>
                     </a:p>
                   </a:txBody>
@@ -9080,7 +9080,7 @@
                   <a:srgbClr val="374151"/>
                 </a:solidFill>
               </a:rPr>
-              <a:t>Even without version changes, Inftune Studio auto-tuning adds 34-56% TTFT improvement through smart gpu_memory_utilization, max_num_seqs, block_size, and EPP weight optimization. Recommended for all production deployments.</a:t>
+              <a:t>Even without version changes, ServeIt Studio auto-tuning adds 34-56% TTFT improvement through smart gpu_memory_utilization, max_num_seqs, block_size, and EPP weight optimization. Recommended for all production deployments.</a:t>
             </a:r>
           </a:p>
           <a:p>
@@ -9095,7 +9095,7 @@
                   <a:srgbClr val="0C4A6E"/>
                 </a:solidFill>
               </a:rPr>
-              <a:t>Inftune Studio Improvements</a:t>
+              <a:t>ServeIt Studio Improvements</a:t>
             </a:r>
           </a:p>
           <a:p>

</xml_diff>